<commit_message>
Slide 9: clickable dashboard screenshot and links; dashboard tab deep links; report screenshot
Co-Authored-By: Claude Opus 5.5 <noreply@anthropic.com>
</commit_message>
<xml_diff>
--- a/presentation/Group3_Forecasting_Presentation.pptx
+++ b/presentation/Group3_Forecasting_Presentation.pptx
@@ -116,26 +116,26 @@
   <p:extLst>
     <p:ext uri="{521415D9-36F7-43E2-AB2F-B90AF26B5E84}">
       <p14:sectionLst xmlns:p14="http://schemas.microsoft.com/office/powerpoint/2010/main">
-        <p14:section name="Question and data" id="{3f72360b-34b3-549c-5a20-8fa84b986065}">
+        <p14:section name="Question and data" id="{2f2cac23-a4e3-d42b-c521-0d0d88bb7117}">
           <p14:sldIdLst>
             <p14:sldId id="256"/>
             <p14:sldId id="257"/>
           </p14:sldIdLst>
         </p14:section>
-        <p14:section name="Models and results" id="{83a3de2b-c7be-7b54-456e-48408f377e87}">
+        <p14:section name="Models and results" id="{a075919e-a987-7e8b-71a4-27e33fc37feb}">
           <p14:sldIdLst>
             <p14:sldId id="258"/>
             <p14:sldId id="259"/>
             <p14:sldId id="260"/>
           </p14:sldIdLst>
         </p14:section>
-        <p14:section name="LLM experiment" id="{2a34bf99-786b-fdf0-0c8e-429bd7c02b83}">
+        <p14:section name="LLM experiment" id="{ccd52858-6f1c-88c8-e639-1e2f41f37f1b}">
           <p14:sldIdLst>
             <p14:sldId id="261"/>
             <p14:sldId id="262"/>
           </p14:sldIdLst>
         </p14:section>
-        <p14:section name="Business insight and demo" id="{cf3f234c-d2c8-ad96-f1bf-0efd334da302}">
+        <p14:section name="Business insight and demo" id="{91ff76a0-f4c9-c5ed-ce11-a48063cad76d}">
           <p14:sldIdLst>
             <p14:sldId id="263"/>
             <p14:sldId id="264"/>
@@ -7201,7 +7201,7 @@
 This is Shelf Signal version 2, which extends our teammate's original dashboard with all of this project's models. First, in the Forecast explorer, I pick a series, say a store's dairy department, and replay each model's forecast against what actually sold.
 Second, in the Order planner, I keep the forecast fixed and change the profit margin. Watch the recommended order: at a low margin it sits near the 20th percentile of demand, and as the margin rises it moves toward the 80th. The table below scores every model's orders against actual sales. Same forecast, different decision.
 Third, note that actual sales are only used to evaluate the forecast afterwards; the forecasts never see the test days.
-BEFORE PRESENTING: open docs/index.html from the project folder (it needs internet for the chart library) and have the screen recording ready as a backup.
+HOW TO DEMO: in Slide Show mode, click the screenshot (or 'Open live dashboard'). The browser opens on the Order planner. Do the demo, then press Cmd+Tab to return to PowerPoint. Before presenting: open the link once and sign in, so it loads instantly; keep the screen recording ready as a backup.
 TRANSITION: To wrap up.</a:t>
             </a:r>
             <a:endParaRPr lang="en-US" dirty="0"/>
@@ -15314,41 +15314,65 @@
       </p:sp>
       <p:sp>
         <p:nvSpPr>
-          <p:cNvPr id="3" name="screenshot placeholder"/>
+          <p:cNvPr id="3" name="screenshot frame"/>
           <p:cNvSpPr/>
           <p:nvPr/>
         </p:nvSpPr>
         <p:spPr>
           <a:xfrm>
             <a:off x="548640" y="1371600"/>
-            <a:ext cx="6766560" cy="4343400"/>
+            <a:ext cx="6583680" cy="4370832"/>
           </a:xfrm>
-          <a:prstGeom prst="roundRect">
-            <a:avLst>
-              <a:gd name="adj" fmla="val 2105"/>
-            </a:avLst>
+          <a:prstGeom prst="rect">
+            <a:avLst/>
           </a:prstGeom>
           <a:solidFill>
-            <a:schemeClr val="bg2"/>
+            <a:srgbClr val="FFFFFF"/>
           </a:solidFill>
-          <a:ln w="15875">
+          <a:ln w="12700">
             <a:solidFill>
-              <a:srgbClr val="9A9993"/>
+              <a:srgbClr val="D9DCE1"/>
             </a:solidFill>
-            <a:prstDash val="dash"/>
+            <a:prstDash val="solid"/>
           </a:ln>
         </p:spPr>
       </p:sp>
-      <p:sp>
-        <p:nvSpPr>
-          <p:cNvPr id="4" name="Text 2"/>
+      <p:pic>
+        <p:nvPicPr>
+          <p:cNvPr id="4" name="dashboard screenshot" descr="Shelf Signal order planner: demand distribution, order quantity and profit by model">
+            <a:hlinkClick r:id="rId2" tooltip="Open the live dashboard"/>
+          </p:cNvPr>
+          <p:cNvPicPr>
+            <a:picLocks noChangeAspect="1"/>
+          </p:cNvPicPr>
+          <p:nvPr/>
+        </p:nvPicPr>
+        <p:blipFill>
+          <a:blip r:embed="rId1"/>
+          <a:stretch>
+            <a:fillRect/>
+          </a:stretch>
+        </p:blipFill>
+        <p:spPr>
+          <a:xfrm>
+            <a:off x="566928" y="1389888"/>
+            <a:ext cx="6547104" cy="4334256"/>
+          </a:xfrm>
+          <a:prstGeom prst="rect">
+            <a:avLst/>
+          </a:prstGeom>
+        </p:spPr>
+      </p:pic>
+      <p:sp>
+        <p:nvSpPr>
+          <p:cNvPr id="5" name="Text 2"/>
           <p:cNvSpPr txBox="1"/>
           <p:nvPr/>
         </p:nvSpPr>
         <p:spPr>
           <a:xfrm>
-            <a:off x="548640" y="1371600"/>
-            <a:ext cx="6766560" cy="4343400"/>
+            <a:off x="548640" y="5806440"/>
+            <a:ext cx="6583680" cy="365760"/>
           </a:xfrm>
           <a:prstGeom prst="rect">
             <a:avLst/>
@@ -15360,58 +15384,60 @@
           <a:bodyPr wrap="square" lIns="0" tIns="0" rIns="0" bIns="0" rtlCol="0" anchor="ctr"/>
           <a:lstStyle/>
           <a:p>
-            <a:pPr algn="ctr" indent="0" marL="0">
+            <a:pPr indent="0" marL="0">
               <a:buNone/>
             </a:pPr>
             <a:r>
-              <a:rPr lang="en-US" sz="1800" dirty="0">
+              <a:rPr lang="en-US" sz="1300" b="1" u="sng" dirty="0">
+                <a:solidFill>
+                  <a:srgbClr val="2A78D6"/>
+                </a:solidFill>
+                <a:hlinkClick r:id="rId3" invalidUrl="" action="" tgtFrame="" tooltip="Opens in your browser" history="1" highlightClick="0" endSnd="0">
+                  <a:extLst>
+                    <a:ext uri="{A12FA001-AC4F-418D-AE19-62706E023703}">
+                      <ahyp:hlinkClr xmlns:ahyp="http://schemas.microsoft.com/office/drawing/2018/hyperlinkcolor" val="tx"/>
+                    </a:ext>
+                  </a:extLst>
+                </a:hlinkClick>
+              </a:rPr>
+              <a:t>Open live dashboard ↗</a:t>
+            </a:r>
+            <a:pPr indent="0" marL="0">
+              <a:buNone/>
+            </a:pPr>
+            <a:r>
+              <a:rPr lang="en-US" sz="1300" dirty="0">
                 <a:solidFill>
                   <a:srgbClr val="6B6A66"/>
                 </a:solidFill>
               </a:rPr>
-              <a:t>Live demo or screen recording</a:t>
+              <a:t>   ·   </a:t>
             </a:r>
-            <a:endParaRPr lang="en-US" sz="1800" dirty="0"/>
-          </a:p>
-          <a:p>
-            <a:pPr algn="ctr" indent="0" marL="0">
-              <a:buNone/>
-            </a:pPr>
-            <a:endParaRPr lang="en-US" sz="1800" dirty="0"/>
-          </a:p>
-          <a:p>
-            <a:pPr algn="ctr" indent="0" marL="0">
+            <a:pPr indent="0" marL="0">
               <a:buNone/>
             </a:pPr>
             <a:r>
-              <a:rPr lang="en-US" sz="1800" dirty="0">
+              <a:rPr lang="en-US" sz="1300" u="sng" dirty="0">
                 <a:solidFill>
-                  <a:srgbClr val="6B6A66"/>
+                  <a:srgbClr val="2A78D6"/>
                 </a:solidFill>
+                <a:hlinkClick r:id="rId4" invalidUrl="" action="" tgtFrame="" tooltip="Opens the local copy" history="1" highlightClick="0" endSnd="0">
+                  <a:extLst>
+                    <a:ext uri="{A12FA001-AC4F-418D-AE19-62706E023703}">
+                      <ahyp:hlinkClr xmlns:ahyp="http://schemas.microsoft.com/office/drawing/2018/hyperlinkcolor" val="tx"/>
+                    </a:ext>
+                  </a:extLst>
+                </a:hlinkClick>
               </a:rPr>
-              <a:t>docs/index.html in our repository</a:t>
+              <a:t>Offline copy (docs/index.html)</a:t>
             </a:r>
-            <a:endParaRPr lang="en-US" sz="1800" dirty="0"/>
-          </a:p>
-          <a:p>
-            <a:pPr algn="ctr" indent="0" marL="0">
-              <a:buNone/>
-            </a:pPr>
-            <a:r>
-              <a:rPr lang="en-US" sz="1800" dirty="0">
-                <a:solidFill>
-                  <a:srgbClr val="6B6A66"/>
-                </a:solidFill>
-              </a:rPr>
-              <a:t>(extends our teammate's Shelf Signal)</a:t>
-            </a:r>
-            <a:endParaRPr lang="en-US" sz="1800" dirty="0"/>
+            <a:endParaRPr lang="en-US" sz="1300" dirty="0"/>
           </a:p>
         </p:txBody>
       </p:sp>
       <p:sp>
         <p:nvSpPr>
-          <p:cNvPr id="5" name="Forecast explorer: pick a series and models circle"/>
+          <p:cNvPr id="6" name="Forecast explorer: pick a series and models circle"/>
           <p:cNvSpPr/>
           <p:nvPr/>
         </p:nvSpPr>
@@ -15436,14 +15462,14 @@
       </p:sp>
       <p:pic>
         <p:nvPicPr>
-          <p:cNvPr id="6" name="Forecast explorer: pick a series and models icon" descr="preencoded.png">    </p:cNvPr>
+          <p:cNvPr id="7" name="Forecast explorer: pick a series and models icon" descr="preencoded.png">    </p:cNvPr>
           <p:cNvPicPr>
             <a:picLocks noChangeAspect="1"/>
           </p:cNvPicPr>
           <p:nvPr/>
         </p:nvPicPr>
         <p:blipFill>
-          <a:blip r:embed="rId1"/>
+          <a:blip r:embed="rId5"/>
           <a:stretch>
             <a:fillRect/>
           </a:stretch>
@@ -15460,7 +15486,7 @@
       </p:pic>
       <p:sp>
         <p:nvSpPr>
-          <p:cNvPr id="7" name="Text 4"/>
+          <p:cNvPr id="8" name="Text 4"/>
           <p:cNvSpPr txBox="1"/>
           <p:nvPr/>
         </p:nvSpPr>
@@ -15496,7 +15522,7 @@
       </p:sp>
       <p:sp>
         <p:nvSpPr>
-          <p:cNvPr id="8" name="Text 5"/>
+          <p:cNvPr id="9" name="Text 5"/>
           <p:cNvSpPr txBox="1"/>
           <p:nvPr/>
         </p:nvSpPr>
@@ -15532,7 +15558,7 @@
       </p:sp>
       <p:sp>
         <p:nvSpPr>
-          <p:cNvPr id="9" name="Order planner: change the margin circle"/>
+          <p:cNvPr id="10" name="Order planner: change the margin circle"/>
           <p:cNvSpPr/>
           <p:nvPr/>
         </p:nvSpPr>
@@ -15557,14 +15583,14 @@
       </p:sp>
       <p:pic>
         <p:nvPicPr>
-          <p:cNvPr id="10" name="Order planner: change the margin icon" descr="preencoded.png">    </p:cNvPr>
+          <p:cNvPr id="11" name="Order planner: change the margin icon" descr="preencoded.png">    </p:cNvPr>
           <p:cNvPicPr>
             <a:picLocks noChangeAspect="1"/>
           </p:cNvPicPr>
           <p:nvPr/>
         </p:nvPicPr>
         <p:blipFill>
-          <a:blip r:embed="rId2"/>
+          <a:blip r:embed="rId6"/>
           <a:stretch>
             <a:fillRect/>
           </a:stretch>
@@ -15581,7 +15607,7 @@
       </p:pic>
       <p:sp>
         <p:nvSpPr>
-          <p:cNvPr id="11" name="Text 7"/>
+          <p:cNvPr id="12" name="Text 7"/>
           <p:cNvSpPr txBox="1"/>
           <p:nvPr/>
         </p:nvSpPr>
@@ -15617,7 +15643,7 @@
       </p:sp>
       <p:sp>
         <p:nvSpPr>
-          <p:cNvPr id="12" name="Text 8"/>
+          <p:cNvPr id="13" name="Text 8"/>
           <p:cNvSpPr txBox="1"/>
           <p:nvPr/>
         </p:nvSpPr>
@@ -15653,7 +15679,7 @@
       </p:sp>
       <p:sp>
         <p:nvSpPr>
-          <p:cNvPr id="13" name="Profit scored with actual sales circle"/>
+          <p:cNvPr id="14" name="Profit scored with actual sales circle"/>
           <p:cNvSpPr/>
           <p:nvPr/>
         </p:nvSpPr>
@@ -15678,14 +15704,14 @@
       </p:sp>
       <p:pic>
         <p:nvPicPr>
-          <p:cNvPr id="14" name="Profit scored with actual sales icon" descr="preencoded.png">    </p:cNvPr>
+          <p:cNvPr id="15" name="Profit scored with actual sales icon" descr="preencoded.png">    </p:cNvPr>
           <p:cNvPicPr>
             <a:picLocks noChangeAspect="1"/>
           </p:cNvPicPr>
           <p:nvPr/>
         </p:nvPicPr>
         <p:blipFill>
-          <a:blip r:embed="rId3"/>
+          <a:blip r:embed="rId7"/>
           <a:stretch>
             <a:fillRect/>
           </a:stretch>
@@ -15702,7 +15728,7 @@
       </p:pic>
       <p:sp>
         <p:nvSpPr>
-          <p:cNvPr id="15" name="Text 10"/>
+          <p:cNvPr id="16" name="Text 10"/>
           <p:cNvSpPr txBox="1"/>
           <p:nvPr/>
         </p:nvSpPr>
@@ -15738,7 +15764,7 @@
       </p:sp>
       <p:sp>
         <p:nvSpPr>
-          <p:cNvPr id="16" name="Text 11"/>
+          <p:cNvPr id="17" name="Text 11"/>
           <p:cNvSpPr txBox="1"/>
           <p:nvPr/>
         </p:nvSpPr>
@@ -15774,7 +15800,7 @@
       </p:sp>
       <p:sp>
         <p:nvSpPr>
-          <p:cNvPr id="17" name="Text 12"/>
+          <p:cNvPr id="18" name="Text 12"/>
           <p:cNvSpPr txBox="1"/>
           <p:nvPr/>
         </p:nvSpPr>
@@ -15802,7 +15828,7 @@
                   <a:srgbClr val="6B6A66"/>
                 </a:solidFill>
               </a:rPr>
-              <a:t>Version 2 shows our models: AutoETS, AutoARIMA, LightGBM, Chronos, the ensemble and Claude. Backup: screen recording.</a:t>
+              <a:t>Click the screenshot or the link to switch to the browser; Cmd+Tab back to the slides. Backup: screen recording.</a:t>
             </a:r>
             <a:endParaRPr lang="en-US" sz="1200" dirty="0"/>
           </a:p>

</xml_diff>

<commit_message>
Link the deck, report and README to the GitHub Pages dashboard
Co-Authored-By: Claude Opus 5.5 <noreply@anthropic.com>
</commit_message>
<xml_diff>
--- a/presentation/Group3_Forecasting_Presentation.pptx
+++ b/presentation/Group3_Forecasting_Presentation.pptx
@@ -116,26 +116,26 @@
   <p:extLst>
     <p:ext uri="{521415D9-36F7-43E2-AB2F-B90AF26B5E84}">
       <p14:sectionLst xmlns:p14="http://schemas.microsoft.com/office/powerpoint/2010/main">
-        <p14:section name="Question and data" id="{2f2cac23-a4e3-d42b-c521-0d0d88bb7117}">
+        <p14:section name="Question and data" id="{f5e58a20-3858-7f6a-3eb9-0079a918180a}">
           <p14:sldIdLst>
             <p14:sldId id="256"/>
             <p14:sldId id="257"/>
           </p14:sldIdLst>
         </p14:section>
-        <p14:section name="Models and results" id="{a075919e-a987-7e8b-71a4-27e33fc37feb}">
+        <p14:section name="Models and results" id="{f69ecb56-febb-972e-f5eb-37b7bd7241a1}">
           <p14:sldIdLst>
             <p14:sldId id="258"/>
             <p14:sldId id="259"/>
             <p14:sldId id="260"/>
           </p14:sldIdLst>
         </p14:section>
-        <p14:section name="LLM experiment" id="{ccd52858-6f1c-88c8-e639-1e2f41f37f1b}">
+        <p14:section name="LLM experiment" id="{f52c5b96-bc2d-44c7-103b-9ff1fcc4db0e}">
           <p14:sldIdLst>
             <p14:sldId id="261"/>
             <p14:sldId id="262"/>
           </p14:sldIdLst>
         </p14:section>
-        <p14:section name="Business insight and demo" id="{91ff76a0-f4c9-c5ed-ce11-a48063cad76d}">
+        <p14:section name="Business insight and demo" id="{72283f01-455a-78a1-cd8a-4d25a0f2625c}">
           <p14:sldIdLst>
             <p14:sldId id="263"/>
             <p14:sldId id="264"/>
@@ -7201,7 +7201,7 @@
 This is Shelf Signal version 2, which extends our teammate's original dashboard with all of this project's models. First, in the Forecast explorer, I pick a series, say a store's dairy department, and replay each model's forecast against what actually sold.
 Second, in the Order planner, I keep the forecast fixed and change the profit margin. Watch the recommended order: at a low margin it sits near the 20th percentile of demand, and as the margin rises it moves toward the 80th. The table below scores every model's orders against actual sales. Same forecast, different decision.
 Third, note that actual sales are only used to evaluate the forecast afterwards; the forecasts never see the test days.
-HOW TO DEMO: in Slide Show mode, click the screenshot (or 'Open live dashboard'). The browser opens on the Order planner. Do the demo, then press Cmd+Tab to return to PowerPoint. Before presenting: open the link once and sign in, so it loads instantly; keep the screen recording ready as a backup.
+HOW TO DEMO: in Slide Show mode, click the screenshot (or 'Open live dashboard'). The browser opens on the Order planner. Do the demo, then press Cmd+Tab to return to PowerPoint. Before presenting: open the link once so it loads instantly; keep the screen recording ready as a backup.
 TRANSITION: To wrap up.</a:t>
             </a:r>
             <a:endParaRPr lang="en-US" dirty="0"/>

</xml_diff>

<commit_message>
Deck: 9 slides ending with the demo; newsvendor as a limitation; updated speaker notes
Co-Authored-By: Claude Opus 5.5 <noreply@anthropic.com>
</commit_message>
<xml_diff>
--- a/presentation/Group3_Forecasting_Presentation.pptx
+++ b/presentation/Group3_Forecasting_Presentation.pptx
@@ -14,10 +14,9 @@
     <p:sldId id="262" r:id="rId8"/>
     <p:sldId id="263" r:id="rId9"/>
     <p:sldId id="264" r:id="rId10"/>
-    <p:sldId id="265" r:id="rId11"/>
   </p:sldIdLst>
   <p:notesMasterIdLst>
-    <p:notesMasterId r:id="rId12"/>
+    <p:notesMasterId r:id="rId11"/>
   </p:notesMasterIdLst>
   <p:sldSz cx="12192000" cy="6858000"/>
   <p:notesSz cx="6858000" cy="12192000"/>
@@ -116,30 +115,29 @@
   <p:extLst>
     <p:ext uri="{521415D9-36F7-43E2-AB2F-B90AF26B5E84}">
       <p14:sectionLst xmlns:p14="http://schemas.microsoft.com/office/powerpoint/2010/main">
-        <p14:section name="Question and data" id="{f5e58a20-3858-7f6a-3eb9-0079a918180a}">
+        <p14:section name="Question and data" id="{91872f20-acaa-c568-9ba0-491dace308b5}">
           <p14:sldIdLst>
             <p14:sldId id="256"/>
             <p14:sldId id="257"/>
           </p14:sldIdLst>
         </p14:section>
-        <p14:section name="Models and results" id="{f69ecb56-febb-972e-f5eb-37b7bd7241a1}">
+        <p14:section name="Models and results" id="{9abb2d2b-9f68-a9ee-37b7-4dd6f8f50744}">
           <p14:sldIdLst>
             <p14:sldId id="258"/>
             <p14:sldId id="259"/>
             <p14:sldId id="260"/>
           </p14:sldIdLst>
         </p14:section>
-        <p14:section name="LLM experiment" id="{f52c5b96-bc2d-44c7-103b-9ff1fcc4db0e}">
+        <p14:section name="LLM experiment" id="{05c29ca8-b7f7-d474-2a2a-97e8eeb51a23}">
           <p14:sldIdLst>
             <p14:sldId id="261"/>
             <p14:sldId id="262"/>
           </p14:sldIdLst>
         </p14:section>
-        <p14:section name="Business insight and demo" id="{72283f01-455a-78a1-cd8a-4d25a0f2625c}">
+        <p14:section name="Answer and demo" id="{d1142097-cac1-c321-0056-9b35a60d72e5}">
           <p14:sldIdLst>
             <p14:sldId id="263"/>
             <p14:sldId id="264"/>
-            <p14:sldId id="265"/>
           </p14:sldIdLst>
         </p14:section>
       </p14:sectionLst>
@@ -5256,725 +5254,6 @@
 </c:chartSpace>
 </file>
 
-<file path=ppt/charts/chart5.xml><?xml version="1.0" encoding="utf-8"?>
-<c:chartSpace xmlns:c="http://schemas.openxmlformats.org/drawingml/2006/chart" xmlns:a="http://schemas.openxmlformats.org/drawingml/2006/main" xmlns:r="http://schemas.openxmlformats.org/officeDocument/2006/relationships">
-  <c:date1904 val="0"/>
-  <c:roundedCorners val="1"/>
-  <c:chart>
-    <c:title>
-      <c:tx>
-        <c:rich>
-          <a:bodyPr/>
-          <a:lstStyle/>
-          <a:p>
-            <a:pPr>
-              <a:defRPr sz="1400" b="0" i="0" u="none" strike="noStrike">
-                <a:solidFill>
-                  <a:srgbClr val="1F2328"/>
-                </a:solidFill>
-                <a:latin typeface="+mn-lt"/>
-              </a:defRPr>
-            </a:pPr>
-            <a:r>
-              <a:rPr sz="1400" b="0" i="0" u="none" strike="noStrike">
-                <a:solidFill>
-                  <a:srgbClr val="1F2328"/>
-                </a:solidFill>
-                <a:latin typeface="+mn-lt"/>
-              </a:rPr>
-              <a:t>Daily demand for an item that sells 5 a day on average</a:t>
-            </a:r>
-          </a:p>
-        </c:rich>
-      </c:tx>
-      <c:layout/>
-      <c:overlay val="0"/>
-    </c:title>
-    <c:autoTitleDeleted val="0"/>
-    <c:plotArea>
-      <c:layout/>
-      <c:barChart>
-        <c:barDir val="col"/>
-        <c:grouping val="stacked"/>
-        <c:varyColors val="0"/>
-        <c:ser>
-          <c:idx val="0"/>
-          <c:order val="0"/>
-          <c:tx>
-            <c:strRef>
-              <c:f>Sheet1!$B$1</c:f>
-              <c:strCache>
-                <c:ptCount val="1"/>
-                <c:pt idx="0">
-                  <c:v>Other demand levels</c:v>
-                </c:pt>
-              </c:strCache>
-            </c:strRef>
-          </c:tx>
-          <c:spPr>
-            <a:solidFill>
-              <a:srgbClr val="C9CCD3"/>
-            </a:solidFill>
-            <a:effectLst/>
-          </c:spPr>
-          <c:invertIfNegative val="0"/>
-          <c:dLbls>
-            <c:numFmt formatCode="#,##0" sourceLinked="0"/>
-            <c:txPr>
-              <a:bodyPr/>
-              <a:lstStyle/>
-              <a:p>
-                <a:pPr>
-                  <a:defRPr b="0" i="0" strike="noStrike" sz="1200" u="none">
-                    <a:solidFill>
-                      <a:srgbClr val="1F2328"/>
-                    </a:solidFill>
-                    <a:latin typeface="+mn-lt"/>
-                  </a:defRPr>
-                </a:pPr>
-              </a:p>
-            </c:txPr>
-            <c:showLegendKey val="0"/>
-            <c:showVal val="0"/>
-            <c:showCatName val="0"/>
-            <c:showSerName val="0"/>
-            <c:showPercent val="0"/>
-            <c:showBubbleSize val="0"/>
-            <c:showLeaderLines val="0"/>
-          </c:dLbls>
-          <c:cat>
-            <c:multiLvlStrRef>
-              <c:f>Sheet1!$A$2:$A$17</c:f>
-              <c:multiLvlStrCache>
-                <c:ptCount val="16"/>
-                <c:lvl>
-                  <c:pt idx="0">
-                    <c:v>0</c:v>
-                  </c:pt>
-                  <c:pt idx="1">
-                    <c:v>1</c:v>
-                  </c:pt>
-                  <c:pt idx="2">
-                    <c:v>2</c:v>
-                  </c:pt>
-                  <c:pt idx="3">
-                    <c:v>3</c:v>
-                  </c:pt>
-                  <c:pt idx="4">
-                    <c:v>4</c:v>
-                  </c:pt>
-                  <c:pt idx="5">
-                    <c:v>5</c:v>
-                  </c:pt>
-                  <c:pt idx="6">
-                    <c:v>6</c:v>
-                  </c:pt>
-                  <c:pt idx="7">
-                    <c:v>7</c:v>
-                  </c:pt>
-                  <c:pt idx="8">
-                    <c:v>8</c:v>
-                  </c:pt>
-                  <c:pt idx="9">
-                    <c:v>9</c:v>
-                  </c:pt>
-                  <c:pt idx="10">
-                    <c:v>10</c:v>
-                  </c:pt>
-                  <c:pt idx="11">
-                    <c:v>11</c:v>
-                  </c:pt>
-                  <c:pt idx="12">
-                    <c:v>12</c:v>
-                  </c:pt>
-                  <c:pt idx="13">
-                    <c:v>13</c:v>
-                  </c:pt>
-                  <c:pt idx="14">
-                    <c:v>14</c:v>
-                  </c:pt>
-                  <c:pt idx="15">
-                    <c:v>15</c:v>
-                  </c:pt>
-                </c:lvl>
-              </c:multiLvlStrCache>
-            </c:multiLvlStrRef>
-          </c:cat>
-          <c:val>
-            <c:numRef>
-              <c:f>Sheet1!$B$2:$B$17</c:f>
-              <c:numCache>
-                <c:formatCode>General</c:formatCode>
-                <c:ptCount val="16"/>
-                <c:pt idx="0">
-                  <c:v>0.0312</c:v>
-                </c:pt>
-                <c:pt idx="1">
-                  <c:v>0.0781</c:v>
-                </c:pt>
-                <c:pt idx="2">
-                  <c:v>0</c:v>
-                </c:pt>
-                <c:pt idx="3">
-                  <c:v>0.1367</c:v>
-                </c:pt>
-                <c:pt idx="4">
-                  <c:v>0.1367</c:v>
-                </c:pt>
-                <c:pt idx="5">
-                  <c:v>0.123</c:v>
-                </c:pt>
-                <c:pt idx="6">
-                  <c:v>0.1025</c:v>
-                </c:pt>
-                <c:pt idx="7">
-                  <c:v>0</c:v>
-                </c:pt>
-                <c:pt idx="8">
-                  <c:v>0.0604</c:v>
-                </c:pt>
-                <c:pt idx="9">
-                  <c:v>0.0436</c:v>
-                </c:pt>
-                <c:pt idx="10">
-                  <c:v>0.0305</c:v>
-                </c:pt>
-                <c:pt idx="11">
-                  <c:v>0.0208</c:v>
-                </c:pt>
-                <c:pt idx="12">
-                  <c:v>0.0139</c:v>
-                </c:pt>
-                <c:pt idx="13">
-                  <c:v>0.0091</c:v>
-                </c:pt>
-                <c:pt idx="14">
-                  <c:v>0.0058</c:v>
-                </c:pt>
-                <c:pt idx="15">
-                  <c:v>0.0037</c:v>
-                </c:pt>
-              </c:numCache>
-            </c:numRef>
-          </c:val>
-        </c:ser>
-        <c:ser>
-          <c:idx val="1"/>
-          <c:order val="1"/>
-          <c:tx>
-            <c:strRef>
-              <c:f>Sheet1!$C$1</c:f>
-              <c:strCache>
-                <c:ptCount val="1"/>
-                <c:pt idx="0">
-                  <c:v>Order at 20% margin (P20)</c:v>
-                </c:pt>
-              </c:strCache>
-            </c:strRef>
-          </c:tx>
-          <c:spPr>
-            <a:solidFill>
-              <a:srgbClr val="EB6834"/>
-            </a:solidFill>
-            <a:effectLst/>
-          </c:spPr>
-          <c:invertIfNegative val="0"/>
-          <c:dLbls>
-            <c:numFmt formatCode="#,##0" sourceLinked="0"/>
-            <c:txPr>
-              <a:bodyPr/>
-              <a:lstStyle/>
-              <a:p>
-                <a:pPr>
-                  <a:defRPr b="0" i="0" strike="noStrike" sz="1200" u="none">
-                    <a:solidFill>
-                      <a:srgbClr val="1F2328"/>
-                    </a:solidFill>
-                    <a:latin typeface="+mn-lt"/>
-                  </a:defRPr>
-                </a:pPr>
-              </a:p>
-            </c:txPr>
-            <c:showLegendKey val="0"/>
-            <c:showVal val="0"/>
-            <c:showCatName val="0"/>
-            <c:showSerName val="0"/>
-            <c:showPercent val="0"/>
-            <c:showBubbleSize val="0"/>
-            <c:showLeaderLines val="0"/>
-          </c:dLbls>
-          <c:cat>
-            <c:multiLvlStrRef>
-              <c:f>Sheet1!$A$2:$A$17</c:f>
-              <c:multiLvlStrCache>
-                <c:ptCount val="16"/>
-                <c:lvl>
-                  <c:pt idx="0">
-                    <c:v>0</c:v>
-                  </c:pt>
-                  <c:pt idx="1">
-                    <c:v>1</c:v>
-                  </c:pt>
-                  <c:pt idx="2">
-                    <c:v>2</c:v>
-                  </c:pt>
-                  <c:pt idx="3">
-                    <c:v>3</c:v>
-                  </c:pt>
-                  <c:pt idx="4">
-                    <c:v>4</c:v>
-                  </c:pt>
-                  <c:pt idx="5">
-                    <c:v>5</c:v>
-                  </c:pt>
-                  <c:pt idx="6">
-                    <c:v>6</c:v>
-                  </c:pt>
-                  <c:pt idx="7">
-                    <c:v>7</c:v>
-                  </c:pt>
-                  <c:pt idx="8">
-                    <c:v>8</c:v>
-                  </c:pt>
-                  <c:pt idx="9">
-                    <c:v>9</c:v>
-                  </c:pt>
-                  <c:pt idx="10">
-                    <c:v>10</c:v>
-                  </c:pt>
-                  <c:pt idx="11">
-                    <c:v>11</c:v>
-                  </c:pt>
-                  <c:pt idx="12">
-                    <c:v>12</c:v>
-                  </c:pt>
-                  <c:pt idx="13">
-                    <c:v>13</c:v>
-                  </c:pt>
-                  <c:pt idx="14">
-                    <c:v>14</c:v>
-                  </c:pt>
-                  <c:pt idx="15">
-                    <c:v>15</c:v>
-                  </c:pt>
-                </c:lvl>
-              </c:multiLvlStrCache>
-            </c:multiLvlStrRef>
-          </c:cat>
-          <c:val>
-            <c:numRef>
-              <c:f>Sheet1!$C$2:$C$17</c:f>
-              <c:numCache>
-                <c:formatCode>General</c:formatCode>
-                <c:ptCount val="16"/>
-                <c:pt idx="0">
-                  <c:v>0</c:v>
-                </c:pt>
-                <c:pt idx="1">
-                  <c:v>0</c:v>
-                </c:pt>
-                <c:pt idx="2">
-                  <c:v>0.1172</c:v>
-                </c:pt>
-                <c:pt idx="3">
-                  <c:v>0</c:v>
-                </c:pt>
-                <c:pt idx="4">
-                  <c:v>0</c:v>
-                </c:pt>
-                <c:pt idx="5">
-                  <c:v>0</c:v>
-                </c:pt>
-                <c:pt idx="6">
-                  <c:v>0</c:v>
-                </c:pt>
-                <c:pt idx="7">
-                  <c:v>0</c:v>
-                </c:pt>
-                <c:pt idx="8">
-                  <c:v>0</c:v>
-                </c:pt>
-                <c:pt idx="9">
-                  <c:v>0</c:v>
-                </c:pt>
-                <c:pt idx="10">
-                  <c:v>0</c:v>
-                </c:pt>
-                <c:pt idx="11">
-                  <c:v>0</c:v>
-                </c:pt>
-                <c:pt idx="12">
-                  <c:v>0</c:v>
-                </c:pt>
-                <c:pt idx="13">
-                  <c:v>0</c:v>
-                </c:pt>
-                <c:pt idx="14">
-                  <c:v>0</c:v>
-                </c:pt>
-                <c:pt idx="15">
-                  <c:v>0</c:v>
-                </c:pt>
-              </c:numCache>
-            </c:numRef>
-          </c:val>
-        </c:ser>
-        <c:ser>
-          <c:idx val="2"/>
-          <c:order val="2"/>
-          <c:tx>
-            <c:strRef>
-              <c:f>Sheet1!$D$1</c:f>
-              <c:strCache>
-                <c:ptCount val="1"/>
-                <c:pt idx="0">
-                  <c:v>Order at 80% margin (P80)</c:v>
-                </c:pt>
-              </c:strCache>
-            </c:strRef>
-          </c:tx>
-          <c:spPr>
-            <a:solidFill>
-              <a:srgbClr val="2A78D6"/>
-            </a:solidFill>
-            <a:effectLst/>
-          </c:spPr>
-          <c:invertIfNegative val="0"/>
-          <c:dLbls>
-            <c:numFmt formatCode="#,##0" sourceLinked="0"/>
-            <c:txPr>
-              <a:bodyPr/>
-              <a:lstStyle/>
-              <a:p>
-                <a:pPr>
-                  <a:defRPr b="0" i="0" strike="noStrike" sz="1200" u="none">
-                    <a:solidFill>
-                      <a:srgbClr val="1F2328"/>
-                    </a:solidFill>
-                    <a:latin typeface="+mn-lt"/>
-                  </a:defRPr>
-                </a:pPr>
-              </a:p>
-            </c:txPr>
-            <c:showLegendKey val="0"/>
-            <c:showVal val="0"/>
-            <c:showCatName val="0"/>
-            <c:showSerName val="0"/>
-            <c:showPercent val="0"/>
-            <c:showBubbleSize val="0"/>
-            <c:showLeaderLines val="0"/>
-          </c:dLbls>
-          <c:cat>
-            <c:multiLvlStrRef>
-              <c:f>Sheet1!$A$2:$A$17</c:f>
-              <c:multiLvlStrCache>
-                <c:ptCount val="16"/>
-                <c:lvl>
-                  <c:pt idx="0">
-                    <c:v>0</c:v>
-                  </c:pt>
-                  <c:pt idx="1">
-                    <c:v>1</c:v>
-                  </c:pt>
-                  <c:pt idx="2">
-                    <c:v>2</c:v>
-                  </c:pt>
-                  <c:pt idx="3">
-                    <c:v>3</c:v>
-                  </c:pt>
-                  <c:pt idx="4">
-                    <c:v>4</c:v>
-                  </c:pt>
-                  <c:pt idx="5">
-                    <c:v>5</c:v>
-                  </c:pt>
-                  <c:pt idx="6">
-                    <c:v>6</c:v>
-                  </c:pt>
-                  <c:pt idx="7">
-                    <c:v>7</c:v>
-                  </c:pt>
-                  <c:pt idx="8">
-                    <c:v>8</c:v>
-                  </c:pt>
-                  <c:pt idx="9">
-                    <c:v>9</c:v>
-                  </c:pt>
-                  <c:pt idx="10">
-                    <c:v>10</c:v>
-                  </c:pt>
-                  <c:pt idx="11">
-                    <c:v>11</c:v>
-                  </c:pt>
-                  <c:pt idx="12">
-                    <c:v>12</c:v>
-                  </c:pt>
-                  <c:pt idx="13">
-                    <c:v>13</c:v>
-                  </c:pt>
-                  <c:pt idx="14">
-                    <c:v>14</c:v>
-                  </c:pt>
-                  <c:pt idx="15">
-                    <c:v>15</c:v>
-                  </c:pt>
-                </c:lvl>
-              </c:multiLvlStrCache>
-            </c:multiLvlStrRef>
-          </c:cat>
-          <c:val>
-            <c:numRef>
-              <c:f>Sheet1!$D$2:$D$17</c:f>
-              <c:numCache>
-                <c:formatCode>General</c:formatCode>
-                <c:ptCount val="16"/>
-                <c:pt idx="0">
-                  <c:v>0</c:v>
-                </c:pt>
-                <c:pt idx="1">
-                  <c:v>0</c:v>
-                </c:pt>
-                <c:pt idx="2">
-                  <c:v>0</c:v>
-                </c:pt>
-                <c:pt idx="3">
-                  <c:v>0</c:v>
-                </c:pt>
-                <c:pt idx="4">
-                  <c:v>0</c:v>
-                </c:pt>
-                <c:pt idx="5">
-                  <c:v>0</c:v>
-                </c:pt>
-                <c:pt idx="6">
-                  <c:v>0</c:v>
-                </c:pt>
-                <c:pt idx="7">
-                  <c:v>0.0806</c:v>
-                </c:pt>
-                <c:pt idx="8">
-                  <c:v>0</c:v>
-                </c:pt>
-                <c:pt idx="9">
-                  <c:v>0</c:v>
-                </c:pt>
-                <c:pt idx="10">
-                  <c:v>0</c:v>
-                </c:pt>
-                <c:pt idx="11">
-                  <c:v>0</c:v>
-                </c:pt>
-                <c:pt idx="12">
-                  <c:v>0</c:v>
-                </c:pt>
-                <c:pt idx="13">
-                  <c:v>0</c:v>
-                </c:pt>
-                <c:pt idx="14">
-                  <c:v>0</c:v>
-                </c:pt>
-                <c:pt idx="15">
-                  <c:v>0</c:v>
-                </c:pt>
-              </c:numCache>
-            </c:numRef>
-          </c:val>
-        </c:ser>
-        <c:dLbls>
-          <c:numFmt formatCode="#,##0" sourceLinked="0"/>
-          <c:txPr>
-            <a:bodyPr/>
-            <a:lstStyle/>
-            <a:p>
-              <a:pPr>
-                <a:defRPr b="0" i="0" strike="noStrike" sz="1200" u="none">
-                  <a:solidFill>
-                    <a:srgbClr val="1F2328"/>
-                  </a:solidFill>
-                  <a:latin typeface="+mn-lt"/>
-                </a:defRPr>
-              </a:pPr>
-            </a:p>
-          </c:txPr>
-          <c:showLegendKey val="0"/>
-          <c:showVal val="0"/>
-          <c:showCatName val="0"/>
-          <c:showSerName val="0"/>
-          <c:showPercent val="0"/>
-          <c:showBubbleSize val="0"/>
-          <c:showLeaderLines val="0"/>
-        </c:dLbls>
-        <c:gapWidth val="30"/>
-        <c:overlap val="100"/>
-        <c:axId val="2094734554"/>
-        <c:axId val="2094734552"/>
-        <c:axId val="2094734556"/>
-      </c:barChart>
-      <c:catAx>
-        <c:axId val="2094734554"/>
-        <c:scaling>
-          <c:orientation val="minMax"/>
-        </c:scaling>
-        <c:delete val="0"/>
-        <c:axPos val="b"/>
-        <c:title>
-          <c:tx>
-            <c:rich>
-              <a:bodyPr/>
-              <a:lstStyle/>
-              <a:p>
-                <a:pPr>
-                  <a:defRPr sz="1200" b="0" i="0" u="none" strike="noStrike">
-                    <a:solidFill>
-                      <a:srgbClr val="6B6A66"/>
-                    </a:solidFill>
-                    <a:latin typeface="+mn-lt"/>
-                  </a:defRPr>
-                </a:pPr>
-                <a:r>
-                  <a:rPr sz="1200" b="0" i="0" u="none" strike="noStrike">
-                    <a:solidFill>
-                      <a:srgbClr val="6B6A66"/>
-                    </a:solidFill>
-                    <a:latin typeface="+mn-lt"/>
-                  </a:rPr>
-                  <a:t>Units demanded</a:t>
-                </a:r>
-              </a:p>
-            </c:rich>
-          </c:tx>
-          <c:layout/>
-          <c:overlay val="0"/>
-        </c:title>
-        <c:numFmt formatCode="General" sourceLinked="1"/>
-        <c:majorTickMark val="out"/>
-        <c:minorTickMark val="none"/>
-        <c:tickLblPos val="low"/>
-        <c:spPr>
-          <a:ln w="12700" cap="flat">
-            <a:solidFill>
-              <a:srgbClr val="888888"/>
-            </a:solidFill>
-            <a:prstDash val="solid"/>
-            <a:round/>
-          </a:ln>
-        </c:spPr>
-        <c:txPr>
-          <a:bodyPr/>
-          <a:lstStyle/>
-          <a:p>
-            <a:pPr>
-              <a:defRPr sz="1200" b="0" i="0" u="none" strike="noStrike">
-                <a:solidFill>
-                  <a:srgbClr val="6B6A66"/>
-                </a:solidFill>
-                <a:latin typeface="+mn-lt"/>
-              </a:defRPr>
-            </a:pPr>
-            <a:endParaRPr lang="en-US"/>
-          </a:p>
-        </c:txPr>
-        <c:crossAx val="2094734552"/>
-        <c:crosses val="autoZero"/>
-        <c:auto val="1"/>
-        <c:lblAlgn val="ctr"/>
-        <c:noMultiLvlLbl val="1"/>
-      </c:catAx>
-      <c:valAx>
-        <c:axId val="2094734552"/>
-        <c:scaling>
-          <c:orientation val="minMax"/>
-          <c:min val="0"/>
-        </c:scaling>
-        <c:delete val="0"/>
-        <c:axPos val="l"/>
-        <c:majorGridlines>
-          <c:spPr>
-            <a:ln w="6350" cap="flat">
-              <a:solidFill>
-                <a:srgbClr val="D9DCE1"/>
-              </a:solidFill>
-              <a:prstDash val="solid"/>
-              <a:round/>
-            </a:ln>
-          </c:spPr>
-        </c:majorGridlines>
-        <c:numFmt formatCode="0%" sourceLinked="0"/>
-        <c:majorTickMark val="out"/>
-        <c:minorTickMark val="none"/>
-        <c:tickLblPos val="nextTo"/>
-        <c:spPr>
-          <a:ln w="12700" cap="flat">
-            <a:solidFill>
-              <a:srgbClr val="888888"/>
-            </a:solidFill>
-            <a:prstDash val="solid"/>
-            <a:round/>
-          </a:ln>
-        </c:spPr>
-        <c:txPr>
-          <a:bodyPr/>
-          <a:lstStyle/>
-          <a:p>
-            <a:pPr>
-              <a:defRPr sz="1100" b="0" i="0" u="none" strike="noStrike">
-                <a:solidFill>
-                  <a:srgbClr val="6B6A66"/>
-                </a:solidFill>
-                <a:latin typeface="+mn-lt"/>
-              </a:defRPr>
-            </a:pPr>
-            <a:endParaRPr lang="en-US"/>
-          </a:p>
-        </c:txPr>
-        <c:crossAx val="2094734554"/>
-        <c:crosses val="autoZero"/>
-        <c:crossBetween val="between"/>
-      </c:valAx>
-      <c:spPr>
-        <a:noFill/>
-        <a:ln>
-          <a:noFill/>
-        </a:ln>
-        <a:effectLst/>
-      </c:spPr>
-    </c:plotArea>
-    <c:legend>
-      <c:legendPos val="b"/>
-      <c:overlay val="0"/>
-      <c:txPr>
-        <a:bodyPr/>
-        <a:lstStyle/>
-        <a:p>
-          <a:pPr>
-            <a:defRPr sz="1200">
-              <a:solidFill>
-                <a:srgbClr val="1F2328"/>
-              </a:solidFill>
-              <a:latin typeface="+mn-lt"/>
-              <a:cs typeface="+mn-lt"/>
-            </a:defRPr>
-          </a:pPr>
-          <a:endParaRPr lang="en-US"/>
-        </a:p>
-      </c:txPr>
-    </c:legend>
-    <c:plotVisOnly val="1"/>
-    <c:dispBlanksAs val="span"/>
-  </c:chart>
-  <c:spPr>
-    <a:noFill/>
-    <a:ln>
-      <a:noFill/>
-    </a:ln>
-    <a:effectLst/>
-  </c:spPr>
-  <c:externalData r:id="rId1">
-    <c:autoUpdate val="0"/>
-  </c:externalData>
-</c:chartSpace>
-</file>
-
 <file path=ppt/notesMasters/notesMaster1.xml><?xml version="1.0" encoding="utf-8"?>
 <p:notesMaster xmlns:a="http://schemas.openxmlformats.org/drawingml/2006/main" xmlns:r="http://schemas.openxmlformats.org/officeDocument/2006/relationships" xmlns:p="http://schemas.openxmlformats.org/presentationml/2006/main">
   <p:cSld>
@@ -6370,10 +5649,9 @@
           <a:p>
             <a:r>
               <a:rPr lang="en-US" dirty="0"/>
-              <a:t>SPEAKER 1 (0:45)
-Good afternoon, we're Group 3. A retailer's forecast has to do three jobs: be accurate, be cheap and fast enough to run every day for thousands of products, and lead to good stocking decisions.
-LightGBM, a machine-learning method, won Walmart's M5 forecasting competition and became the standard. Since then, AI models pre-trained on huge datasets can forecast with no training at all. So we ask two questions. Can pre-trained AI forecast as well as traditional methods, and faster? And does a better forecast actually mean a better replenishment decision?
-TRANSITION: Here is the data and how we tested.</a:t>
+              <a:t>SPEAKER 1 (0:40)
+Good afternoon, we're Group 3. A retail forecast has three jobs: be accurate, be cheap and fast enough to run every day for thousands of products, and support good stocking decisions. In Walmart's M5 forecasting competition, LightGBM, a machine-learning method, dominated. Since then, AI models pre-trained on huge datasets can forecast with no training at all. So we ask: can these AI foundation models beat traditional statistical and machine-learning methods, on accuracy and on efficiency?
+TRANSITION: Here is our data and how we tested.</a:t>
             </a:r>
             <a:endParaRPr lang="en-US" dirty="0"/>
           </a:p>
@@ -6397,96 +5675,6 @@
             <a:fld id="{F7021451-1387-4CA6-816F-3879F97B5CBC}" type="slidenum">
               <a:rPr lang="en-US"/>
               <a:t>1</a:t>
-            </a:fld>
-            <a:endParaRPr lang="en-US"/>
-          </a:p>
-        </p:txBody>
-      </p:sp>
-    </p:spTree>
-    <p:extLst>
-      <p:ext uri="{BB962C8B-B14F-4D97-AF65-F5344CB8AC3E}">
-        <p14:creationId xmlns:p14="http://schemas.microsoft.com/office/powerpoint/2010/main" val="1024086991"/>
-      </p:ext>
-    </p:extLst>
-  </p:cSld>
-  <p:clrMapOvr>
-    <a:masterClrMapping/>
-  </p:clrMapOvr>
-</p:notes>
-</file>
-
-<file path=ppt/notesSlides/notesSlide10.xml><?xml version="1.0" encoding="utf-8"?>
-<p:notes xmlns:a="http://schemas.openxmlformats.org/drawingml/2006/main" xmlns:r="http://schemas.openxmlformats.org/officeDocument/2006/relationships" xmlns:p="http://schemas.openxmlformats.org/presentationml/2006/main">
-  <p:cSld>
-    <p:spTree>
-      <p:nvGrpSpPr>
-        <p:cNvPr id="1" name=""/>
-        <p:cNvGrpSpPr/>
-        <p:nvPr/>
-      </p:nvGrpSpPr>
-      <p:grpSpPr>
-        <a:xfrm>
-          <a:off x="0" y="0"/>
-          <a:ext cx="0" cy="0"/>
-          <a:chOff x="0" y="0"/>
-          <a:chExt cx="0" cy="0"/>
-        </a:xfrm>
-      </p:grpSpPr>
-      <p:sp>
-        <p:nvSpPr>
-          <p:cNvPr id="2" name="Slide Image Placeholder 1"/>
-          <p:cNvSpPr>
-            <a:spLocks noGrp="1" noRot="1" noChangeAspect="1"/>
-          </p:cNvSpPr>
-          <p:nvPr>
-            <p:ph type="sldImg"/>
-          </p:nvPr>
-        </p:nvSpPr>
-        <p:spPr/>
-      </p:sp>
-      <p:sp>
-        <p:nvSpPr>
-          <p:cNvPr id="3" name="Notes Placeholder 2"/>
-          <p:cNvSpPr>
-            <a:spLocks noGrp="1"/>
-          </p:cNvSpPr>
-          <p:nvPr>
-            <p:ph type="body" idx="1"/>
-          </p:nvPr>
-        </p:nvSpPr>
-        <p:spPr/>
-        <p:txBody>
-          <a:bodyPr/>
-          <a:lstStyle/>
-          <a:p>
-            <a:r>
-              <a:rPr lang="en-US" dirty="0"/>
-              <a:t>SPEAKER 4 (0:30)
-To sum up: traditional methods still lead on accuracy. LightGBM is the best single model, AutoETS is close behind, and simply averaging the two is best of all. Chronos offers a huge speed advantage, though its accuracy was weaker here. Claude matched the best traditional approach on the store totals, but on limited evidence. And good replenishment depends on costs and uncertainty, not on accuracy alone.
-Thank you; we're happy to take questions.</a:t>
-            </a:r>
-            <a:endParaRPr lang="en-US" dirty="0"/>
-          </a:p>
-        </p:txBody>
-      </p:sp>
-      <p:sp>
-        <p:nvSpPr>
-          <p:cNvPr id="4" name="Slide Number Placeholder 3"/>
-          <p:cNvSpPr>
-            <a:spLocks noGrp="1"/>
-          </p:cNvSpPr>
-          <p:nvPr>
-            <p:ph type="sldNum" sz="quarter" idx="10"/>
-          </p:nvPr>
-        </p:nvSpPr>
-        <p:spPr/>
-        <p:txBody>
-          <a:bodyPr/>
-          <a:lstStyle/>
-          <a:p>
-            <a:fld id="{F7021451-1387-4CA6-816F-3879F97B5CBC}" type="slidenum">
-              <a:rPr lang="en-US"/>
-              <a:t>10</a:t>
             </a:fld>
             <a:endParaRPr lang="en-US"/>
           </a:p>
@@ -6551,11 +5739,10 @@
           <a:p>
             <a:r>
               <a:rPr lang="en-US" dirty="0"/>
-              <a:t>SPEAKER 1 (1:15)
-We used Walmart's M5 data: the four California stores and all 1,437 food items, so 5,748 daily series, each one item in one store.
-The split is simple. Every model is trained on data up to May 22, 2016, and forecasts the next 28 days, the official M5 test window. No model sees those days. The one model we tuned, LightGBM, was tuned only on the last 28 days of the training period.
-We score with WRMSSE, the competition's own metric. It scales each product's error by how hard that product is to forecast and weights it by dollar sales; lower is better, and below one beats a naive forecast.
-One caveat up front: everything comes from a single 28-day window, so close rankings could shift in another month.
+              <a:t>SPEAKER 1 (1:00)
+We used Walmart's M5 data: all 1,437 food items in four California stores, so 5,748 daily series, each one item in one store.
+Every model trains on data up to May 22, 2016, and forecasts the next 28 days, the official M5 test window, which no model sees. The one model we tuned, LightGBM, was tuned only on the last 28 training days.
+We score accuracy with WRMSSE, the competition's own metric: it scales each product's error by how hard it is to forecast and weights it by dollar sales. Lower is better, and below one beats a naive forecast. One caveat up front: this is a single 28-day window.
 TRANSITION: Speaker 2 will introduce the models.</a:t>
             </a:r>
             <a:endParaRPr lang="en-US" dirty="0"/>
@@ -6644,7 +5831,7 @@
           <a:p>
             <a:r>
               <a:rPr lang="en-US" dirty="0"/>
-              <a:t>SPEAKER 2 (1:00)
+              <a:t>SPEAKER 2 (0:50)
 We compared five models. AutoETS and AutoARIMA are classic time series models: they fit one model to each product's own history, with a weekly cycle.
 LightGBM is the M5 winner's approach: one machine-learning model trained across all products at once, which then predicts each product. It also sees prices, holidays and food-stamp days.
 Chronos is Amazon's pre-trained AI model for time series. It was trained on about 100 billion data points from other domains and forecasts our data zero-shot, with no training. And seasonal naive, 'same weekday last week', is the benchmark.
@@ -6737,7 +5924,7 @@
           <a:p>
             <a:r>
               <a:rPr lang="en-US" dirty="0"/>
-              <a:t>SPEAKER 2 (1:00)
+              <a:t>SPEAKER 2 (0:55)
 Across all 5,748 series, LightGBM was the most accurate single model, with a WRMSSE of 0.646. AutoETS, a much simpler statistical model, was close behind at 0.661. These two were the only single models to beat the seasonal-naive benchmark at 0.814; AutoARIMA scored 0.89 and Chronos 0.95.
 The best result came from simply averaging AutoETS and LightGBM: 0.604, better than either, with no tuning. The two make different kinds of errors, so averaging cancels part of them. Our teammate's Shelf Signal study found the same thing on a different store and item set.
 TRANSITION: But the overall score hides an important pattern.</a:t>
@@ -6828,7 +6015,7 @@
           <a:p>
             <a:r>
               <a:rPr lang="en-US" dirty="0"/>
-              <a:t>SPEAKER 2 (1:00)
+              <a:t>SPEAKER 2 (0:55)
 The ranking changes with the level. On the left are store and department totals, where LightGBM and AutoETS are far ahead: they capture the shared weekly pattern. AutoARIMA and Chronos forecast each product separately and give nearly flat lines for slow sellers, so their totals miss the weekend peaks.
 On the right, for one item in one store, all models are close. But close is not the same as a statistical tie; we did not formally test those gaps.
 On speed, the differences are huge. Chronos forecasts everything in 10 seconds with no training. LightGBM and AutoETS take under a minute and a half; AutoARIMA takes 39 minutes. So Chronos's advantage in our study is speed, while its overall accuracy is weaker.
@@ -7012,11 +6199,11 @@
           <a:p>
             <a:r>
               <a:rPr lang="en-US" dirty="0"/>
-              <a:t>SPEAKER 3 (1:00)
+              <a:t>SPEAKER 3 (0:50)
 Forecasting with a language model has four risks. First, contamination: the M5 data is public, so Claude may have seen it in training. Our safeguard was the named-versus-blind test: we removed product names, dates and the year. Accuracy didn't change, 0.579 versus 0.583, so real names gave it no advantage.
 Second, outputs can vary between runs; we fixed the prompt and model and saved every response. Third, cost and scale, which is why we used a subset and compared every model on the same subset. Fourth, malformed answers; we required a fixed format and checked every response.
 But be clear about the limit: the blind test reduces identity cues; it cannot guarantee contamination is excluded, because the sales pattern itself could still be recognised.
-TRANSITION: Speaker 4 will turn forecasts into business decisions.</a:t>
+TRANSITION: Speaker 4 will wrap up and show the dashboard.</a:t>
             </a:r>
             <a:endParaRPr lang="en-US" dirty="0"/>
           </a:p>
@@ -7104,11 +6291,11 @@
           <a:p>
             <a:r>
               <a:rPr lang="en-US" dirty="0"/>
-              <a:t>SPEAKER 4 (1:15)
-A forecast only matters through the decision it drives. Here is the key business insight: the best order quantity is not the forecast.
-This is the newsvendor problem. If leftover food has no salvage value, you should order the demand level you will meet with probability equal to your profit margin. Take an item that sells 5 units a day on average. With a 20% margin, every wasted unit costs four times a lost sale, so you order low, at the 20th percentile: 2 units. With an 80% margin it's the reverse: order high, at the 80th percentile, 7 units.
-So a retailer needs the whole demand distribution, not just one number. And when we tested this, more accurate forecasts earned significantly more only at an 80% margin; at typical margins the profit differences were within chance.
-TRANSITION: Let me show you this in our dashboard.</a:t>
+              <a:t>SPEAKER 4 (1:20)
+So, can AI foundation models beat traditional methods? Our answer: not yet on accuracy, yes on speed. LightGBM, AutoETS and their simple average were the three most accurate. Chronos was the clear winner on speed: ten seconds, no training. And Claude matched the best traditional approach on store totals, but on only 112 series.
+Three limitations. First, we tested one 28-day window, so close rankings could flip in another month. Second, Claude was tested on a subset, and our blind test can't fully rule out that it saw this public data.
+Third, and most important for a business: accuracy isn't the real goal. Ordering stock is a newsvendor problem with two different costs. If you order too little, you lose the margin on every sale you miss; that's the underage cost. If you order too much, unsold food is wasted at its cost; that's the overage cost. Because those costs depend on the margin, the best order isn't the forecast itself but a quantile of demand. Our accuracy metrics treat over- and under-forecasting the same, so they don't capture this. Let me show you in our dashboard.
+TRANSITION: switch to the demo.</a:t>
             </a:r>
             <a:endParaRPr lang="en-US" dirty="0"/>
           </a:p>
@@ -7196,13 +6383,13 @@
           <a:p>
             <a:r>
               <a:rPr lang="en-US" dirty="0"/>
-              <a:t>SPEAKER 4 (1:15)
-[LIVE DEMO. If the connection fails, play the screen recording.]
-This is Shelf Signal version 2, which extends our teammate's original dashboard with all of this project's models. First, in the Forecast explorer, I pick a series, say a store's dairy department, and replay each model's forecast against what actually sold.
-Second, in the Order planner, I keep the forecast fixed and change the profit margin. Watch the recommended order: at a low margin it sits near the 20th percentile of demand, and as the margin rises it moves toward the 80th. The table below scores every model's orders against actual sales. Same forecast, different decision.
-Third, note that actual sales are only used to evaluate the forecast afterwards; the forecasts never see the test days.
-HOW TO DEMO: in Slide Show mode, click the screenshot (or 'Open live dashboard'). The browser opens on the Order planner. Do the demo, then press Cmd+Tab to return to PowerPoint. Before presenting: open the link once so it loads instantly; keep the screen recording ready as a backup.
-TRANSITION: To wrap up.</a:t>
+              <a:t>SPEAKER 4 (1:30 demo + 0:10 close)
+[Click the screenshot to open the dashboard. If the internet fails, play the screen recording.]
+(0:00-0:20) FORECAST EXPLORER. This is Shelf Signal, which extends our teammate's original dashboard with all our models. Here's one store's department total: the black line is actual sales, and you can switch each model on and off. The ensemble and LightGBM follow the weekend peaks; Chronos runs low.
+(0:20-0:40) AI LAB. Here Claude explains its own forecast in plain English, and this chart is the named-versus-blind test: every point sits on the diagonal, so real names gave it no advantage.
+(0:40-1:30) ORDER PLANNER. Now the business problem. For this item, the model forecasts about eight units for the day. At a 50% margin, the best order is the median of demand. Drop the margin to 20%: a wasted unit now costs four times a lost sale, so the order falls. Raise it to 80%: a lost sale costs four times a wasted unit, so we order more. Same forecast, different decision. The table scores every model's orders against actual sales: the profit ranking isn't the same as the accuracy ranking, and at typical margins the differences are small.
+(close) That's our project. Thank you, and we're happy to take questions.
+[Press Cmd+Tab to return to the slides for Q&amp;A.]</a:t>
             </a:r>
             <a:endParaRPr lang="en-US" dirty="0"/>
           </a:p>
@@ -8766,493 +7953,6 @@
 </p:sld>
 </file>
 
-<file path=ppt/slides/slide10.xml><?xml version="1.0" encoding="utf-8"?>
-<p:sld xmlns:a="http://schemas.openxmlformats.org/drawingml/2006/main" xmlns:r="http://schemas.openxmlformats.org/officeDocument/2006/relationships" xmlns:p="http://schemas.openxmlformats.org/presentationml/2006/main">
-  <p:cSld name="Slide 10">
-    <p:spTree>
-      <p:nvGrpSpPr>
-        <p:cNvPr id="1" name=""/>
-        <p:cNvGrpSpPr/>
-        <p:nvPr/>
-      </p:nvGrpSpPr>
-      <p:grpSpPr>
-        <a:xfrm>
-          <a:off x="0" y="0"/>
-          <a:ext cx="0" cy="0"/>
-          <a:chOff x="0" y="0"/>
-          <a:chExt cx="0" cy="0"/>
-        </a:xfrm>
-      </p:grpSpPr>
-      <p:sp>
-        <p:nvSpPr>
-          <p:cNvPr id="2" name="Text 0"/>
-          <p:cNvSpPr/>
-          <p:nvPr>
-            <p:ph idx="100" type="title" hasCustomPrompt="1"/>
-          </p:nvPr>
-        </p:nvSpPr>
-        <p:spPr>
-          <a:xfrm>
-            <a:off x="548640" y="320040"/>
-            <a:ext cx="11064240" cy="868680"/>
-          </a:xfrm>
-          <a:prstGeom prst="rect">
-            <a:avLst/>
-          </a:prstGeom>
-          <a:noFill/>
-          <a:ln/>
-        </p:spPr>
-        <p:txBody>
-          <a:bodyPr wrap="square" rtlCol="0" anchor="ctr"/>
-          <a:lstStyle/>
-          <a:p>
-            <a:pPr algn="l" indent="0" marL="0">
-              <a:buNone/>
-            </a:pPr>
-            <a:r>
-              <a:rPr lang="en-US" sz="3400" b="1" dirty="0">
-                <a:solidFill>
-                  <a:schemeClr val="bg1"/>
-                </a:solidFill>
-              </a:rPr>
-              <a:t>Takeaways</a:t>
-            </a:r>
-            <a:endParaRPr lang="en-US" sz="3400" dirty="0"/>
-          </a:p>
-        </p:txBody>
-      </p:sp>
-      <p:sp>
-        <p:nvSpPr>
-          <p:cNvPr id="3" name="Traditional methods lead on accuracy: LightGBM, AutoETS and their average circle"/>
-          <p:cNvSpPr/>
-          <p:nvPr/>
-        </p:nvSpPr>
-        <p:spPr>
-          <a:xfrm>
-            <a:off x="731520" y="1417320"/>
-            <a:ext cx="731520" cy="731520"/>
-          </a:xfrm>
-          <a:prstGeom prst="ellipse">
-            <a:avLst/>
-          </a:prstGeom>
-          <a:solidFill>
-            <a:srgbClr val="2A78D6"/>
-          </a:solidFill>
-          <a:ln w="12700">
-            <a:solidFill>
-              <a:srgbClr val="2A78D6"/>
-            </a:solidFill>
-            <a:prstDash val="solid"/>
-          </a:ln>
-        </p:spPr>
-      </p:sp>
-      <p:pic>
-        <p:nvPicPr>
-          <p:cNvPr id="4" name="Traditional methods lead on accuracy: LightGBM, AutoETS and their average icon" descr="preencoded.png">    </p:cNvPr>
-          <p:cNvPicPr>
-            <a:picLocks noChangeAspect="1"/>
-          </p:cNvPicPr>
-          <p:nvPr/>
-        </p:nvPicPr>
-        <p:blipFill>
-          <a:blip r:embed="rId1"/>
-          <a:stretch>
-            <a:fillRect/>
-          </a:stretch>
-        </p:blipFill>
-        <p:spPr>
-          <a:xfrm>
-            <a:off x="907085" y="1592885"/>
-            <a:ext cx="380390" cy="380390"/>
-          </a:xfrm>
-          <a:prstGeom prst="rect">
-            <a:avLst/>
-          </a:prstGeom>
-        </p:spPr>
-      </p:pic>
-      <p:sp>
-        <p:nvSpPr>
-          <p:cNvPr id="5" name="Text 2"/>
-          <p:cNvSpPr txBox="1"/>
-          <p:nvPr/>
-        </p:nvSpPr>
-        <p:spPr>
-          <a:xfrm>
-            <a:off x="1691640" y="1417320"/>
-            <a:ext cx="9875520" cy="731520"/>
-          </a:xfrm>
-          <a:prstGeom prst="rect">
-            <a:avLst/>
-          </a:prstGeom>
-          <a:noFill/>
-          <a:ln/>
-        </p:spPr>
-        <p:txBody>
-          <a:bodyPr wrap="square" lIns="0" tIns="0" rIns="0" bIns="0" rtlCol="0" anchor="ctr"/>
-          <a:lstStyle/>
-          <a:p>
-            <a:pPr indent="0" marL="0">
-              <a:buNone/>
-            </a:pPr>
-            <a:r>
-              <a:rPr lang="en-US" sz="2200" b="1" dirty="0">
-                <a:solidFill>
-                  <a:schemeClr val="bg1"/>
-                </a:solidFill>
-              </a:rPr>
-              <a:t>Traditional methods lead on accuracy: LightGBM, AutoETS and their average</a:t>
-            </a:r>
-            <a:endParaRPr lang="en-US" sz="2200" dirty="0"/>
-          </a:p>
-        </p:txBody>
-      </p:sp>
-      <p:sp>
-        <p:nvSpPr>
-          <p:cNvPr id="6" name="Chronos offers a large speed advantage, with weaker accuracy here circle"/>
-          <p:cNvSpPr/>
-          <p:nvPr/>
-        </p:nvSpPr>
-        <p:spPr>
-          <a:xfrm>
-            <a:off x="731520" y="2377440"/>
-            <a:ext cx="731520" cy="731520"/>
-          </a:xfrm>
-          <a:prstGeom prst="ellipse">
-            <a:avLst/>
-          </a:prstGeom>
-          <a:solidFill>
-            <a:srgbClr val="EB6834"/>
-          </a:solidFill>
-          <a:ln w="12700">
-            <a:solidFill>
-              <a:srgbClr val="EB6834"/>
-            </a:solidFill>
-            <a:prstDash val="solid"/>
-          </a:ln>
-        </p:spPr>
-      </p:sp>
-      <p:pic>
-        <p:nvPicPr>
-          <p:cNvPr id="7" name="Chronos offers a large speed advantage, with weaker accuracy here icon" descr="preencoded.png">    </p:cNvPr>
-          <p:cNvPicPr>
-            <a:picLocks noChangeAspect="1"/>
-          </p:cNvPicPr>
-          <p:nvPr/>
-        </p:nvPicPr>
-        <p:blipFill>
-          <a:blip r:embed="rId2"/>
-          <a:stretch>
-            <a:fillRect/>
-          </a:stretch>
-        </p:blipFill>
-        <p:spPr>
-          <a:xfrm>
-            <a:off x="907085" y="2553005"/>
-            <a:ext cx="380390" cy="380390"/>
-          </a:xfrm>
-          <a:prstGeom prst="rect">
-            <a:avLst/>
-          </a:prstGeom>
-        </p:spPr>
-      </p:pic>
-      <p:sp>
-        <p:nvSpPr>
-          <p:cNvPr id="8" name="Text 4"/>
-          <p:cNvSpPr txBox="1"/>
-          <p:nvPr/>
-        </p:nvSpPr>
-        <p:spPr>
-          <a:xfrm>
-            <a:off x="1691640" y="2377440"/>
-            <a:ext cx="9875520" cy="731520"/>
-          </a:xfrm>
-          <a:prstGeom prst="rect">
-            <a:avLst/>
-          </a:prstGeom>
-          <a:noFill/>
-          <a:ln/>
-        </p:spPr>
-        <p:txBody>
-          <a:bodyPr wrap="square" lIns="0" tIns="0" rIns="0" bIns="0" rtlCol="0" anchor="ctr"/>
-          <a:lstStyle/>
-          <a:p>
-            <a:pPr indent="0" marL="0">
-              <a:buNone/>
-            </a:pPr>
-            <a:r>
-              <a:rPr lang="en-US" sz="2200" b="1" dirty="0">
-                <a:solidFill>
-                  <a:schemeClr val="bg1"/>
-                </a:solidFill>
-              </a:rPr>
-              <a:t>Chronos offers a large speed advantage, with weaker accuracy here</a:t>
-            </a:r>
-            <a:endParaRPr lang="en-US" sz="2200" dirty="0"/>
-          </a:p>
-        </p:txBody>
-      </p:sp>
-      <p:sp>
-        <p:nvSpPr>
-          <p:cNvPr id="9" name="Claude matched the best traditional approach on totals; evidence is limited circle"/>
-          <p:cNvSpPr/>
-          <p:nvPr/>
-        </p:nvSpPr>
-        <p:spPr>
-          <a:xfrm>
-            <a:off x="731520" y="3337560"/>
-            <a:ext cx="731520" cy="731520"/>
-          </a:xfrm>
-          <a:prstGeom prst="ellipse">
-            <a:avLst/>
-          </a:prstGeom>
-          <a:solidFill>
-            <a:srgbClr val="4A3AA7"/>
-          </a:solidFill>
-          <a:ln w="12700">
-            <a:solidFill>
-              <a:srgbClr val="4A3AA7"/>
-            </a:solidFill>
-            <a:prstDash val="solid"/>
-          </a:ln>
-        </p:spPr>
-      </p:sp>
-      <p:pic>
-        <p:nvPicPr>
-          <p:cNvPr id="10" name="Claude matched the best traditional approach on totals; evidence is limited icon" descr="preencoded.png">    </p:cNvPr>
-          <p:cNvPicPr>
-            <a:picLocks noChangeAspect="1"/>
-          </p:cNvPicPr>
-          <p:nvPr/>
-        </p:nvPicPr>
-        <p:blipFill>
-          <a:blip r:embed="rId3"/>
-          <a:stretch>
-            <a:fillRect/>
-          </a:stretch>
-        </p:blipFill>
-        <p:spPr>
-          <a:xfrm>
-            <a:off x="907085" y="3513125"/>
-            <a:ext cx="380390" cy="380390"/>
-          </a:xfrm>
-          <a:prstGeom prst="rect">
-            <a:avLst/>
-          </a:prstGeom>
-        </p:spPr>
-      </p:pic>
-      <p:sp>
-        <p:nvSpPr>
-          <p:cNvPr id="11" name="Text 6"/>
-          <p:cNvSpPr txBox="1"/>
-          <p:nvPr/>
-        </p:nvSpPr>
-        <p:spPr>
-          <a:xfrm>
-            <a:off x="1691640" y="3337560"/>
-            <a:ext cx="9875520" cy="731520"/>
-          </a:xfrm>
-          <a:prstGeom prst="rect">
-            <a:avLst/>
-          </a:prstGeom>
-          <a:noFill/>
-          <a:ln/>
-        </p:spPr>
-        <p:txBody>
-          <a:bodyPr wrap="square" lIns="0" tIns="0" rIns="0" bIns="0" rtlCol="0" anchor="ctr"/>
-          <a:lstStyle/>
-          <a:p>
-            <a:pPr indent="0" marL="0">
-              <a:buNone/>
-            </a:pPr>
-            <a:r>
-              <a:rPr lang="en-US" sz="2200" b="1" dirty="0">
-                <a:solidFill>
-                  <a:schemeClr val="bg1"/>
-                </a:solidFill>
-              </a:rPr>
-              <a:t>Claude matched the best traditional approach on totals; evidence is limited</a:t>
-            </a:r>
-            <a:endParaRPr lang="en-US" sz="2200" dirty="0"/>
-          </a:p>
-        </p:txBody>
-      </p:sp>
-      <p:sp>
-        <p:nvSpPr>
-          <p:cNvPr id="12" name="Good replenishment depends on costs and uncertainty, not accuracy alone circle"/>
-          <p:cNvSpPr/>
-          <p:nvPr/>
-        </p:nvSpPr>
-        <p:spPr>
-          <a:xfrm>
-            <a:off x="731520" y="4297680"/>
-            <a:ext cx="731520" cy="731520"/>
-          </a:xfrm>
-          <a:prstGeom prst="ellipse">
-            <a:avLst/>
-          </a:prstGeom>
-          <a:solidFill>
-            <a:srgbClr val="F2B33D"/>
-          </a:solidFill>
-          <a:ln w="12700">
-            <a:solidFill>
-              <a:srgbClr val="F2B33D"/>
-            </a:solidFill>
-            <a:prstDash val="solid"/>
-          </a:ln>
-        </p:spPr>
-      </p:sp>
-      <p:pic>
-        <p:nvPicPr>
-          <p:cNvPr id="13" name="Good replenishment depends on costs and uncertainty, not accuracy alone icon" descr="preencoded.png">    </p:cNvPr>
-          <p:cNvPicPr>
-            <a:picLocks noChangeAspect="1"/>
-          </p:cNvPicPr>
-          <p:nvPr/>
-        </p:nvPicPr>
-        <p:blipFill>
-          <a:blip r:embed="rId4"/>
-          <a:stretch>
-            <a:fillRect/>
-          </a:stretch>
-        </p:blipFill>
-        <p:spPr>
-          <a:xfrm>
-            <a:off x="907085" y="4473245"/>
-            <a:ext cx="380390" cy="380390"/>
-          </a:xfrm>
-          <a:prstGeom prst="rect">
-            <a:avLst/>
-          </a:prstGeom>
-        </p:spPr>
-      </p:pic>
-      <p:sp>
-        <p:nvSpPr>
-          <p:cNvPr id="14" name="Text 8"/>
-          <p:cNvSpPr txBox="1"/>
-          <p:nvPr/>
-        </p:nvSpPr>
-        <p:spPr>
-          <a:xfrm>
-            <a:off x="1691640" y="4297680"/>
-            <a:ext cx="9875520" cy="731520"/>
-          </a:xfrm>
-          <a:prstGeom prst="rect">
-            <a:avLst/>
-          </a:prstGeom>
-          <a:noFill/>
-          <a:ln/>
-        </p:spPr>
-        <p:txBody>
-          <a:bodyPr wrap="square" lIns="0" tIns="0" rIns="0" bIns="0" rtlCol="0" anchor="ctr"/>
-          <a:lstStyle/>
-          <a:p>
-            <a:pPr indent="0" marL="0">
-              <a:buNone/>
-            </a:pPr>
-            <a:r>
-              <a:rPr lang="en-US" sz="2200" b="1" dirty="0">
-                <a:solidFill>
-                  <a:schemeClr val="bg1"/>
-                </a:solidFill>
-              </a:rPr>
-              <a:t>Good replenishment depends on costs and uncertainty, not accuracy alone</a:t>
-            </a:r>
-            <a:endParaRPr lang="en-US" sz="2200" dirty="0"/>
-          </a:p>
-        </p:txBody>
-      </p:sp>
-      <p:sp>
-        <p:nvSpPr>
-          <p:cNvPr id="15" name="Text 9"/>
-          <p:cNvSpPr txBox="1"/>
-          <p:nvPr/>
-        </p:nvSpPr>
-        <p:spPr>
-          <a:xfrm>
-            <a:off x="731520" y="5486400"/>
-            <a:ext cx="10058400" cy="640080"/>
-          </a:xfrm>
-          <a:prstGeom prst="rect">
-            <a:avLst/>
-          </a:prstGeom>
-          <a:noFill/>
-          <a:ln/>
-        </p:spPr>
-        <p:txBody>
-          <a:bodyPr wrap="square" lIns="0" tIns="0" rIns="0" bIns="0" rtlCol="0" anchor="ctr"/>
-          <a:lstStyle/>
-          <a:p>
-            <a:pPr indent="0" marL="0">
-              <a:buNone/>
-            </a:pPr>
-            <a:r>
-              <a:rPr lang="en-US" sz="3000" b="1" dirty="0">
-                <a:solidFill>
-                  <a:srgbClr val="F2B33D"/>
-                </a:solidFill>
-                <a:latin typeface="Cambria" pitchFamily="34" charset="0"/>
-                <a:ea typeface="Cambria" pitchFamily="34" charset="-122"/>
-                <a:cs typeface="Cambria" pitchFamily="34" charset="-120"/>
-              </a:rPr>
-              <a:t>Thank you — questions?</a:t>
-            </a:r>
-            <a:endParaRPr lang="en-US" sz="3000" dirty="0"/>
-          </a:p>
-        </p:txBody>
-      </p:sp>
-      <p:sp>
-        <p:nvSpPr>
-          <p:cNvPr id="25" name="Slide Number Placeholder 0"/>
-          <p:cNvSpPr>
-            <a:spLocks noGrp="1"/>
-          </p:cNvSpPr>
-          <p:nvPr>
-            <p:ph type="sldNum" sz="quarter" idx="4294967295"/>
-          </p:nvPr>
-        </p:nvSpPr>
-        <p:spPr>
-          <a:xfrm>
-            <a:off x="11155680" y="6400800"/>
-            <a:ext cx="548640" cy="274320"/>
-          </a:xfrm>
-          <a:prstGeom prst="rect">
-            <a:avLst/>
-          </a:prstGeom>
-          <a:extLst>
-            <a:ext uri="{C572A759-6A51-4108-AA02-DFA0A04FC94B}">
-              <ma14:wrappingTextBoxFlag xmlns:ma14="http://schemas.microsoft.com/office/mac/drawingml/2011/main" val="0"/>
-            </a:ext>
-          </a:extLst>
-        </p:spPr>
-        <p:txBody>
-          <a:bodyPr/>
-          <a:lstStyle>
-            <a:lvl1pPr>
-              <a:defRPr sz="1000">
-                <a:solidFill>
-                  <a:schemeClr val="bg2"/>
-                </a:solidFill>
-              </a:defRPr>
-            </a:lvl1pPr>
-          </a:lstStyle>
-          <a:p>
-            <a:pPr algn="r"/>
-            <a:fld id="{F7021451-1387-4CA6-816F-3879F97B5CBC}" type="slidenum">
-              <a:rPr b="0" lang="en-US"/>
-              <a:t>10</a:t>
-            </a:fld>
-            <a:endParaRPr lang="en-US"/>
-          </a:p>
-        </p:txBody>
-      </p:sp>
-    </p:spTree>
-  </p:cSld>
-  <p:clrMapOvr>
-    <a:masterClrMapping/>
-  </p:clrMapOvr>
-</p:sld>
-</file>
-
 <file path=ppt/slides/slide2.xml><?xml version="1.0" encoding="utf-8"?>
 <p:sld xmlns:a="http://schemas.openxmlformats.org/drawingml/2006/main" xmlns:r="http://schemas.openxmlformats.org/officeDocument/2006/relationships" xmlns:p="http://schemas.openxmlformats.org/presentationml/2006/main">
   <p:cSld name="Slide 2">
@@ -14983,58 +13683,64 @@
             <a:r>
               <a:rPr lang="en-US" sz="3400" b="1" dirty="0">
                 <a:solidFill>
-                  <a:schemeClr val="tx2"/>
+                  <a:schemeClr val="bg1"/>
                 </a:solidFill>
               </a:rPr>
-              <a:t>The best order is not the forecast</a:t>
+              <a:t>Our answer: not yet on accuracy, yes on speed</a:t>
             </a:r>
             <a:endParaRPr lang="en-US" sz="3400" dirty="0"/>
           </a:p>
         </p:txBody>
       </p:sp>
-      <p:graphicFrame>
-        <p:nvGraphicFramePr>
-          <p:cNvPr id="3" name="demand distribution chart" descr=""/>
-          <p:cNvGraphicFramePr/>
-          <p:nvPr/>
-        </p:nvGraphicFramePr>
-        <p:xfrm>
-          <a:off x="548640" y="1371600"/>
-          <a:ext cx="6400800" cy="4389120"/>
-        </p:xfrm>
-        <a:graphic xmlns:a="http://schemas.openxmlformats.org/drawingml/2006/main">
-          <a:graphicData uri="http://schemas.openxmlformats.org/drawingml/2006/chart">
-            <c:chart xmlns:c="http://schemas.openxmlformats.org/drawingml/2006/chart" r:id="rId1"/>
-          </a:graphicData>
-        </a:graphic>
-      </p:graphicFrame>
-      <p:sp>
-        <p:nvSpPr>
-          <p:cNvPr id="4" name="formula card"/>
+      <p:sp>
+        <p:nvSpPr>
+          <p:cNvPr id="3" name="Traditional methods lead on accuracy circle"/>
           <p:cNvSpPr/>
           <p:nvPr/>
         </p:nvSpPr>
         <p:spPr>
           <a:xfrm>
-            <a:off x="7315200" y="1417320"/>
-            <a:ext cx="4297680" cy="1325880"/>
-          </a:xfrm>
-          <a:prstGeom prst="roundRect">
-            <a:avLst>
-              <a:gd name="adj" fmla="val 8276"/>
-            </a:avLst>
+            <a:off x="548640" y="1463040"/>
+            <a:ext cx="731520" cy="731520"/>
+          </a:xfrm>
+          <a:prstGeom prst="ellipse">
+            <a:avLst/>
           </a:prstGeom>
           <a:solidFill>
-            <a:schemeClr val="bg2"/>
+            <a:srgbClr val="2A78D6"/>
           </a:solidFill>
           <a:ln w="12700">
             <a:solidFill>
-              <a:schemeClr val="bg2"/>
+              <a:srgbClr val="2A78D6"/>
             </a:solidFill>
             <a:prstDash val="solid"/>
           </a:ln>
         </p:spPr>
       </p:sp>
+      <p:pic>
+        <p:nvPicPr>
+          <p:cNvPr id="4" name="Traditional methods lead on accuracy icon" descr="preencoded.png">    </p:cNvPr>
+          <p:cNvPicPr>
+            <a:picLocks noChangeAspect="1"/>
+          </p:cNvPicPr>
+          <p:nvPr/>
+        </p:nvPicPr>
+        <p:blipFill>
+          <a:blip r:embed="rId1"/>
+          <a:stretch>
+            <a:fillRect/>
+          </a:stretch>
+        </p:blipFill>
+        <p:spPr>
+          <a:xfrm>
+            <a:off x="724205" y="1638605"/>
+            <a:ext cx="380390" cy="380390"/>
+          </a:xfrm>
+          <a:prstGeom prst="rect">
+            <a:avLst/>
+          </a:prstGeom>
+        </p:spPr>
+      </p:pic>
       <p:sp>
         <p:nvSpPr>
           <p:cNvPr id="5" name="Text 2"/>
@@ -15043,8 +13749,8 @@
         </p:nvSpPr>
         <p:spPr>
           <a:xfrm>
-            <a:off x="7543800" y="1463040"/>
-            <a:ext cx="3931920" cy="685800"/>
+            <a:off x="1463040" y="1463040"/>
+            <a:ext cx="4937760" cy="411480"/>
           </a:xfrm>
           <a:prstGeom prst="rect">
             <a:avLst/>
@@ -15060,17 +13766,14 @@
               <a:buNone/>
             </a:pPr>
             <a:r>
-              <a:rPr lang="en-US" sz="3000" b="1" dirty="0">
+              <a:rPr lang="en-US" sz="1900" b="1" dirty="0">
                 <a:solidFill>
-                  <a:schemeClr val="tx2"/>
+                  <a:schemeClr val="bg1"/>
                 </a:solidFill>
-                <a:latin typeface="Cambria" pitchFamily="34" charset="0"/>
-                <a:ea typeface="Cambria" pitchFamily="34" charset="-122"/>
-                <a:cs typeface="Cambria" pitchFamily="34" charset="-120"/>
               </a:rPr>
-              <a:t>Q* = F⁻¹(margin)</a:t>
+              <a:t>Traditional methods lead on accuracy</a:t>
             </a:r>
-            <a:endParaRPr lang="en-US" sz="3000" dirty="0"/>
+            <a:endParaRPr lang="en-US" sz="1900" dirty="0"/>
           </a:p>
         </p:txBody>
       </p:sp>
@@ -15082,8 +13785,8 @@
         </p:nvSpPr>
         <p:spPr>
           <a:xfrm>
-            <a:off x="7543800" y="2148840"/>
-            <a:ext cx="3931920" cy="548640"/>
+            <a:off x="1463040" y="1901952"/>
+            <a:ext cx="4937760" cy="411480"/>
           </a:xfrm>
           <a:prstGeom prst="rect">
             <a:avLst/>
@@ -15099,27 +13802,381 @@
               <a:buNone/>
             </a:pPr>
             <a:r>
-              <a:rPr lang="en-US" sz="1300" dirty="0">
+              <a:rPr lang="en-US" sz="1400" dirty="0">
                 <a:solidFill>
-                  <a:schemeClr val="tx1"/>
+                  <a:schemeClr val="bg2"/>
                 </a:solidFill>
               </a:rPr>
-              <a:t>Order the demand quantile set by the margin (no salvage value)</a:t>
+              <a:t>LightGBM, AutoETS and their average are the three best</a:t>
             </a:r>
-            <a:endParaRPr lang="en-US" sz="1300" dirty="0"/>
+            <a:endParaRPr lang="en-US" sz="1400" dirty="0"/>
           </a:p>
         </p:txBody>
       </p:sp>
       <p:sp>
         <p:nvSpPr>
-          <p:cNvPr id="7" name="Text 4"/>
+          <p:cNvPr id="7" name="Chronos wins on speed circle"/>
+          <p:cNvSpPr/>
+          <p:nvPr/>
+        </p:nvSpPr>
+        <p:spPr>
+          <a:xfrm>
+            <a:off x="548640" y="2697480"/>
+            <a:ext cx="731520" cy="731520"/>
+          </a:xfrm>
+          <a:prstGeom prst="ellipse">
+            <a:avLst/>
+          </a:prstGeom>
+          <a:solidFill>
+            <a:srgbClr val="EB6834"/>
+          </a:solidFill>
+          <a:ln w="12700">
+            <a:solidFill>
+              <a:srgbClr val="EB6834"/>
+            </a:solidFill>
+            <a:prstDash val="solid"/>
+          </a:ln>
+        </p:spPr>
+      </p:sp>
+      <p:pic>
+        <p:nvPicPr>
+          <p:cNvPr id="8" name="Chronos wins on speed icon" descr="preencoded.png">    </p:cNvPr>
+          <p:cNvPicPr>
+            <a:picLocks noChangeAspect="1"/>
+          </p:cNvPicPr>
+          <p:nvPr/>
+        </p:nvPicPr>
+        <p:blipFill>
+          <a:blip r:embed="rId2"/>
+          <a:stretch>
+            <a:fillRect/>
+          </a:stretch>
+        </p:blipFill>
+        <p:spPr>
+          <a:xfrm>
+            <a:off x="724205" y="2873045"/>
+            <a:ext cx="380390" cy="380390"/>
+          </a:xfrm>
+          <a:prstGeom prst="rect">
+            <a:avLst/>
+          </a:prstGeom>
+        </p:spPr>
+      </p:pic>
+      <p:sp>
+        <p:nvSpPr>
+          <p:cNvPr id="9" name="Text 5"/>
           <p:cNvSpPr txBox="1"/>
           <p:nvPr/>
         </p:nvSpPr>
         <p:spPr>
           <a:xfrm>
-            <a:off x="7315200" y="2926080"/>
-            <a:ext cx="4297680" cy="2834640"/>
+            <a:off x="1463040" y="2697480"/>
+            <a:ext cx="4937760" cy="411480"/>
+          </a:xfrm>
+          <a:prstGeom prst="rect">
+            <a:avLst/>
+          </a:prstGeom>
+          <a:noFill/>
+          <a:ln/>
+        </p:spPr>
+        <p:txBody>
+          <a:bodyPr wrap="square" lIns="0" tIns="0" rIns="0" bIns="0" rtlCol="0" anchor="ctr"/>
+          <a:lstStyle/>
+          <a:p>
+            <a:pPr indent="0" marL="0">
+              <a:buNone/>
+            </a:pPr>
+            <a:r>
+              <a:rPr lang="en-US" sz="1900" b="1" dirty="0">
+                <a:solidFill>
+                  <a:schemeClr val="bg1"/>
+                </a:solidFill>
+              </a:rPr>
+              <a:t>Chronos wins on speed</a:t>
+            </a:r>
+            <a:endParaRPr lang="en-US" sz="1900" dirty="0"/>
+          </a:p>
+        </p:txBody>
+      </p:sp>
+      <p:sp>
+        <p:nvSpPr>
+          <p:cNvPr id="10" name="Text 6"/>
+          <p:cNvSpPr txBox="1"/>
+          <p:nvPr/>
+        </p:nvSpPr>
+        <p:spPr>
+          <a:xfrm>
+            <a:off x="1463040" y="3136392"/>
+            <a:ext cx="4937760" cy="411480"/>
+          </a:xfrm>
+          <a:prstGeom prst="rect">
+            <a:avLst/>
+          </a:prstGeom>
+          <a:noFill/>
+          <a:ln/>
+        </p:spPr>
+        <p:txBody>
+          <a:bodyPr wrap="square" lIns="0" tIns="0" rIns="0" bIns="0" rtlCol="0" anchor="ctr"/>
+          <a:lstStyle/>
+          <a:p>
+            <a:pPr indent="0" marL="0">
+              <a:buNone/>
+            </a:pPr>
+            <a:r>
+              <a:rPr lang="en-US" sz="1400" dirty="0">
+                <a:solidFill>
+                  <a:schemeClr val="bg2"/>
+                </a:solidFill>
+              </a:rPr>
+              <a:t>10 s for all series, no training</a:t>
+            </a:r>
+            <a:endParaRPr lang="en-US" sz="1400" dirty="0"/>
+          </a:p>
+        </p:txBody>
+      </p:sp>
+      <p:sp>
+        <p:nvSpPr>
+          <p:cNvPr id="11" name="Claude matched the best on totals circle"/>
+          <p:cNvSpPr/>
+          <p:nvPr/>
+        </p:nvSpPr>
+        <p:spPr>
+          <a:xfrm>
+            <a:off x="548640" y="3931920"/>
+            <a:ext cx="731520" cy="731520"/>
+          </a:xfrm>
+          <a:prstGeom prst="ellipse">
+            <a:avLst/>
+          </a:prstGeom>
+          <a:solidFill>
+            <a:srgbClr val="4A3AA7"/>
+          </a:solidFill>
+          <a:ln w="12700">
+            <a:solidFill>
+              <a:srgbClr val="4A3AA7"/>
+            </a:solidFill>
+            <a:prstDash val="solid"/>
+          </a:ln>
+        </p:spPr>
+      </p:sp>
+      <p:pic>
+        <p:nvPicPr>
+          <p:cNvPr id="12" name="Claude matched the best on totals icon" descr="preencoded.png">    </p:cNvPr>
+          <p:cNvPicPr>
+            <a:picLocks noChangeAspect="1"/>
+          </p:cNvPicPr>
+          <p:nvPr/>
+        </p:nvPicPr>
+        <p:blipFill>
+          <a:blip r:embed="rId3"/>
+          <a:stretch>
+            <a:fillRect/>
+          </a:stretch>
+        </p:blipFill>
+        <p:spPr>
+          <a:xfrm>
+            <a:off x="724205" y="4107485"/>
+            <a:ext cx="380390" cy="380390"/>
+          </a:xfrm>
+          <a:prstGeom prst="rect">
+            <a:avLst/>
+          </a:prstGeom>
+        </p:spPr>
+      </p:pic>
+      <p:sp>
+        <p:nvSpPr>
+          <p:cNvPr id="13" name="Text 8"/>
+          <p:cNvSpPr txBox="1"/>
+          <p:nvPr/>
+        </p:nvSpPr>
+        <p:spPr>
+          <a:xfrm>
+            <a:off x="1463040" y="3931920"/>
+            <a:ext cx="4937760" cy="411480"/>
+          </a:xfrm>
+          <a:prstGeom prst="rect">
+            <a:avLst/>
+          </a:prstGeom>
+          <a:noFill/>
+          <a:ln/>
+        </p:spPr>
+        <p:txBody>
+          <a:bodyPr wrap="square" lIns="0" tIns="0" rIns="0" bIns="0" rtlCol="0" anchor="ctr"/>
+          <a:lstStyle/>
+          <a:p>
+            <a:pPr indent="0" marL="0">
+              <a:buNone/>
+            </a:pPr>
+            <a:r>
+              <a:rPr lang="en-US" sz="1900" b="1" dirty="0">
+                <a:solidFill>
+                  <a:schemeClr val="bg1"/>
+                </a:solidFill>
+              </a:rPr>
+              <a:t>Claude matched the best on totals</a:t>
+            </a:r>
+            <a:endParaRPr lang="en-US" sz="1900" dirty="0"/>
+          </a:p>
+        </p:txBody>
+      </p:sp>
+      <p:sp>
+        <p:nvSpPr>
+          <p:cNvPr id="14" name="Text 9"/>
+          <p:cNvSpPr txBox="1"/>
+          <p:nvPr/>
+        </p:nvSpPr>
+        <p:spPr>
+          <a:xfrm>
+            <a:off x="1463040" y="4370832"/>
+            <a:ext cx="4937760" cy="411480"/>
+          </a:xfrm>
+          <a:prstGeom prst="rect">
+            <a:avLst/>
+          </a:prstGeom>
+          <a:noFill/>
+          <a:ln/>
+        </p:spPr>
+        <p:txBody>
+          <a:bodyPr wrap="square" lIns="0" tIns="0" rIns="0" bIns="0" rtlCol="0" anchor="ctr"/>
+          <a:lstStyle/>
+          <a:p>
+            <a:pPr indent="0" marL="0">
+              <a:buNone/>
+            </a:pPr>
+            <a:r>
+              <a:rPr lang="en-US" sz="1400" dirty="0">
+                <a:solidFill>
+                  <a:schemeClr val="bg2"/>
+                </a:solidFill>
+              </a:rPr>
+              <a:t>Promising, but tested on 112 series only</a:t>
+            </a:r>
+            <a:endParaRPr lang="en-US" sz="1400" dirty="0"/>
+          </a:p>
+        </p:txBody>
+      </p:sp>
+      <p:sp>
+        <p:nvSpPr>
+          <p:cNvPr id="15" name="limitations card"/>
+          <p:cNvSpPr/>
+          <p:nvPr/>
+        </p:nvSpPr>
+        <p:spPr>
+          <a:xfrm>
+            <a:off x="6675120" y="1371600"/>
+            <a:ext cx="4937760" cy="4572000"/>
+          </a:xfrm>
+          <a:prstGeom prst="roundRect">
+            <a:avLst>
+              <a:gd name="adj" fmla="val 2400"/>
+            </a:avLst>
+          </a:prstGeom>
+          <a:solidFill>
+            <a:srgbClr val="2A3B55"/>
+          </a:solidFill>
+          <a:ln w="12700">
+            <a:solidFill>
+              <a:srgbClr val="2A3B55"/>
+            </a:solidFill>
+            <a:prstDash val="solid"/>
+          </a:ln>
+        </p:spPr>
+      </p:sp>
+      <p:sp>
+        <p:nvSpPr>
+          <p:cNvPr id="16" name="limitations circle"/>
+          <p:cNvSpPr/>
+          <p:nvPr/>
+        </p:nvSpPr>
+        <p:spPr>
+          <a:xfrm>
+            <a:off x="6949440" y="1600200"/>
+            <a:ext cx="594360" cy="594360"/>
+          </a:xfrm>
+          <a:prstGeom prst="ellipse">
+            <a:avLst/>
+          </a:prstGeom>
+          <a:solidFill>
+            <a:srgbClr val="F2B33D"/>
+          </a:solidFill>
+          <a:ln w="12700">
+            <a:solidFill>
+              <a:srgbClr val="F2B33D"/>
+            </a:solidFill>
+            <a:prstDash val="solid"/>
+          </a:ln>
+        </p:spPr>
+      </p:sp>
+      <p:pic>
+        <p:nvPicPr>
+          <p:cNvPr id="17" name="limitations icon" descr="preencoded.png">    </p:cNvPr>
+          <p:cNvPicPr>
+            <a:picLocks noChangeAspect="1"/>
+          </p:cNvPicPr>
+          <p:nvPr/>
+        </p:nvPicPr>
+        <p:blipFill>
+          <a:blip r:embed="rId4"/>
+          <a:stretch>
+            <a:fillRect/>
+          </a:stretch>
+        </p:blipFill>
+        <p:spPr>
+          <a:xfrm>
+            <a:off x="7092086" y="1742846"/>
+            <a:ext cx="309067" cy="309067"/>
+          </a:xfrm>
+          <a:prstGeom prst="rect">
+            <a:avLst/>
+          </a:prstGeom>
+        </p:spPr>
+      </p:pic>
+      <p:sp>
+        <p:nvSpPr>
+          <p:cNvPr id="18" name="Text 12"/>
+          <p:cNvSpPr txBox="1"/>
+          <p:nvPr/>
+        </p:nvSpPr>
+        <p:spPr>
+          <a:xfrm>
+            <a:off x="7680960" y="1600200"/>
+            <a:ext cx="3657600" cy="594360"/>
+          </a:xfrm>
+          <a:prstGeom prst="rect">
+            <a:avLst/>
+          </a:prstGeom>
+          <a:noFill/>
+          <a:ln/>
+        </p:spPr>
+        <p:txBody>
+          <a:bodyPr wrap="square" lIns="0" tIns="0" rIns="0" bIns="0" rtlCol="0" anchor="ctr"/>
+          <a:lstStyle/>
+          <a:p>
+            <a:pPr indent="0" marL="0">
+              <a:buNone/>
+            </a:pPr>
+            <a:r>
+              <a:rPr lang="en-US" sz="1900" b="1" dirty="0">
+                <a:solidFill>
+                  <a:schemeClr val="bg1"/>
+                </a:solidFill>
+              </a:rPr>
+              <a:t>Limitations</a:t>
+            </a:r>
+            <a:endParaRPr lang="en-US" sz="1900" dirty="0"/>
+          </a:p>
+        </p:txBody>
+      </p:sp>
+      <p:sp>
+        <p:nvSpPr>
+          <p:cNvPr id="19" name="Text 13"/>
+          <p:cNvSpPr txBox="1"/>
+          <p:nvPr/>
+        </p:nvSpPr>
+        <p:spPr>
+          <a:xfrm>
+            <a:off x="6949440" y="2377440"/>
+            <a:ext cx="4480560" cy="3383280"/>
           </a:xfrm>
           <a:prstGeom prst="rect">
             <a:avLst/>
@@ -15139,14 +14196,14 @@
               <a:buChar char="•"/>
             </a:pPr>
             <a:r>
-              <a:rPr lang="en-US" sz="1500" dirty="0">
+              <a:rPr lang="en-US" sz="1400" dirty="0">
                 <a:solidFill>
-                  <a:schemeClr val="tx1"/>
+                  <a:schemeClr val="bg2"/>
                 </a:solidFill>
               </a:rPr>
-              <a:t>20% margin: wasted stock costs more, so order low (P20 = 2 units)</a:t>
+              <a:t>One 28-day test window: close rankings could flip in another month.</a:t>
             </a:r>
-            <a:endParaRPr lang="en-US" sz="1500" dirty="0"/>
+            <a:endParaRPr lang="en-US" sz="1400" dirty="0"/>
           </a:p>
           <a:p>
             <a:pPr marL="342900" indent="-342900">
@@ -15157,14 +14214,14 @@
               <a:buChar char="•"/>
             </a:pPr>
             <a:r>
-              <a:rPr lang="en-US" sz="1500" dirty="0">
+              <a:rPr lang="en-US" sz="1400" dirty="0">
                 <a:solidFill>
-                  <a:schemeClr val="tx1"/>
+                  <a:schemeClr val="bg2"/>
                 </a:solidFill>
               </a:rPr>
-              <a:t>80% margin: a lost sale costs more, so order high (P80 = 7 units)</a:t>
+              <a:t>Claude: 112 series only; the blind test can't fully rule out contamination.</a:t>
             </a:r>
-            <a:endParaRPr lang="en-US" sz="1500" dirty="0"/>
+            <a:endParaRPr lang="en-US" sz="1400" dirty="0"/>
           </a:p>
           <a:p>
             <a:pPr marL="342900" indent="-342900">
@@ -15175,32 +14232,14 @@
               <a:buChar char="•"/>
             </a:pPr>
             <a:r>
-              <a:rPr lang="en-US" sz="1500" dirty="0">
+              <a:rPr lang="en-US" sz="1400" dirty="0">
                 <a:solidFill>
-                  <a:schemeClr val="tx1"/>
+                  <a:schemeClr val="bg2"/>
                 </a:solidFill>
               </a:rPr>
-              <a:t>Needs the full demand distribution, not just the point forecast</a:t>
+              <a:t>Accuracy is not the business goal. Ordering is a newsvendor problem: running out costs the margin (underage), unsold food costs its price (overage). The best order is a margin-set quantile, not the forecast, and our accuracy metrics weigh both errors equally.</a:t>
             </a:r>
-            <a:endParaRPr lang="en-US" sz="1500" dirty="0"/>
-          </a:p>
-          <a:p>
-            <a:pPr marL="342900" indent="-342900">
-              <a:spcAft>
-                <a:spcPts val="800"/>
-              </a:spcAft>
-              <a:buSzPct val="100000"/>
-              <a:buChar char="•"/>
-            </a:pPr>
-            <a:r>
-              <a:rPr lang="en-US" sz="1500" b="1" dirty="0">
-                <a:solidFill>
-                  <a:schemeClr val="tx1"/>
-                </a:solidFill>
-              </a:rPr>
-              <a:t>Our test: more accurate forecasts earned significantly more only at an 80% margin</a:t>
-            </a:r>
-            <a:endParaRPr lang="en-US" sz="1500" dirty="0"/>
+            <a:endParaRPr lang="en-US" sz="1400" dirty="0"/>
           </a:p>
         </p:txBody>
       </p:sp>
@@ -15234,7 +14273,7 @@
             <a:lvl1pPr>
               <a:defRPr sz="1000">
                 <a:solidFill>
-                  <a:schemeClr val="tx2"/>
+                  <a:schemeClr val="bg2"/>
                 </a:solidFill>
               </a:defRPr>
             </a:lvl1pPr>
@@ -15306,7 +14345,7 @@
                   <a:schemeClr val="tx2"/>
                 </a:solidFill>
               </a:rPr>
-              <a:t>Demo: Shelf Signal v2 dashboard</a:t>
+              <a:t>Demo: Shelf Signal dashboard</a:t>
             </a:r>
             <a:endParaRPr lang="en-US" sz="3400" dirty="0"/>
           </a:p>
@@ -15421,7 +14460,7 @@
                 <a:solidFill>
                   <a:srgbClr val="2A78D6"/>
                 </a:solidFill>
-                <a:hlinkClick r:id="rId4" invalidUrl="" action="" tgtFrame="" tooltip="Opens the local copy" history="1" highlightClick="0" endSnd="0">
+                <a:hlinkClick r:id="rId4" invalidUrl="" action="" tgtFrame="" tooltip="" history="1" highlightClick="0" endSnd="0">
                   <a:extLst>
                     <a:ext uri="{A12FA001-AC4F-418D-AE19-62706E023703}">
                       <ahyp:hlinkClr xmlns:ahyp="http://schemas.microsoft.com/office/drawing/2018/hyperlinkcolor" val="tx"/>
@@ -15429,7 +14468,7 @@
                   </a:extLst>
                 </a:hlinkClick>
               </a:rPr>
-              <a:t>Offline copy (docs/index.html)</a:t>
+              <a:t>shihan-2002.github.io/shelf-signal-dashboard</a:t>
             </a:r>
             <a:endParaRPr lang="en-US" sz="1300" dirty="0"/>
           </a:p>
@@ -15437,13 +14476,13 @@
       </p:sp>
       <p:sp>
         <p:nvSpPr>
-          <p:cNvPr id="6" name="Forecast explorer: pick a series and models circle"/>
+          <p:cNvPr id="6" name="Forecast explorer circle"/>
           <p:cNvSpPr/>
           <p:nvPr/>
         </p:nvSpPr>
         <p:spPr>
           <a:xfrm>
-            <a:off x="7680960" y="1508760"/>
+            <a:off x="7680960" y="1463040"/>
             <a:ext cx="685800" cy="685800"/>
           </a:xfrm>
           <a:prstGeom prst="ellipse">
@@ -15462,7 +14501,7 @@
       </p:sp>
       <p:pic>
         <p:nvPicPr>
-          <p:cNvPr id="7" name="Forecast explorer: pick a series and models icon" descr="preencoded.png">    </p:cNvPr>
+          <p:cNvPr id="7" name="Forecast explorer icon" descr="preencoded.png">    </p:cNvPr>
           <p:cNvPicPr>
             <a:picLocks noChangeAspect="1"/>
           </p:cNvPicPr>
@@ -15476,7 +14515,7 @@
         </p:blipFill>
         <p:spPr>
           <a:xfrm>
-            <a:off x="7845552" y="1673352"/>
+            <a:off x="7845552" y="1627632"/>
             <a:ext cx="356616" cy="356616"/>
           </a:xfrm>
           <a:prstGeom prst="rect">
@@ -15493,7 +14532,7 @@
         <p:spPr>
           <a:xfrm>
             <a:off x="8549640" y="1417320"/>
-            <a:ext cx="3108960" cy="502920"/>
+            <a:ext cx="3108960" cy="411480"/>
           </a:xfrm>
           <a:prstGeom prst="rect">
             <a:avLst/>
@@ -15509,14 +14548,14 @@
               <a:buNone/>
             </a:pPr>
             <a:r>
-              <a:rPr lang="en-US" sz="1600" b="1" dirty="0">
+              <a:rPr lang="en-US" sz="1700" b="1" dirty="0">
                 <a:solidFill>
                   <a:schemeClr val="tx2"/>
                 </a:solidFill>
               </a:rPr>
-              <a:t>1. Forecast explorer: pick a series and models</a:t>
+              <a:t>Forecast explorer</a:t>
             </a:r>
-            <a:endParaRPr lang="en-US" sz="1600" dirty="0"/>
+            <a:endParaRPr lang="en-US" sz="1700" dirty="0"/>
           </a:p>
         </p:txBody>
       </p:sp>
@@ -15528,7 +14567,7 @@
         </p:nvSpPr>
         <p:spPr>
           <a:xfrm>
-            <a:off x="8549640" y="1965960"/>
+            <a:off x="8549640" y="1856232"/>
             <a:ext cx="3108960" cy="640080"/>
           </a:xfrm>
           <a:prstGeom prst="rect">
@@ -15550,7 +14589,7 @@
                   <a:schemeClr val="tx1"/>
                 </a:solidFill>
               </a:rPr>
-              <a:t>Replay forecasts against what actually sold</a:t>
+              <a:t>One store's department: every model against actual sales</a:t>
             </a:r>
             <a:endParaRPr lang="en-US" sz="1400" dirty="0"/>
           </a:p>
@@ -15558,13 +14597,13 @@
       </p:sp>
       <p:sp>
         <p:nvSpPr>
-          <p:cNvPr id="10" name="Order planner: change the margin circle"/>
+          <p:cNvPr id="10" name="AI lab circle"/>
           <p:cNvSpPr/>
           <p:nvPr/>
         </p:nvSpPr>
         <p:spPr>
           <a:xfrm>
-            <a:off x="7680960" y="2834640"/>
+            <a:off x="7680960" y="2651760"/>
             <a:ext cx="685800" cy="685800"/>
           </a:xfrm>
           <a:prstGeom prst="ellipse">
@@ -15583,7 +14622,7 @@
       </p:sp>
       <p:pic>
         <p:nvPicPr>
-          <p:cNvPr id="11" name="Order planner: change the margin icon" descr="preencoded.png">    </p:cNvPr>
+          <p:cNvPr id="11" name="AI lab icon" descr="preencoded.png">    </p:cNvPr>
           <p:cNvPicPr>
             <a:picLocks noChangeAspect="1"/>
           </p:cNvPicPr>
@@ -15597,7 +14636,7 @@
         </p:blipFill>
         <p:spPr>
           <a:xfrm>
-            <a:off x="7845552" y="2999232"/>
+            <a:off x="7845552" y="2816352"/>
             <a:ext cx="356616" cy="356616"/>
           </a:xfrm>
           <a:prstGeom prst="rect">
@@ -15613,8 +14652,8 @@
         </p:nvSpPr>
         <p:spPr>
           <a:xfrm>
-            <a:off x="8549640" y="2743200"/>
-            <a:ext cx="3108960" cy="502920"/>
+            <a:off x="8549640" y="2606040"/>
+            <a:ext cx="3108960" cy="411480"/>
           </a:xfrm>
           <a:prstGeom prst="rect">
             <a:avLst/>
@@ -15630,14 +14669,14 @@
               <a:buNone/>
             </a:pPr>
             <a:r>
-              <a:rPr lang="en-US" sz="1600" b="1" dirty="0">
+              <a:rPr lang="en-US" sz="1700" b="1" dirty="0">
                 <a:solidFill>
                   <a:schemeClr val="tx2"/>
                 </a:solidFill>
               </a:rPr>
-              <a:t>2. Order planner: change the margin</a:t>
+              <a:t>AI lab</a:t>
             </a:r>
-            <a:endParaRPr lang="en-US" sz="1600" dirty="0"/>
+            <a:endParaRPr lang="en-US" sz="1700" dirty="0"/>
           </a:p>
         </p:txBody>
       </p:sp>
@@ -15649,7 +14688,7 @@
         </p:nvSpPr>
         <p:spPr>
           <a:xfrm>
-            <a:off x="8549640" y="3291840"/>
+            <a:off x="8549640" y="3044952"/>
             <a:ext cx="3108960" cy="640080"/>
           </a:xfrm>
           <a:prstGeom prst="rect">
@@ -15671,7 +14710,7 @@
                   <a:schemeClr val="tx1"/>
                 </a:solidFill>
               </a:rPr>
-              <a:t>Same forecast; the order moves from P20 to P80</a:t>
+              <a:t>Claude's own reasoning, and the named-vs-blind test</a:t>
             </a:r>
             <a:endParaRPr lang="en-US" sz="1400" dirty="0"/>
           </a:p>
@@ -15679,13 +14718,13 @@
       </p:sp>
       <p:sp>
         <p:nvSpPr>
-          <p:cNvPr id="14" name="Profit scored with actual sales circle"/>
+          <p:cNvPr id="14" name="Order planner circle"/>
           <p:cNvSpPr/>
           <p:nvPr/>
         </p:nvSpPr>
         <p:spPr>
           <a:xfrm>
-            <a:off x="7680960" y="4160520"/>
+            <a:off x="7680960" y="3840480"/>
             <a:ext cx="685800" cy="685800"/>
           </a:xfrm>
           <a:prstGeom prst="ellipse">
@@ -15704,7 +14743,7 @@
       </p:sp>
       <p:pic>
         <p:nvPicPr>
-          <p:cNvPr id="15" name="Profit scored with actual sales icon" descr="preencoded.png">    </p:cNvPr>
+          <p:cNvPr id="15" name="Order planner icon" descr="preencoded.png">    </p:cNvPr>
           <p:cNvPicPr>
             <a:picLocks noChangeAspect="1"/>
           </p:cNvPicPr>
@@ -15718,7 +14757,7 @@
         </p:blipFill>
         <p:spPr>
           <a:xfrm>
-            <a:off x="7845552" y="4325112"/>
+            <a:off x="7845552" y="4005072"/>
             <a:ext cx="356616" cy="356616"/>
           </a:xfrm>
           <a:prstGeom prst="rect">
@@ -15734,8 +14773,8 @@
         </p:nvSpPr>
         <p:spPr>
           <a:xfrm>
-            <a:off x="8549640" y="4069080"/>
-            <a:ext cx="3108960" cy="502920"/>
+            <a:off x="8549640" y="3794760"/>
+            <a:ext cx="3108960" cy="411480"/>
           </a:xfrm>
           <a:prstGeom prst="rect">
             <a:avLst/>
@@ -15751,14 +14790,14 @@
               <a:buNone/>
             </a:pPr>
             <a:r>
-              <a:rPr lang="en-US" sz="1600" b="1" dirty="0">
+              <a:rPr lang="en-US" sz="1700" b="1" dirty="0">
                 <a:solidFill>
                   <a:schemeClr val="tx2"/>
                 </a:solidFill>
               </a:rPr>
-              <a:t>3. Profit scored with actual sales</a:t>
+              <a:t>Order planner</a:t>
             </a:r>
-            <a:endParaRPr lang="en-US" sz="1600" dirty="0"/>
+            <a:endParaRPr lang="en-US" sz="1700" dirty="0"/>
           </a:p>
         </p:txBody>
       </p:sp>
@@ -15770,7 +14809,7 @@
         </p:nvSpPr>
         <p:spPr>
           <a:xfrm>
-            <a:off x="8549640" y="4617720"/>
+            <a:off x="8549640" y="4233672"/>
             <a:ext cx="3108960" cy="640080"/>
           </a:xfrm>
           <a:prstGeom prst="rect">
@@ -15792,7 +14831,7 @@
                   <a:schemeClr val="tx1"/>
                 </a:solidFill>
               </a:rPr>
-              <a:t>Actuals are used only after the fact</a:t>
+              <a:t>Change the margin: the order moves between P20 and P80</a:t>
             </a:r>
             <a:endParaRPr lang="en-US" sz="1400" dirty="0"/>
           </a:p>
@@ -15806,8 +14845,8 @@
         </p:nvSpPr>
         <p:spPr>
           <a:xfrm>
-            <a:off x="7680960" y="5440680"/>
-            <a:ext cx="3931920" cy="548640"/>
+            <a:off x="7680960" y="5074920"/>
+            <a:ext cx="3931920" cy="640080"/>
           </a:xfrm>
           <a:prstGeom prst="rect">
             <a:avLst/>
@@ -15816,21 +14855,24 @@
           <a:ln/>
         </p:spPr>
         <p:txBody>
-          <a:bodyPr wrap="square" lIns="0" tIns="0" rIns="0" bIns="0" rtlCol="0" anchor="t"/>
+          <a:bodyPr wrap="square" lIns="0" tIns="0" rIns="0" bIns="0" rtlCol="0" anchor="ctr"/>
           <a:lstStyle/>
           <a:p>
             <a:pPr indent="0" marL="0">
               <a:buNone/>
             </a:pPr>
             <a:r>
-              <a:rPr lang="en-US" sz="1200" i="1" dirty="0">
+              <a:rPr lang="en-US" sz="2600" b="1" dirty="0">
                 <a:solidFill>
-                  <a:srgbClr val="6B6A66"/>
+                  <a:srgbClr val="1B2A41"/>
                 </a:solidFill>
+                <a:latin typeface="Cambria" pitchFamily="34" charset="0"/>
+                <a:ea typeface="Cambria" pitchFamily="34" charset="-122"/>
+                <a:cs typeface="Cambria" pitchFamily="34" charset="-120"/>
               </a:rPr>
-              <a:t>Click the screenshot or the link to switch to the browser; Cmd+Tab back to the slides. Backup: screen recording.</a:t>
+              <a:t>Thank you — questions?</a:t>
             </a:r>
-            <a:endParaRPr lang="en-US" sz="1200" dirty="0"/>
+            <a:endParaRPr lang="en-US" sz="2600" dirty="0"/>
           </a:p>
         </p:txBody>
       </p:sp>

</xml_diff>

<commit_message>
Fuller speaker notes (~11 min, optional lines marked)
Co-Authored-By: Claude Opus 5.5 <noreply@anthropic.com>
</commit_message>
<xml_diff>
--- a/presentation/Group3_Forecasting_Presentation.pptx
+++ b/presentation/Group3_Forecasting_Presentation.pptx
@@ -115,26 +115,26 @@
   <p:extLst>
     <p:ext uri="{521415D9-36F7-43E2-AB2F-B90AF26B5E84}">
       <p14:sectionLst xmlns:p14="http://schemas.microsoft.com/office/powerpoint/2010/main">
-        <p14:section name="Question and data" id="{91872f20-acaa-c568-9ba0-491dace308b5}">
+        <p14:section name="Question and data" id="{7411678b-17e3-484f-d00b-e15c19a65a25}">
           <p14:sldIdLst>
             <p14:sldId id="256"/>
             <p14:sldId id="257"/>
           </p14:sldIdLst>
         </p14:section>
-        <p14:section name="Models and results" id="{9abb2d2b-9f68-a9ee-37b7-4dd6f8f50744}">
+        <p14:section name="Models and results" id="{7906edb7-a6ec-96c0-d117-9cc6e06930b8}">
           <p14:sldIdLst>
             <p14:sldId id="258"/>
             <p14:sldId id="259"/>
             <p14:sldId id="260"/>
           </p14:sldIdLst>
         </p14:section>
-        <p14:section name="LLM experiment" id="{05c29ca8-b7f7-d474-2a2a-97e8eeb51a23}">
+        <p14:section name="LLM experiment" id="{74cc1d32-fbc6-7896-cc2f-8ff5e038e5e2}">
           <p14:sldIdLst>
             <p14:sldId id="261"/>
             <p14:sldId id="262"/>
           </p14:sldIdLst>
         </p14:section>
-        <p14:section name="Answer and demo" id="{d1142097-cac1-c321-0056-9b35a60d72e5}">
+        <p14:section name="Answer and demo" id="{c3d8b5ba-3947-b996-2a53-ca602d5cc296}">
           <p14:sldIdLst>
             <p14:sldId id="263"/>
             <p14:sldId id="264"/>
@@ -5649,8 +5649,8 @@
           <a:p>
             <a:r>
               <a:rPr lang="en-US" dirty="0"/>
-              <a:t>SPEAKER 1 (0:40)
-Good afternoon, we're Group 3. A retail forecast has three jobs: be accurate, be cheap and fast enough to run every day for thousands of products, and support good stocking decisions. In Walmart's M5 forecasting competition, LightGBM, a machine-learning method, dominated. Since then, AI models pre-trained on huge datasets can forecast with no training at all. So we ask: can these AI foundation models beat traditional statistical and machine-learning methods, on accuracy and on efficiency?
+              <a:t>SPEAKER 1 (0:45)
+Good afternoon, we're Group 3. A retail forecast has three jobs: be accurate, be cheap and fast enough to run every day for thousands of products, and support good stocking decisions. In Walmart's M5 forecasting competition, LightGBM, a machine-learning method, dominated the leaderboard and became the industry default. Since then, AI foundation models, pre-trained on huge datasets, can forecast a product they have never seen, with no training at all. So we ask: can these AI models beat traditional statistical and machine-learning methods, on accuracy and on efficiency?
 TRANSITION: Here is our data and how we tested.</a:t>
             </a:r>
             <a:endParaRPr lang="en-US" dirty="0"/>
@@ -5739,9 +5739,10 @@
           <a:p>
             <a:r>
               <a:rPr lang="en-US" dirty="0"/>
-              <a:t>SPEAKER 1 (1:00)
-We used Walmart's M5 data: all 1,437 food items in four California stores, so 5,748 daily series, each one item in one store.
+              <a:t>SPEAKER 1 (1:20)
+We used Walmart's M5 data: all 1,437 food items in four California stores, so 5,748 daily series, each one item in one store, from 2011 to 2016.
 Every model trains on data up to May 22, 2016, and forecasts the next 28 days, the official M5 test window, which no model sees. The one model we tuned, LightGBM, was tuned only on the last 28 training days.
+Three features make this data hard. Sales follow a weekly rhythm: weekends sell about 20% above an average day. Food-stamp payment days add about 10%. And demand is sparse: the typical item sells nothing on half of all days.
 We score accuracy with WRMSSE, the competition's own metric: it scales each product's error by how hard it is to forecast and weights it by dollar sales. Lower is better, and below one beats a naive forecast. One caveat up front: this is a single 28-day window.
 TRANSITION: Speaker 2 will introduce the models.</a:t>
             </a:r>
@@ -5831,11 +5832,11 @@
           <a:p>
             <a:r>
               <a:rPr lang="en-US" dirty="0"/>
-              <a:t>SPEAKER 2 (0:50)
+              <a:t>SPEAKER 2 (1:05)
 We compared five models. AutoETS and AutoARIMA are classic time series models: they fit one model to each product's own history, with a weekly cycle.
 LightGBM is the M5 winner's approach: one machine-learning model trained across all products at once, which then predicts each product. It also sees prices, holidays and food-stamp days.
-Chronos is Amazon's pre-trained AI model for time series. It was trained on about 100 billion data points from other domains and forecasts our data zero-shot, with no training. And seasonal naive, 'same weekday last week', is the benchmark.
-Note that the inputs differ: only LightGBM sees prices and the calendar.
+Chronos is Amazon's pre-trained AI model for time series, trained on about 100 billion data points from energy, traffic, weather and more. It was not trained on M5 or on any retail data: the Chronos paper lists M5 as a held-out test set, so this is a true zero-shot test. Seasonal naive, 'same weekday last week', is the benchmark.
+We also test the simplest possible combination: an unweighted average of AutoETS and LightGBM. Note that the inputs differ: only LightGBM sees prices and the calendar.
 TRANSITION: So how accurate were they?</a:t>
             </a:r>
             <a:endParaRPr lang="en-US" dirty="0"/>
@@ -5924,9 +5925,10 @@
           <a:p>
             <a:r>
               <a:rPr lang="en-US" dirty="0"/>
-              <a:t>SPEAKER 2 (0:55)
+              <a:t>SPEAKER 2 (1:05)
 Across all 5,748 series, LightGBM was the most accurate single model, with a WRMSSE of 0.646. AutoETS, a much simpler statistical model, was close behind at 0.661. These two were the only single models to beat the seasonal-naive benchmark at 0.814; AutoARIMA scored 0.89 and Chronos 0.95.
 The best result came from simply averaging AutoETS and LightGBM: 0.604, better than either, with no tuning. The two make different kinds of errors, so averaging cancels part of them. Our teammate's Shelf Signal study found the same thing on a different store and item set.
+(OPTIONAL) The metric matters too. Chronos actually has the lowest MAE of all models but the weakest WRMSSE: its forecasts run about 11% low in total, and WRMSSE punishes errors that add up across products.
 TRANSITION: But the overall score hides an important pattern.</a:t>
             </a:r>
             <a:endParaRPr lang="en-US" dirty="0"/>
@@ -6015,9 +6017,9 @@
           <a:p>
             <a:r>
               <a:rPr lang="en-US" dirty="0"/>
-              <a:t>SPEAKER 2 (0:55)
-The ranking changes with the level. On the left are store and department totals, where LightGBM and AutoETS are far ahead: they capture the shared weekly pattern. AutoARIMA and Chronos forecast each product separately and give nearly flat lines for slow sellers, so their totals miss the weekend peaks.
-On the right, for one item in one store, all models are close. But close is not the same as a statistical tie; we did not formally test those gaps.
+              <a:t>SPEAKER 2 (1:10)
+The ranking changes with the level. On the left are store and department totals, where LightGBM and AutoETS are far ahead: they capture the shared weekly pattern. AutoARIMA and Chronos forecast each product separately and give nearly flat lines for slow sellers, so their totals miss the weekend peaks. Summed to the four-store total, daily error is about 4% for LightGBM and 5% for AutoETS, against about 10% for AutoARIMA and Chronos.
+On the right, for one item in one store, all models are close: each single model is the most accurate on between a fifth and a third of products. But close is not the same as a statistical tie; we did not formally test those gaps.
 On speed, the differences are huge. Chronos forecasts everything in 10 seconds with no training. LightGBM and AutoETS take under a minute and a half; AutoARIMA takes 39 minutes. So Chronos's advantage in our study is speed, while its overall accuracy is weaker.
 TRANSITION: Speaker 3 will cover our experiment with a general-purpose language model.</a:t>
             </a:r>
@@ -6107,10 +6109,11 @@
           <a:p>
             <a:r>
               <a:rPr lang="en-US" dirty="0"/>
-              <a:t>SPEAKER 3 (1:00)
-As an experiment, we also tried Claude, a general-purpose language model. We paste each product's last year of sales into the prompt as text, one row per day, and it returns a 28-day forecast with a short explanation. Running all 5,748 series would cost hundreds of dollars, so we tested a subset: 100 random items and the 12 store-by-department totals, and compared every model on exactly those series.
-On the totals, Claude scored 0.58, level with the AutoETS-plus-LightGBM average and better than any single model. So it matched the best traditional approach, but did not beat it. Note that we also fitted the other models directly on the totals, which is fairer than summing item forecasts. On the 100 items, Claude came third, behind AutoETS and AutoARIMA.
-How is Claude different from Chronos? Both are pre-trained and need no training on our data. But Chronos was trained on numbers and returns quantiles in seconds for free; Claude was trained on text, reads our data as text, explains itself, and costs about six cents per forecast.
+              <a:t>SPEAKER 3 (1:15)
+As an experiment, we also tried Claude, a general-purpose language model. We paste each product's last year of sales into the prompt as text, one row per day, with the same calendar and price information LightGBM sees, and it returns a 28-day forecast with a short explanation. Running all 5,748 series would cost hundreds of dollars, so we tested a subset: 100 random items and the 12 store-by-department totals, for $13.54, and compared every model on exactly those series.
+On the totals, Claude scored 0.58, level with the AutoETS-plus-LightGBM average and better than any single model. So it matched the best traditional approach, but did not beat it. On the 100 items, Claude came third, behind AutoETS and AutoARIMA.
+For fairness, we also fitted the other models directly on the totals instead of summing item forecasts, and that mattered: AutoARIMA improved from 0.90 to 0.64 and Chronos from 0.97 to 0.64. How you build a total matters as much as which model you use.
+How is Claude different from Chronos? Both are pre-trained and need no training on our data. But Chronos was trained on numbers, returns quantiles in seconds for free, and gives the same answer every time. Claude was trained on text, reads our data as text, explains itself, costs about six cents per forecast, and may answer slightly differently on a rerun.
 TRANSITION: Using a language model also brings specific risks.</a:t>
             </a:r>
             <a:endParaRPr lang="en-US" dirty="0"/>
@@ -6199,9 +6202,9 @@
           <a:p>
             <a:r>
               <a:rPr lang="en-US" dirty="0"/>
-              <a:t>SPEAKER 3 (0:50)
+              <a:t>SPEAKER 3 (0:55)
 Forecasting with a language model has four risks. First, contamination: the M5 data is public, so Claude may have seen it in training. Our safeguard was the named-versus-blind test: we removed product names, dates and the year. Accuracy didn't change, 0.579 versus 0.583, so real names gave it no advantage.
-Second, outputs can vary between runs; we fixed the prompt and model and saved every response. Third, cost and scale, which is why we used a subset and compared every model on the same subset. Fourth, malformed answers; we required a fixed format and checked every response.
+Second, outputs can vary between runs; we fixed the prompt and model and saved every response. Third, cost and scale, which is why we used a subset and compared every model on the same subset. Fourth, malformed answers; we required a fixed format and checked every response, and none of the 224 calls failed.
 But be clear about the limit: the blind test reduces identity cues; it cannot guarantee contamination is excluded, because the sales pattern itself could still be recognised.
 TRANSITION: Speaker 4 will wrap up and show the dashboard.</a:t>
             </a:r>
@@ -6291,11 +6294,14 @@
           <a:p>
             <a:r>
               <a:rPr lang="en-US" dirty="0"/>
-              <a:t>SPEAKER 4 (1:20)
+              <a:t>SPEAKER 4 (2:00)
 So, can AI foundation models beat traditional methods? Our answer: not yet on accuracy, yes on speed. LightGBM, AutoETS and their simple average were the three most accurate. Chronos was the clear winner on speed: ten seconds, no training. And Claude matched the best traditional approach on store totals, but on only 112 series.
-Three limitations. First, we tested one 28-day window, so close rankings could flip in another month. Second, Claude was tested on a subset, and our blind test can't fully rule out that it saw this public data.
-Third, and most important for a business: accuracy isn't the real goal. Ordering stock is a newsvendor problem with two different costs. If you order too little, you lose the margin on every sale you miss; that's the underage cost. If you order too much, unsold food is wasted at its cost; that's the overage cost. Because those costs depend on the margin, the best order isn't the forecast itself but a quantile of demand. Our accuracy metrics treat over- and under-forecasting the same, so they don't capture this. Let me show you in our dashboard.
-TRANSITION: switch to the demo.</a:t>
+Our results have limits. First, we tested one 28-day window, so close rankings could flip in another month. (OPTIONAL) Our teammate's Shelf Signal study, which tested several windows, saw exactly this: gradient-boosted trees beat ETS in one window and lost in the next. Second, Claude was tested on a subset, and our blind test can't fully rule out that it saw this public data. Third, sales are not demand: when a shelf is empty, sales show zero even if customers wanted the product.
+And the most important limitation for a business: accuracy isn't the real goal. Ordering stock is a newsvendor problem with two different costs. If you order too little, you lose the margin on every sale you miss; that's the underage cost. If you order too much, unsold food is wasted at its cost; that's the overage cost. Because those costs depend on the margin, the best order isn't the forecast itself but a quantile of demand, and our accuracy metrics treat over- and under-forecasting the same. When we turned each model's forecasts into orders, the profit differences at typical margins were within chance; only at an 80% margin, where running out is expensive, did the more accurate LightGBM earn significantly more.
+So our recommendation: average a statistical model like AutoETS with LightGBM, use Chronos where speed or a lack of training data matters, and choose models on the metric that matches the business decision. Our next step is a rolling backtest over several windows.
+(OPTIONAL) On AI tools: besides testing Chronos and Claude as forecasters, we used Claude Code to help build the pipeline and the dashboard, and we checked its work; every number comes from our own code.
+Let me show you the business problem in our dashboard.
+TRANSITION: click the screenshot on the next slide.</a:t>
             </a:r>
             <a:endParaRPr lang="en-US" dirty="0"/>
           </a:p>
@@ -6383,12 +6389,12 @@
           <a:p>
             <a:r>
               <a:rPr lang="en-US" dirty="0"/>
-              <a:t>SPEAKER 4 (1:30 demo + 0:10 close)
+              <a:t>SPEAKER 4 (1:30 demo + 0:15 close)
 [Click the screenshot to open the dashboard. If the internet fails, play the screen recording.]
 (0:00-0:20) FORECAST EXPLORER. This is Shelf Signal, which extends our teammate's original dashboard with all our models. Here's one store's department total: the black line is actual sales, and you can switch each model on and off. The ensemble and LightGBM follow the weekend peaks; Chronos runs low.
 (0:20-0:40) AI LAB. Here Claude explains its own forecast in plain English, and this chart is the named-versus-blind test: every point sits on the diagonal, so real names gave it no advantage.
 (0:40-1:30) ORDER PLANNER. Now the business problem. For this item, the model forecasts about eight units for the day. At a 50% margin, the best order is the median of demand. Drop the margin to 20%: a wasted unit now costs four times a lost sale, so the order falls. Raise it to 80%: a lost sale costs four times a wasted unit, so we order more. Same forecast, different decision. The table scores every model's orders against actual sales: the profit ranking isn't the same as the accuracy ranking, and at typical margins the differences are small.
-(close) That's our project. Thank you, and we're happy to take questions.
+(close) That's our project: traditional methods still lead on accuracy, AI wins on speed, and the right order depends on your costs. Thank you, and we're happy to take questions.
 [Press Cmd+Tab to return to the slides for Q&amp;A.]</a:t>
             </a:r>
             <a:endParaRPr lang="en-US" dirty="0"/>

</xml_diff>

<commit_message>
Speaker notes: Claude forecasts were sent by code through the API
Co-Authored-By: Claude Opus 5.5 <noreply@anthropic.com>
</commit_message>
<xml_diff>
--- a/presentation/Group3_Forecasting_Presentation.pptx
+++ b/presentation/Group3_Forecasting_Presentation.pptx
@@ -115,26 +115,26 @@
   <p:extLst>
     <p:ext uri="{521415D9-36F7-43E2-AB2F-B90AF26B5E84}">
       <p14:sectionLst xmlns:p14="http://schemas.microsoft.com/office/powerpoint/2010/main">
-        <p14:section name="Question and data" id="{7411678b-17e3-484f-d00b-e15c19a65a25}">
+        <p14:section name="Question and data" id="{22bc92b0-43a4-17ca-8d90-2ba475c26c2d}">
           <p14:sldIdLst>
             <p14:sldId id="256"/>
             <p14:sldId id="257"/>
           </p14:sldIdLst>
         </p14:section>
-        <p14:section name="Models and results" id="{7906edb7-a6ec-96c0-d117-9cc6e06930b8}">
+        <p14:section name="Models and results" id="{847a8879-b418-6c3b-d34b-da653e5ab700}">
           <p14:sldIdLst>
             <p14:sldId id="258"/>
             <p14:sldId id="259"/>
             <p14:sldId id="260"/>
           </p14:sldIdLst>
         </p14:section>
-        <p14:section name="LLM experiment" id="{74cc1d32-fbc6-7896-cc2f-8ff5e038e5e2}">
+        <p14:section name="LLM experiment" id="{770c0812-e405-aeda-7422-af7dbef1db6b}">
           <p14:sldIdLst>
             <p14:sldId id="261"/>
             <p14:sldId id="262"/>
           </p14:sldIdLst>
         </p14:section>
-        <p14:section name="Answer and demo" id="{c3d8b5ba-3947-b996-2a53-ca602d5cc296}">
+        <p14:section name="Answer and demo" id="{be8db08f-5d42-ca15-7636-57af16111b03}">
           <p14:sldIdLst>
             <p14:sldId id="263"/>
             <p14:sldId id="264"/>
@@ -6110,7 +6110,7 @@
             <a:r>
               <a:rPr lang="en-US" dirty="0"/>
               <a:t>SPEAKER 3 (1:15)
-As an experiment, we also tried Claude, a general-purpose language model. We paste each product's last year of sales into the prompt as text, one row per day, with the same calendar and price information LightGBM sees, and it returns a 28-day forecast with a short explanation. Running all 5,748 series would cost hundreds of dollars, so we tested a subset: 100 random items and the 12 store-by-department totals, for $13.54, and compared every model on exactly those series.
+As an experiment, we also tried Claude, a general-purpose language model. Our code sends each product's last year of sales to Claude through its API, as text, one row per day, with the same calendar and price information LightGBM sees, and it returns a 28-day forecast with a short explanation. Running all 5,748 series would cost hundreds of dollars, so we tested a subset: 100 random items and the 12 store-by-department totals, for $13.54, and compared every model on exactly those series.
 On the totals, Claude scored 0.58, level with the AutoETS-plus-LightGBM average and better than any single model. So it matched the best traditional approach, but did not beat it. On the 100 items, Claude came third, behind AutoETS and AutoARIMA.
 For fairness, we also fitted the other models directly on the totals instead of summing item forecasts, and that mattered: AutoARIMA improved from 0.90 to 0.64 and Chronos from 0.97 to 0.64. How you build a total matters as much as which model you use.
 How is Claude different from Chronos? Both are pre-trained and need no training on our data. But Chronos was trained on numbers, returns quantiles in seconds for free, and gives the same answer every time. Claude was trained on text, reads our data as text, explains itself, costs about six cents per forecast, and may answer slightly differently on a rerun.

</xml_diff>

<commit_message>
Speaker notes: lighter, story-led script for slides 4 and 5
Co-Authored-By: Claude Opus 5.5 <noreply@anthropic.com>
</commit_message>
<xml_diff>
--- a/presentation/Group3_Forecasting_Presentation.pptx
+++ b/presentation/Group3_Forecasting_Presentation.pptx
@@ -115,26 +115,26 @@
   <p:extLst>
     <p:ext uri="{521415D9-36F7-43E2-AB2F-B90AF26B5E84}">
       <p14:sectionLst xmlns:p14="http://schemas.microsoft.com/office/powerpoint/2010/main">
-        <p14:section name="Question and data" id="{22bc92b0-43a4-17ca-8d90-2ba475c26c2d}">
+        <p14:section name="Question and data" id="{46c17889-ebc1-36fd-9bd7-6aa035514cd3}">
           <p14:sldIdLst>
             <p14:sldId id="256"/>
             <p14:sldId id="257"/>
           </p14:sldIdLst>
         </p14:section>
-        <p14:section name="Models and results" id="{847a8879-b418-6c3b-d34b-da653e5ab700}">
+        <p14:section name="Models and results" id="{0aca5bdb-18cc-f69c-48c7-d7a103b32170}">
           <p14:sldIdLst>
             <p14:sldId id="258"/>
             <p14:sldId id="259"/>
             <p14:sldId id="260"/>
           </p14:sldIdLst>
         </p14:section>
-        <p14:section name="LLM experiment" id="{770c0812-e405-aeda-7422-af7dbef1db6b}">
+        <p14:section name="LLM experiment" id="{c792bc7c-8540-0307-c5fc-d42092c4908f}">
           <p14:sldIdLst>
             <p14:sldId id="261"/>
             <p14:sldId id="262"/>
           </p14:sldIdLst>
         </p14:section>
-        <p14:section name="Answer and demo" id="{be8db08f-5d42-ca15-7636-57af16111b03}">
+        <p14:section name="Answer and demo" id="{2cdff3a3-a64a-a793-06c1-a467fdc92169}">
           <p14:sldIdLst>
             <p14:sldId id="263"/>
             <p14:sldId id="264"/>
@@ -5926,10 +5926,11 @@
             <a:r>
               <a:rPr lang="en-US" dirty="0"/>
               <a:t>SPEAKER 2 (1:05)
-Across all 5,748 series, LightGBM was the most accurate single model, with a WRMSSE of 0.646. AutoETS, a much simpler statistical model, was close behind at 0.661. These two were the only single models to beat the seasonal-naive benchmark at 0.814; AutoARIMA scored 0.89 and Chronos 0.95.
-The best result came from simply averaging AutoETS and LightGBM: 0.604, better than either, with no tuning. The two make different kinds of errors, so averaging cancels part of them. Our teammate's Shelf Signal study found the same thing on a different store and item set.
-(OPTIONAL) The metric matters too. Chronos actually has the lowest MAE of all models but the weakest WRMSSE: its forecasts run about 11% low in total, and WRMSSE punishes errors that add up across products.
-TRANSITION: But the overall score hides an important pattern.</a:t>
+Here's the first surprise. Among single models, the M5 champion still wins: LightGBM is the most accurate. But a far simpler statistical model, AutoETS, finishes almost level with it, just 2% behind. And the best forecast came from neither of them on its own: we simply averaged the two, with no tuning at all, and that average beat every model, at 0.604.
+Why does that work? The two models get things wrong in different ways. AutoETS follows each product's own rhythm; LightGBM learns what all products have in common. Averaging them cancels part of each one's mistakes. Our teammate's Shelf Signal study found exactly the same thing on a different store.
+And the pre-trained AI, Chronos, sits at the bottom of this chart, behind even the simple benchmark. (OPTIONAL) Though by a different measure, average error per item, it is actually the best; it just forecasts too low overall, and this metric punishes errors that add up.
+POINT AT: the top bar (0.604), then the Chronos bar at the bottom.
+TRANSITION: But one overall score hides where those differences come from.</a:t>
             </a:r>
             <a:endParaRPr lang="en-US" dirty="0"/>
           </a:p>
@@ -6018,10 +6019,10 @@
             <a:r>
               <a:rPr lang="en-US" dirty="0"/>
               <a:t>SPEAKER 2 (1:10)
-The ranking changes with the level. On the left are store and department totals, where LightGBM and AutoETS are far ahead: they capture the shared weekly pattern. AutoARIMA and Chronos forecast each product separately and give nearly flat lines for slow sellers, so their totals miss the weekend peaks. Summed to the four-store total, daily error is about 4% for LightGBM and 5% for AutoETS, against about 10% for AutoARIMA and Chronos.
-On the right, for one item in one store, all models are close: each single model is the most accurate on between a fifth and a third of products. But close is not the same as a statistical tie; we did not formally test those gaps.
-On speed, the differences are huge. Chronos forecasts everything in 10 seconds with no training. LightGBM and AutoETS take under a minute and a half; AutoARIMA takes 39 minutes. So Chronos's advantage in our study is speed, while its overall accuracy is weaker.
-TRANSITION: Speaker 3 will cover our experiment with a general-purpose language model.</a:t>
+So where does that gap come from? Look at the left side of this chart: whole stores and departments. Here LightGBM and AutoETS are far ahead, because they see the weekend rush. AutoARIMA and Chronos forecast one product at a time, and for a product that sells one or two units a day, their best guess is a flat line. Add up thousands of flat lines, and you miss every Saturday.
+Now look at the right side: a single product in a single store. Here the lines come together. For one product, picking the best model is close to a coin flip, because one product's daily sales are mostly noise. Close isn't a proven tie, but no model stands out.
+And this is where the AI shines: speed. Chronos produces all 5,748 forecasts in about ten seconds, with no training. LightGBM and AutoETS need about a minute and a half; AutoARIMA needs 39 minutes.
+TRANSITION: So a specialist AI is fast. What about a generalist AI that reads and reasons? Speaker 3.</a:t>
             </a:r>
             <a:endParaRPr lang="en-US" dirty="0"/>
           </a:p>

</xml_diff>

<commit_message>
Speaker notes: clearer wording on unusable LLM answers
Co-Authored-By: Claude Opus 5.5 <noreply@anthropic.com>
</commit_message>
<xml_diff>
--- a/presentation/Group3_Forecasting_Presentation.pptx
+++ b/presentation/Group3_Forecasting_Presentation.pptx
@@ -115,26 +115,26 @@
   <p:extLst>
     <p:ext uri="{521415D9-36F7-43E2-AB2F-B90AF26B5E84}">
       <p14:sectionLst xmlns:p14="http://schemas.microsoft.com/office/powerpoint/2010/main">
-        <p14:section name="Question and data" id="{46c17889-ebc1-36fd-9bd7-6aa035514cd3}">
+        <p14:section name="Question and data" id="{43ed8548-6670-9881-5bad-dca4f610feda}">
           <p14:sldIdLst>
             <p14:sldId id="256"/>
             <p14:sldId id="257"/>
           </p14:sldIdLst>
         </p14:section>
-        <p14:section name="Models and results" id="{0aca5bdb-18cc-f69c-48c7-d7a103b32170}">
+        <p14:section name="Models and results" id="{9441dde9-7b3a-4341-4715-2ee168ea709a}">
           <p14:sldIdLst>
             <p14:sldId id="258"/>
             <p14:sldId id="259"/>
             <p14:sldId id="260"/>
           </p14:sldIdLst>
         </p14:section>
-        <p14:section name="LLM experiment" id="{c792bc7c-8540-0307-c5fc-d42092c4908f}">
+        <p14:section name="LLM experiment" id="{2339296c-1fec-ebd2-21b4-695076621150}">
           <p14:sldIdLst>
             <p14:sldId id="261"/>
             <p14:sldId id="262"/>
           </p14:sldIdLst>
         </p14:section>
-        <p14:section name="Answer and demo" id="{2cdff3a3-a64a-a793-06c1-a467fdc92169}">
+        <p14:section name="Answer and demo" id="{22350827-0ec5-a639-60b6-e2e6c396a624}">
           <p14:sldIdLst>
             <p14:sldId id="263"/>
             <p14:sldId id="264"/>
@@ -6205,7 +6205,7 @@
               <a:rPr lang="en-US" dirty="0"/>
               <a:t>SPEAKER 3 (0:55)
 Forecasting with a language model has four risks. First, contamination: the M5 data is public, so Claude may have seen it in training. Our safeguard was the named-versus-blind test: we removed product names, dates and the year. Accuracy didn't change, 0.579 versus 0.583, so real names gave it no advantage.
-Second, outputs can vary between runs; we fixed the prompt and model and saved every response. Third, cost and scale, which is why we used a subset and compared every model on the same subset. Fourth, malformed answers; we required a fixed format and checked every response, and none of the 224 calls failed.
+Second, outputs can vary between runs; we fixed the prompt and model and saved every response. Third, cost and scale, which is why we used a subset and compared every model on the same subset. Fourth, unusable answers: a language model might not reply with exactly 28 clean numbers. We made it answer in a fixed format and checked every reply, and all 224 requests, 112 series each run twice, came back usable.
 But be clear about the limit: the blind test reduces identity cues; it cannot guarantee contamination is excluded, because the sales pattern itself could still be recognised.
 TRANSITION: Speaker 4 will wrap up and show the dashboard.</a:t>
             </a:r>

</xml_diff>

<commit_message>
Speaker notes: drop repeated Claude recap on slide 8
Co-Authored-By: Claude Opus 5.5 <noreply@anthropic.com>
</commit_message>
<xml_diff>
--- a/presentation/Group3_Forecasting_Presentation.pptx
+++ b/presentation/Group3_Forecasting_Presentation.pptx
@@ -115,26 +115,26 @@
   <p:extLst>
     <p:ext uri="{521415D9-36F7-43E2-AB2F-B90AF26B5E84}">
       <p14:sectionLst xmlns:p14="http://schemas.microsoft.com/office/powerpoint/2010/main">
-        <p14:section name="Question and data" id="{43ed8548-6670-9881-5bad-dca4f610feda}">
+        <p14:section name="Question and data" id="{b9fb7d2c-28ae-9c42-ea37-14c2d148c5ca}">
           <p14:sldIdLst>
             <p14:sldId id="256"/>
             <p14:sldId id="257"/>
           </p14:sldIdLst>
         </p14:section>
-        <p14:section name="Models and results" id="{9441dde9-7b3a-4341-4715-2ee168ea709a}">
+        <p14:section name="Models and results" id="{4d995404-611a-7d7b-6201-07642668302f}">
           <p14:sldIdLst>
             <p14:sldId id="258"/>
             <p14:sldId id="259"/>
             <p14:sldId id="260"/>
           </p14:sldIdLst>
         </p14:section>
-        <p14:section name="LLM experiment" id="{2339296c-1fec-ebd2-21b4-695076621150}">
+        <p14:section name="LLM experiment" id="{b8fcc599-0ca4-5df4-22a3-513f53f6e3bf}">
           <p14:sldIdLst>
             <p14:sldId id="261"/>
             <p14:sldId id="262"/>
           </p14:sldIdLst>
         </p14:section>
-        <p14:section name="Answer and demo" id="{22350827-0ec5-a639-60b6-e2e6c396a624}">
+        <p14:section name="Answer and demo" id="{9be2f7ad-688f-09d0-becb-b09e32f22a6e}">
           <p14:sldIdLst>
             <p14:sldId id="263"/>
             <p14:sldId id="264"/>
@@ -6296,7 +6296,7 @@
             <a:r>
               <a:rPr lang="en-US" dirty="0"/>
               <a:t>SPEAKER 4 (2:00)
-So, can AI foundation models beat traditional methods? Our answer: not yet on accuracy, yes on speed. LightGBM, AutoETS and their simple average were the three most accurate. Chronos was the clear winner on speed: ten seconds, no training. And Claude matched the best traditional approach on store totals, but on only 112 series.
+So, can AI foundation models beat traditional methods? Our answer: not yet on accuracy, yes on speed. LightGBM, AutoETS and their simple average were the three most accurate. Chronos was the clear winner on speed: ten seconds, no training.
 Our results have limits. First, we tested one 28-day window, so close rankings could flip in another month. (OPTIONAL) Our teammate's Shelf Signal study, which tested several windows, saw exactly this: gradient-boosted trees beat ETS in one window and lost in the next. Second, Claude was tested on a subset, and our blind test can't fully rule out that it saw this public data. Third, sales are not demand: when a shelf is empty, sales show zero even if customers wanted the product.
 And the most important limitation for a business: accuracy isn't the real goal. Ordering stock is a newsvendor problem with two different costs. If you order too little, you lose the margin on every sale you miss; that's the underage cost. If you order too much, unsold food is wasted at its cost; that's the overage cost. Because those costs depend on the margin, the best order isn't the forecast itself but a quantile of demand, and our accuracy metrics treat over- and under-forecasting the same. When we turned each model's forecasts into orders, the profit differences at typical margins were within chance; only at an 80% margin, where running out is expensive, did the more accurate LightGBM earn significantly more.
 So our recommendation: average a statistical model like AutoETS with LightGBM, use Chronos where speed or a lack of training data matters, and choose models on the metric that matches the business decision. Our next step is a rolling backtest over several windows.

</xml_diff>

<commit_message>
Speaker notes: drop the one-window limitation from slide 8 (covered on slide 2)
Co-Authored-By: Claude Opus 5.5 <noreply@anthropic.com>
</commit_message>
<xml_diff>
--- a/presentation/Group3_Forecasting_Presentation.pptx
+++ b/presentation/Group3_Forecasting_Presentation.pptx
@@ -115,26 +115,26 @@
   <p:extLst>
     <p:ext uri="{521415D9-36F7-43E2-AB2F-B90AF26B5E84}">
       <p14:sectionLst xmlns:p14="http://schemas.microsoft.com/office/powerpoint/2010/main">
-        <p14:section name="Question and data" id="{b9fb7d2c-28ae-9c42-ea37-14c2d148c5ca}">
+        <p14:section name="Question and data" id="{484a4408-60fd-8d2f-e130-77d2b995d7d5}">
           <p14:sldIdLst>
             <p14:sldId id="256"/>
             <p14:sldId id="257"/>
           </p14:sldIdLst>
         </p14:section>
-        <p14:section name="Models and results" id="{4d995404-611a-7d7b-6201-07642668302f}">
+        <p14:section name="Models and results" id="{1a70bd88-0337-9c80-bf1d-fa2e459650f8}">
           <p14:sldIdLst>
             <p14:sldId id="258"/>
             <p14:sldId id="259"/>
             <p14:sldId id="260"/>
           </p14:sldIdLst>
         </p14:section>
-        <p14:section name="LLM experiment" id="{b8fcc599-0ca4-5df4-22a3-513f53f6e3bf}">
+        <p14:section name="LLM experiment" id="{c04d5a34-8d81-c4b4-f265-107c560471a6}">
           <p14:sldIdLst>
             <p14:sldId id="261"/>
             <p14:sldId id="262"/>
           </p14:sldIdLst>
         </p14:section>
-        <p14:section name="Answer and demo" id="{9be2f7ad-688f-09d0-becb-b09e32f22a6e}">
+        <p14:section name="Answer and demo" id="{c63c02af-8ede-696f-b4ed-16c61f5db82f}">
           <p14:sldIdLst>
             <p14:sldId id="263"/>
             <p14:sldId id="264"/>
@@ -6295,9 +6295,9 @@
           <a:p>
             <a:r>
               <a:rPr lang="en-US" dirty="0"/>
-              <a:t>SPEAKER 4 (2:00)
+              <a:t>SPEAKER 4 (1:45)
 So, can AI foundation models beat traditional methods? Our answer: not yet on accuracy, yes on speed. LightGBM, AutoETS and their simple average were the three most accurate. Chronos was the clear winner on speed: ten seconds, no training.
-Our results have limits. First, we tested one 28-day window, so close rankings could flip in another month. (OPTIONAL) Our teammate's Shelf Signal study, which tested several windows, saw exactly this: gradient-boosted trees beat ETS in one window and lost in the next. Second, Claude was tested on a subset, and our blind test can't fully rule out that it saw this public data. Third, sales are not demand: when a shelf is empty, sales show zero even if customers wanted the product.
+Our results have limits. First, Claude was tested on a subset, and our blind test can't fully rule out that it saw this public data. Second, sales are not demand: when a shelf is empty, sales show zero even if customers wanted the product.
 And the most important limitation for a business: accuracy isn't the real goal. Ordering stock is a newsvendor problem with two different costs. If you order too little, you lose the margin on every sale you miss; that's the underage cost. If you order too much, unsold food is wasted at its cost; that's the overage cost. Because those costs depend on the margin, the best order isn't the forecast itself but a quantile of demand, and our accuracy metrics treat over- and under-forecasting the same. When we turned each model's forecasts into orders, the profit differences at typical margins were within chance; only at an 80% margin, where running out is expensive, did the more accurate LightGBM earn significantly more.
 So our recommendation: average a statistical model like AutoETS with LightGBM, use Chronos where speed or a lack of training data matters, and choose models on the metric that matches the business decision. Our next step is a rolling backtest over several windows.
 (OPTIONAL) On AI tools: besides testing Chronos and Claude as forecasters, we used Claude Code to help build the pipeline and the dashboard, and we checked its work; every number comes from our own code.

</xml_diff>

<commit_message>
Speaker notes: drop the AI-tools aside on slide 8
Co-Authored-By: Claude Opus 5.5 <noreply@anthropic.com>
</commit_message>
<xml_diff>
--- a/presentation/Group3_Forecasting_Presentation.pptx
+++ b/presentation/Group3_Forecasting_Presentation.pptx
@@ -115,26 +115,26 @@
   <p:extLst>
     <p:ext uri="{521415D9-36F7-43E2-AB2F-B90AF26B5E84}">
       <p14:sectionLst xmlns:p14="http://schemas.microsoft.com/office/powerpoint/2010/main">
-        <p14:section name="Question and data" id="{484a4408-60fd-8d2f-e130-77d2b995d7d5}">
+        <p14:section name="Question and data" id="{032f1e58-c9c8-b74e-1318-f3b9afc5b0bd}">
           <p14:sldIdLst>
             <p14:sldId id="256"/>
             <p14:sldId id="257"/>
           </p14:sldIdLst>
         </p14:section>
-        <p14:section name="Models and results" id="{1a70bd88-0337-9c80-bf1d-fa2e459650f8}">
+        <p14:section name="Models and results" id="{53e795fd-9348-7508-8882-56ce243bc791}">
           <p14:sldIdLst>
             <p14:sldId id="258"/>
             <p14:sldId id="259"/>
             <p14:sldId id="260"/>
           </p14:sldIdLst>
         </p14:section>
-        <p14:section name="LLM experiment" id="{c04d5a34-8d81-c4b4-f265-107c560471a6}">
+        <p14:section name="LLM experiment" id="{3231596b-e0b0-c6e5-6098-85ffe4336804}">
           <p14:sldIdLst>
             <p14:sldId id="261"/>
             <p14:sldId id="262"/>
           </p14:sldIdLst>
         </p14:section>
-        <p14:section name="Answer and demo" id="{c63c02af-8ede-696f-b4ed-16c61f5db82f}">
+        <p14:section name="Answer and demo" id="{5dbecb49-ee6f-4ab1-d7e7-fdccd33fdaf5}">
           <p14:sldIdLst>
             <p14:sldId id="263"/>
             <p14:sldId id="264"/>
@@ -6300,7 +6300,6 @@
 Our results have limits. First, Claude was tested on a subset, and our blind test can't fully rule out that it saw this public data. Second, sales are not demand: when a shelf is empty, sales show zero even if customers wanted the product.
 And the most important limitation for a business: accuracy isn't the real goal. Ordering stock is a newsvendor problem with two different costs. If you order too little, you lose the margin on every sale you miss; that's the underage cost. If you order too much, unsold food is wasted at its cost; that's the overage cost. Because those costs depend on the margin, the best order isn't the forecast itself but a quantile of demand, and our accuracy metrics treat over- and under-forecasting the same. When we turned each model's forecasts into orders, the profit differences at typical margins were within chance; only at an 80% margin, where running out is expensive, did the more accurate LightGBM earn significantly more.
 So our recommendation: average a statistical model like AutoETS with LightGBM, use Chronos where speed or a lack of training data matters, and choose models on the metric that matches the business decision. Our next step is a rolling backtest over several windows.
-(OPTIONAL) On AI tools: besides testing Chronos and Claude as forecasters, we used Claude Code to help build the pipeline and the dashboard, and we checked its work; every number comes from our own code.
 Let me show you the business problem in our dashboard.
 TRANSITION: click the screenshot on the next slide.</a:t>
             </a:r>

</xml_diff>

<commit_message>
Speaker notes: background note on checking Claude's replies
Co-Authored-By: Claude Opus 5.5 <noreply@anthropic.com>
</commit_message>
<xml_diff>
--- a/presentation/Group3_Forecasting_Presentation.pptx
+++ b/presentation/Group3_Forecasting_Presentation.pptx
@@ -115,26 +115,26 @@
   <p:extLst>
     <p:ext uri="{521415D9-36F7-43E2-AB2F-B90AF26B5E84}">
       <p14:sectionLst xmlns:p14="http://schemas.microsoft.com/office/powerpoint/2010/main">
-        <p14:section name="Question and data" id="{032f1e58-c9c8-b74e-1318-f3b9afc5b0bd}">
+        <p14:section name="Question and data" id="{6be08b0c-fdf9-ffad-3469-4dbab72cf1af}">
           <p14:sldIdLst>
             <p14:sldId id="256"/>
             <p14:sldId id="257"/>
           </p14:sldIdLst>
         </p14:section>
-        <p14:section name="Models and results" id="{53e795fd-9348-7508-8882-56ce243bc791}">
+        <p14:section name="Models and results" id="{ab43614c-e6af-46e7-8b64-fb16f373edf0}">
           <p14:sldIdLst>
             <p14:sldId id="258"/>
             <p14:sldId id="259"/>
             <p14:sldId id="260"/>
           </p14:sldIdLst>
         </p14:section>
-        <p14:section name="LLM experiment" id="{3231596b-e0b0-c6e5-6098-85ffe4336804}">
+        <p14:section name="LLM experiment" id="{a3e5d349-1943-d36c-3b7a-d3cbcd44258c}">
           <p14:sldIdLst>
             <p14:sldId id="261"/>
             <p14:sldId id="262"/>
           </p14:sldIdLst>
         </p14:section>
-        <p14:section name="Answer and demo" id="{5dbecb49-ee6f-4ab1-d7e7-fdccd33fdaf5}">
+        <p14:section name="Answer and demo" id="{68b7dc48-da5b-00b9-4441-e6b4688efde8}">
           <p14:sldIdLst>
             <p14:sldId id="263"/>
             <p14:sldId id="264"/>
@@ -6207,6 +6207,7 @@
 Forecasting with a language model has four risks. First, contamination: the M5 data is public, so Claude may have seen it in training. Our safeguard was the named-versus-blind test: we removed product names, dates and the year. Accuracy didn't change, 0.579 versus 0.583, so real names gave it no advantage.
 Second, outputs can vary between runs; we fixed the prompt and model and saved every response. Third, cost and scale, which is why we used a subset and compared every model on the same subset. Fourth, unusable answers: a language model might not reply with exactly 28 clean numbers. We made it answer in a fixed format and checked every reply, and all 224 requests, 112 series each run twice, came back usable.
 But be clear about the limit: the blind test reduces identity cues; it cannot guarantee contamination is excluded, because the sales pattern itself could still be recognised.
+BACKGROUND (not to read aloud): Our code asked Claude for 28 daily forecasts in a fixed JSON format, one number per day. The risk is that a chatbot answers with prose, skips days or adds extras, which a program can't use. We required that format, checked each reply had exactly 28 days, and retried automatically if a reply failed the check. '224 requests' = 112 series (12 store x department totals + 100 items) x 2 versions (named and blind). All 224 came back usable. If asked: every reply is saved in our repo, so anyone can re-score Claude's forecasts without calling it again.
 TRANSITION: Speaker 4 will wrap up and show the dashboard.</a:t>
             </a:r>
             <a:endParaRPr lang="en-US" dirty="0"/>

</xml_diff>

<commit_message>
Speaker notes: LightGBM as the dominant approach for retail data
Co-Authored-By: Claude Opus 5.5 <noreply@anthropic.com>
</commit_message>
<xml_diff>
--- a/presentation/Group3_Forecasting_Presentation.pptx
+++ b/presentation/Group3_Forecasting_Presentation.pptx
@@ -115,26 +115,26 @@
   <p:extLst>
     <p:ext uri="{521415D9-36F7-43E2-AB2F-B90AF26B5E84}">
       <p14:sectionLst xmlns:p14="http://schemas.microsoft.com/office/powerpoint/2010/main">
-        <p14:section name="Question and data" id="{6be08b0c-fdf9-ffad-3469-4dbab72cf1af}">
+        <p14:section name="Question and data" id="{2598e0b0-62a1-918a-e3f5-621077121f79}">
           <p14:sldIdLst>
             <p14:sldId id="256"/>
             <p14:sldId id="257"/>
           </p14:sldIdLst>
         </p14:section>
-        <p14:section name="Models and results" id="{ab43614c-e6af-46e7-8b64-fb16f373edf0}">
+        <p14:section name="Models and results" id="{b9c0634f-3f8b-3065-7f20-41d2a012557e}">
           <p14:sldIdLst>
             <p14:sldId id="258"/>
             <p14:sldId id="259"/>
             <p14:sldId id="260"/>
           </p14:sldIdLst>
         </p14:section>
-        <p14:section name="LLM experiment" id="{a3e5d349-1943-d36c-3b7a-d3cbcd44258c}">
+        <p14:section name="LLM experiment" id="{ebfcd56c-a665-08a7-16ae-91ac71945609}">
           <p14:sldIdLst>
             <p14:sldId id="261"/>
             <p14:sldId id="262"/>
           </p14:sldIdLst>
         </p14:section>
-        <p14:section name="Answer and demo" id="{68b7dc48-da5b-00b9-4441-e6b4688efde8}">
+        <p14:section name="Answer and demo" id="{bf8791d0-6d5c-3b06-d1b0-2f70560c80ba}">
           <p14:sldIdLst>
             <p14:sldId id="263"/>
             <p14:sldId id="264"/>
@@ -5834,7 +5834,7 @@
               <a:rPr lang="en-US" dirty="0"/>
               <a:t>SPEAKER 2 (1:05)
 We compared five models. AutoETS and AutoARIMA are classic time series models: they fit one model to each product's own history, with a weekly cycle.
-LightGBM is the M5 winner's approach: one machine-learning model trained across all products at once, which then predicts each product. It also sees prices, holidays and food-stamp days.
+LightGBM is the dominant approach for this kind of retail data; it dominated the M5 competition. It is one machine-learning model trained across all products at once, which then predicts each product. It also sees prices, holidays and food-stamp days.
 Chronos is Amazon's pre-trained AI model for time series, trained on about 100 billion data points from energy, traffic, weather and more. It was not trained on M5 or on any retail data: the Chronos paper lists M5 as a held-out test set, so this is a true zero-shot test. Seasonal naive, 'same weekday last week', is the benchmark.
 We also test the simplest possible combination: an unweighted average of AutoETS and LightGBM. Note that the inputs differ: only LightGBM sees prices and the calendar.
 TRANSITION: So how accurate were they?</a:t>

</xml_diff>

<commit_message>
Speaker notes: shorter Chronos sentence on slide 3
Co-Authored-By: Claude Opus 5.5 <noreply@anthropic.com>
</commit_message>
<xml_diff>
--- a/presentation/Group3_Forecasting_Presentation.pptx
+++ b/presentation/Group3_Forecasting_Presentation.pptx
@@ -115,26 +115,26 @@
   <p:extLst>
     <p:ext uri="{521415D9-36F7-43E2-AB2F-B90AF26B5E84}">
       <p14:sectionLst xmlns:p14="http://schemas.microsoft.com/office/powerpoint/2010/main">
-        <p14:section name="Question and data" id="{2598e0b0-62a1-918a-e3f5-621077121f79}">
+        <p14:section name="Question and data" id="{6e140cd0-baae-a340-041d-8c5a328a5e7c}">
           <p14:sldIdLst>
             <p14:sldId id="256"/>
             <p14:sldId id="257"/>
           </p14:sldIdLst>
         </p14:section>
-        <p14:section name="Models and results" id="{b9c0634f-3f8b-3065-7f20-41d2a012557e}">
+        <p14:section name="Models and results" id="{c13dabe5-8229-2427-5898-c2703181283a}">
           <p14:sldIdLst>
             <p14:sldId id="258"/>
             <p14:sldId id="259"/>
             <p14:sldId id="260"/>
           </p14:sldIdLst>
         </p14:section>
-        <p14:section name="LLM experiment" id="{ebfcd56c-a665-08a7-16ae-91ac71945609}">
+        <p14:section name="LLM experiment" id="{7b4ee145-95b1-43c3-ce4e-123df4b5c90e}">
           <p14:sldIdLst>
             <p14:sldId id="261"/>
             <p14:sldId id="262"/>
           </p14:sldIdLst>
         </p14:section>
-        <p14:section name="Answer and demo" id="{bf8791d0-6d5c-3b06-d1b0-2f70560c80ba}">
+        <p14:section name="Answer and demo" id="{9bef4849-f6e4-729b-1caf-257764846cb1}">
           <p14:sldIdLst>
             <p14:sldId id="263"/>
             <p14:sldId id="264"/>
@@ -5835,7 +5835,7 @@
               <a:t>SPEAKER 2 (1:05)
 We compared five models. AutoETS and AutoARIMA are classic time series models: they fit one model to each product's own history, with a weekly cycle.
 LightGBM is the dominant approach for this kind of retail data; it dominated the M5 competition. It is one machine-learning model trained across all products at once, which then predicts each product. It also sees prices, holidays and food-stamp days.
-Chronos is Amazon's pre-trained AI model for time series, trained on about 100 billion data points from energy, traffic, weather and more. It was not trained on M5 or on any retail data: the Chronos paper lists M5 as a held-out test set, so this is a true zero-shot test. Seasonal naive, 'same weekday last week', is the benchmark.
+Chronos is Amazon's pre-trained AI model for time series, trained on about 100 billion data points from energy, traffic, weather and more. It was not trained on M5 or on any retail data, so this is a true zero-shot test. Seasonal naive, 'same weekday last week', is the benchmark.
 We also test the simplest possible combination: an unweighted average of AutoETS and LightGBM. Note that the inputs differ: only LightGBM sees prices and the calendar.
 TRANSITION: So how accurate were they?</a:t>
             </a:r>

</xml_diff>

<commit_message>
Slides 4-5 notes framed as traditional vs AI rounds; fix Chronos MAE claim in report
Co-Authored-By: Claude Opus 5.5 <noreply@anthropic.com>
</commit_message>
<xml_diff>
--- a/presentation/Group3_Forecasting_Presentation.pptx
+++ b/presentation/Group3_Forecasting_Presentation.pptx
@@ -115,26 +115,26 @@
   <p:extLst>
     <p:ext uri="{521415D9-36F7-43E2-AB2F-B90AF26B5E84}">
       <p14:sectionLst xmlns:p14="http://schemas.microsoft.com/office/powerpoint/2010/main">
-        <p14:section name="Question and data" id="{6e140cd0-baae-a340-041d-8c5a328a5e7c}">
+        <p14:section name="Question and data" id="{3bd17daf-1a60-2004-c83e-4373683d8659}">
           <p14:sldIdLst>
             <p14:sldId id="256"/>
             <p14:sldId id="257"/>
           </p14:sldIdLst>
         </p14:section>
-        <p14:section name="Models and results" id="{c13dabe5-8229-2427-5898-c2703181283a}">
+        <p14:section name="Models and results" id="{794ce634-1679-eb3a-fcaa-55a9273700dd}">
           <p14:sldIdLst>
             <p14:sldId id="258"/>
             <p14:sldId id="259"/>
             <p14:sldId id="260"/>
           </p14:sldIdLst>
         </p14:section>
-        <p14:section name="LLM experiment" id="{7b4ee145-95b1-43c3-ce4e-123df4b5c90e}">
+        <p14:section name="LLM experiment" id="{ba73816c-f630-6178-6d73-618fa06580f2}">
           <p14:sldIdLst>
             <p14:sldId id="261"/>
             <p14:sldId id="262"/>
           </p14:sldIdLst>
         </p14:section>
-        <p14:section name="Answer and demo" id="{9bef4849-f6e4-729b-1caf-257764846cb1}">
+        <p14:section name="Answer and demo" id="{39b7eff0-5f4d-c120-157a-6a6de18a8abc}">
           <p14:sldIdLst>
             <p14:sldId id="263"/>
             <p14:sldId id="264"/>
@@ -5837,7 +5837,7 @@
 LightGBM is the dominant approach for this kind of retail data; it dominated the M5 competition. It is one machine-learning model trained across all products at once, which then predicts each product. It also sees prices, holidays and food-stamp days.
 Chronos is Amazon's pre-trained AI model for time series, trained on about 100 billion data points from energy, traffic, weather and more. It was not trained on M5 or on any retail data, so this is a true zero-shot test. Seasonal naive, 'same weekday last week', is the benchmark.
 We also test the simplest possible combination: an unweighted average of AutoETS and LightGBM. Note that the inputs differ: only LightGBM sees prices and the calendar.
-TRANSITION: So how accurate were they?</a:t>
+TRANSITION: So, traditional models or AI: round one, accuracy.</a:t>
             </a:r>
             <a:endParaRPr lang="en-US" dirty="0"/>
           </a:p>
@@ -5926,11 +5926,11 @@
             <a:r>
               <a:rPr lang="en-US" dirty="0"/>
               <a:t>SPEAKER 2 (1:05)
-Here's the first surprise. Among single models, the M5 champion still wins: LightGBM is the most accurate. But a far simpler statistical model, AutoETS, finishes almost level with it, just 2% behind. And the best forecast came from neither of them on its own: we simply averaged the two, with no tuning at all, and that average beat every model, at 0.604.
-Why does that work? The two models get things wrong in different ways. AutoETS follows each product's own rhythm; LightGBM learns what all products have in common. Averaging them cancels part of each one's mistakes. Our teammate's Shelf Signal study found exactly the same thing on a different store.
-And the pre-trained AI, Chronos, sits at the bottom of this chart, behind even the simple benchmark. (OPTIONAL) Though by a different measure, average error per item, it is actually the best; it just forecasts too low overall, and this metric punishes errors that add up.
+Round one: accuracy, traditional models against AI. Here the scoreboard is clear: traditional methods win. The three most accurate forecasts are all traditional: the simple average of AutoETS and LightGBM at 0.604, LightGBM alone at 0.646, and AutoETS at 0.661. The AI model, Chronos, comes last at 0.949, with errors more than 50% larger than the best traditional forecast, and behind even the 'same as last week' benchmark at 0.814.
+Why does the AI lose this round? Chronos has never seen our data, and it reads each product on its own, so it can't learn what all products share, like the weekend rush; it also forecasts about 11% too low overall. LightGBM learns from all 5,748 products at once, and averaging it with AutoETS cancels part of each one's mistakes, which is why the combination wins. Our teammate's Shelf Signal study found the same on a different store.
+(OPTIONAL) One nuance: measured product by product, with plain average error, Chronos has the lowest error of any single model; its mistakes only become costly once they add up across products.
 POINT AT: the top bar (0.604), then the Chronos bar at the bottom.
-TRANSITION: But one overall score hides where those differences come from.</a:t>
+TRANSITION: That's round one to traditional methods. But the score changes when we zoom in, and when we start the clock.</a:t>
             </a:r>
             <a:endParaRPr lang="en-US" dirty="0"/>
           </a:p>
@@ -6019,10 +6019,9 @@
             <a:r>
               <a:rPr lang="en-US" dirty="0"/>
               <a:t>SPEAKER 2 (1:10)
-So where does that gap come from? Look at the left side of this chart: whole stores and departments. Here LightGBM and AutoETS are far ahead, because they see the weekend rush. AutoARIMA and Chronos forecast one product at a time, and for a product that sells one or two units a day, their best guess is a flat line. Add up thousands of flat lines, and you miss every Saturday.
-Now look at the right side: a single product in a single store. Here the lines come together. For one product, picking the best model is close to a coin flip, because one product's daily sales are mostly noise. Close isn't a proven tie, but no model stands out.
-And this is where the AI shines: speed. Chronos produces all 5,748 forecasts in about ten seconds, with no training. LightGBM and AutoETS need about a minute and a half; AutoARIMA needs 39 minutes.
-TRANSITION: So a specialist AI is fast. What about a generalist AI that reads and reasons? Speaker 3.</a:t>
+Round two: where, and how fast. Zoom in to a single product in a single store, the right side of this chart, and the AI catches up. There, Chronos is level with LightGBM, and it is the most accurate model on 27% of products. The traditional advantage sits at the store and department level, where learning across products pays off; for a single product, daily sales are mostly noise, and no model stands out.
+On speed, the AI wins outright. Chronos produced all 5,748 forecasts in ten seconds, with no training at all. LightGBM and AutoETS needed about a minute and a half; AutoARIMA needed 39 minutes, more than 200 times longer. For a retailer re-forecasting thousands of products every day, that difference decides what is practical.
+TRANSITION: So a specialist AI is fast but less accurate. Round three: a generalist AI that reads and reasons. Speaker 3.</a:t>
             </a:r>
             <a:endParaRPr lang="en-US" dirty="0"/>
           </a:p>

</xml_diff>

<commit_message>
Speaker notes: Claude vs Chronos as measured in this study
Co-Authored-By: Claude Opus 5.5 <noreply@anthropic.com>
</commit_message>
<xml_diff>
--- a/presentation/Group3_Forecasting_Presentation.pptx
+++ b/presentation/Group3_Forecasting_Presentation.pptx
@@ -115,26 +115,26 @@
   <p:extLst>
     <p:ext uri="{521415D9-36F7-43E2-AB2F-B90AF26B5E84}">
       <p14:sectionLst xmlns:p14="http://schemas.microsoft.com/office/powerpoint/2010/main">
-        <p14:section name="Question and data" id="{3bd17daf-1a60-2004-c83e-4373683d8659}">
+        <p14:section name="Question and data" id="{4f02856d-c2bb-c28e-f187-b64ce05626b7}">
           <p14:sldIdLst>
             <p14:sldId id="256"/>
             <p14:sldId id="257"/>
           </p14:sldIdLst>
         </p14:section>
-        <p14:section name="Models and results" id="{794ce634-1679-eb3a-fcaa-55a9273700dd}">
+        <p14:section name="Models and results" id="{6f25a654-07f3-dd55-38a4-19836e9f342b}">
           <p14:sldIdLst>
             <p14:sldId id="258"/>
             <p14:sldId id="259"/>
             <p14:sldId id="260"/>
           </p14:sldIdLst>
         </p14:section>
-        <p14:section name="LLM experiment" id="{ba73816c-f630-6178-6d73-618fa06580f2}">
+        <p14:section name="LLM experiment" id="{e803a0bc-8219-e80c-24af-a65237027f4f}">
           <p14:sldIdLst>
             <p14:sldId id="261"/>
             <p14:sldId id="262"/>
           </p14:sldIdLst>
         </p14:section>
-        <p14:section name="Answer and demo" id="{39b7eff0-5f4d-c120-157a-6a6de18a8abc}">
+        <p14:section name="Answer and demo" id="{a268c0d2-016a-c383-9367-c48a02440156}">
           <p14:sldIdLst>
             <p14:sldId id="263"/>
             <p14:sldId id="264"/>
@@ -6113,7 +6113,7 @@
 As an experiment, we also tried Claude, a general-purpose language model. Our code sends each product's last year of sales to Claude through its API, as text, one row per day, with the same calendar and price information LightGBM sees, and it returns a 28-day forecast with a short explanation. Running all 5,748 series would cost hundreds of dollars, so we tested a subset: 100 random items and the 12 store-by-department totals, for $13.54, and compared every model on exactly those series.
 On the totals, Claude scored 0.58, level with the AutoETS-plus-LightGBM average and better than any single model. So it matched the best traditional approach, but did not beat it. On the 100 items, Claude came third, behind AutoETS and AutoARIMA.
 For fairness, we also fitted the other models directly on the totals instead of summing item forecasts, and that mattered: AutoARIMA improved from 0.90 to 0.64 and Chronos from 0.97 to 0.64. How you build a total matters as much as which model you use.
-How is Claude different from Chronos? Both are pre-trained and need no training on our data. But Chronos was trained on numbers, returns quantiles in seconds for free, and gives the same answer every time. Claude was trained on text, reads our data as text, explains itself, costs about six cents per forecast, and may answer slightly differently on a rerun.
+So how did our two AI models compare in this study? Head to head on the same series, Claude was the more accurate: 0.58 against 0.64 for Chronos on the 12 totals, and 0.96 against 0.995 on the 100 items. But Chronos covered all 5,748 series in ten seconds for free, using only each product's sales history, while Claude covered 112 series in about nine minutes for $13.54, with calendar and price information added. And Claude came with a written explanation for every forecast, which Chronos can't give.
 TRANSITION: Using a language model also brings specific risks.</a:t>
             </a:r>
             <a:endParaRPr lang="en-US" dirty="0"/>

</xml_diff>

<commit_message>
Slide 3: add Claude (experiment) row and mention it in the notes
Co-Authored-By: Claude Opus 5.5 <noreply@anthropic.com>
</commit_message>
<xml_diff>
--- a/presentation/Group3_Forecasting_Presentation.pptx
+++ b/presentation/Group3_Forecasting_Presentation.pptx
@@ -115,26 +115,26 @@
   <p:extLst>
     <p:ext uri="{521415D9-36F7-43E2-AB2F-B90AF26B5E84}">
       <p14:sectionLst xmlns:p14="http://schemas.microsoft.com/office/powerpoint/2010/main">
-        <p14:section name="Question and data" id="{4f02856d-c2bb-c28e-f187-b64ce05626b7}">
+        <p14:section name="Question and data" id="{a42c395c-21a3-a36b-7302-4f5d3a85c61b}">
           <p14:sldIdLst>
             <p14:sldId id="256"/>
             <p14:sldId id="257"/>
           </p14:sldIdLst>
         </p14:section>
-        <p14:section name="Models and results" id="{6f25a654-07f3-dd55-38a4-19836e9f342b}">
+        <p14:section name="Models and results" id="{81881492-96be-a306-a292-00e87ccd4434}">
           <p14:sldIdLst>
             <p14:sldId id="258"/>
             <p14:sldId id="259"/>
             <p14:sldId id="260"/>
           </p14:sldIdLst>
         </p14:section>
-        <p14:section name="LLM experiment" id="{e803a0bc-8219-e80c-24af-a65237027f4f}">
+        <p14:section name="LLM experiment" id="{01dcbc77-e345-9229-31d2-d896987dbb58}">
           <p14:sldIdLst>
             <p14:sldId id="261"/>
             <p14:sldId id="262"/>
           </p14:sldIdLst>
         </p14:section>
-        <p14:section name="Answer and demo" id="{a268c0d2-016a-c383-9367-c48a02440156}">
+        <p14:section name="Answer and demo" id="{620f315b-c66d-baf0-ee93-1387d2ebc475}">
           <p14:sldIdLst>
             <p14:sldId id="263"/>
             <p14:sldId id="264"/>
@@ -5836,7 +5836,7 @@
 We compared five models. AutoETS and AutoARIMA are classic time series models: they fit one model to each product's own history, with a weekly cycle.
 LightGBM is the dominant approach for this kind of retail data; it dominated the M5 competition. It is one machine-learning model trained across all products at once, which then predicts each product. It also sees prices, holidays and food-stamp days.
 Chronos is Amazon's pre-trained AI model for time series, trained on about 100 billion data points from energy, traffic, weather and more. It was not trained on M5 or on any retail data, so this is a true zero-shot test. Seasonal naive, 'same weekday last week', is the benchmark.
-We also test the simplest possible combination: an unweighted average of AutoETS and LightGBM. Note that the inputs differ: only LightGBM sees prices and the calendar.
+We also test the simplest possible combination: an unweighted average of AutoETS and LightGBM. And as an experiment, a second AI joins on a subset of series: Claude, a general-purpose language model, which we'll come back to in round three. Note that the inputs differ: only LightGBM and Claude see prices and the calendar.
 TRANSITION: So, traditional models or AI: round one, accuracy.</a:t>
             </a:r>
             <a:endParaRPr lang="en-US" dirty="0"/>
@@ -8634,7 +8634,7 @@
                 <a:gridCol w="4206240"/>
                 <a:gridCol w="2743200"/>
               </a:tblGrid>
-              <a:tr h="512064">
+              <a:tr h="457200">
                 <a:tc>
                   <a:txBody>
                     <a:bodyPr/>
@@ -8880,7 +8880,7 @@
                   </a:tcPr>
                 </a:tc>
               </a:tr>
-              <a:tr h="512064">
+              <a:tr h="457200">
                 <a:tc>
                   <a:txBody>
                     <a:bodyPr/>
@@ -9114,7 +9114,7 @@
                   </a:tcPr>
                 </a:tc>
               </a:tr>
-              <a:tr h="512064">
+              <a:tr h="457200">
                 <a:tc>
                   <a:txBody>
                     <a:bodyPr/>
@@ -9348,7 +9348,7 @@
                   </a:tcPr>
                 </a:tc>
               </a:tr>
-              <a:tr h="512064">
+              <a:tr h="457200">
                 <a:tc>
                   <a:txBody>
                     <a:bodyPr/>
@@ -9582,7 +9582,7 @@
                   </a:tcPr>
                 </a:tc>
               </a:tr>
-              <a:tr h="512064">
+              <a:tr h="457200">
                 <a:tc>
                   <a:txBody>
                     <a:bodyPr/>
@@ -9816,7 +9816,7 @@
                   </a:tcPr>
                 </a:tc>
               </a:tr>
-              <a:tr h="512064">
+              <a:tr h="457200">
                 <a:tc>
                   <a:txBody>
                     <a:bodyPr/>
@@ -10050,7 +10050,7 @@
                   </a:tcPr>
                 </a:tc>
               </a:tr>
-              <a:tr h="512064">
+              <a:tr h="457200">
                 <a:tc>
                   <a:txBody>
                     <a:bodyPr/>
@@ -10284,6 +10284,240 @@
                   </a:tcPr>
                 </a:tc>
               </a:tr>
+              <a:tr h="457200">
+                <a:tc>
+                  <a:txBody>
+                    <a:bodyPr/>
+                    <a:lstStyle/>
+                    <a:p>
+                      <a:pPr indent="0" marL="0">
+                        <a:buNone/>
+                      </a:pPr>
+                      <a:r>
+                        <a:rPr lang="en-US" sz="1500" b="1" dirty="0">
+                          <a:solidFill>
+                            <a:srgbClr val="4A3AA7"/>
+                          </a:solidFill>
+                        </a:rPr>
+                        <a:t>Claude (experiment)</a:t>
+                      </a:r>
+                      <a:endParaRPr lang="en-US" sz="1500" dirty="0"/>
+                    </a:p>
+                  </a:txBody>
+                  <a:tcPr marL="73152" marR="73152" marT="73152" marB="73152" anchor="ctr">
+                    <a:lnL w="9525" cap="flat" cmpd="sng" algn="ctr">
+                      <a:solidFill>
+                        <a:srgbClr val="D9DCE1"/>
+                      </a:solidFill>
+                      <a:prstDash val="solid"/>
+                      <a:round/>
+                      <a:headEnd type="none" w="med" len="med"/>
+                      <a:tailEnd type="none" w="med" len="med"/>
+                    </a:lnL>
+                    <a:lnR w="9525" cap="flat" cmpd="sng" algn="ctr">
+                      <a:solidFill>
+                        <a:srgbClr val="D9DCE1"/>
+                      </a:solidFill>
+                      <a:prstDash val="solid"/>
+                      <a:round/>
+                      <a:headEnd type="none" w="med" len="med"/>
+                      <a:tailEnd type="none" w="med" len="med"/>
+                    </a:lnR>
+                    <a:lnT w="9525" cap="flat" cmpd="sng" algn="ctr">
+                      <a:solidFill>
+                        <a:srgbClr val="D9DCE1"/>
+                      </a:solidFill>
+                      <a:prstDash val="solid"/>
+                      <a:round/>
+                      <a:headEnd type="none" w="med" len="med"/>
+                      <a:tailEnd type="none" w="med" len="med"/>
+                    </a:lnT>
+                    <a:lnB w="9525" cap="flat" cmpd="sng" algn="ctr">
+                      <a:solidFill>
+                        <a:srgbClr val="D9DCE1"/>
+                      </a:solidFill>
+                      <a:prstDash val="solid"/>
+                      <a:round/>
+                      <a:headEnd type="none" w="med" len="med"/>
+                      <a:tailEnd type="none" w="med" len="med"/>
+                    </a:lnB>
+                  </a:tcPr>
+                </a:tc>
+                <a:tc>
+                  <a:txBody>
+                    <a:bodyPr/>
+                    <a:lstStyle/>
+                    <a:p>
+                      <a:pPr indent="0" marL="0">
+                        <a:buNone/>
+                      </a:pPr>
+                      <a:r>
+                        <a:rPr lang="en-US" sz="1500" dirty="0">
+                          <a:solidFill>
+                            <a:srgbClr val="1F2328"/>
+                          </a:solidFill>
+                        </a:rPr>
+                        <a:t>General-purpose AI</a:t>
+                      </a:r>
+                      <a:endParaRPr lang="en-US" sz="1500" dirty="0"/>
+                    </a:p>
+                  </a:txBody>
+                  <a:tcPr marL="73152" marR="73152" marT="73152" marB="73152" anchor="ctr">
+                    <a:lnL w="9525" cap="flat" cmpd="sng" algn="ctr">
+                      <a:solidFill>
+                        <a:srgbClr val="D9DCE1"/>
+                      </a:solidFill>
+                      <a:prstDash val="solid"/>
+                      <a:round/>
+                      <a:headEnd type="none" w="med" len="med"/>
+                      <a:tailEnd type="none" w="med" len="med"/>
+                    </a:lnL>
+                    <a:lnR w="9525" cap="flat" cmpd="sng" algn="ctr">
+                      <a:solidFill>
+                        <a:srgbClr val="D9DCE1"/>
+                      </a:solidFill>
+                      <a:prstDash val="solid"/>
+                      <a:round/>
+                      <a:headEnd type="none" w="med" len="med"/>
+                      <a:tailEnd type="none" w="med" len="med"/>
+                    </a:lnR>
+                    <a:lnT w="9525" cap="flat" cmpd="sng" algn="ctr">
+                      <a:solidFill>
+                        <a:srgbClr val="D9DCE1"/>
+                      </a:solidFill>
+                      <a:prstDash val="solid"/>
+                      <a:round/>
+                      <a:headEnd type="none" w="med" len="med"/>
+                      <a:tailEnd type="none" w="med" len="med"/>
+                    </a:lnT>
+                    <a:lnB w="9525" cap="flat" cmpd="sng" algn="ctr">
+                      <a:solidFill>
+                        <a:srgbClr val="D9DCE1"/>
+                      </a:solidFill>
+                      <a:prstDash val="solid"/>
+                      <a:round/>
+                      <a:headEnd type="none" w="med" len="med"/>
+                      <a:tailEnd type="none" w="med" len="med"/>
+                    </a:lnB>
+                  </a:tcPr>
+                </a:tc>
+                <a:tc>
+                  <a:txBody>
+                    <a:bodyPr/>
+                    <a:lstStyle/>
+                    <a:p>
+                      <a:pPr indent="0" marL="0">
+                        <a:buNone/>
+                      </a:pPr>
+                      <a:r>
+                        <a:rPr lang="en-US" sz="1500" dirty="0">
+                          <a:solidFill>
+                            <a:srgbClr val="1F2328"/>
+                          </a:solidFill>
+                        </a:rPr>
+                        <a:t>Reads sales as text and reasons; 112 series only</a:t>
+                      </a:r>
+                      <a:endParaRPr lang="en-US" sz="1500" dirty="0"/>
+                    </a:p>
+                  </a:txBody>
+                  <a:tcPr marL="73152" marR="73152" marT="73152" marB="73152" anchor="ctr">
+                    <a:lnL w="9525" cap="flat" cmpd="sng" algn="ctr">
+                      <a:solidFill>
+                        <a:srgbClr val="D9DCE1"/>
+                      </a:solidFill>
+                      <a:prstDash val="solid"/>
+                      <a:round/>
+                      <a:headEnd type="none" w="med" len="med"/>
+                      <a:tailEnd type="none" w="med" len="med"/>
+                    </a:lnL>
+                    <a:lnR w="9525" cap="flat" cmpd="sng" algn="ctr">
+                      <a:solidFill>
+                        <a:srgbClr val="D9DCE1"/>
+                      </a:solidFill>
+                      <a:prstDash val="solid"/>
+                      <a:round/>
+                      <a:headEnd type="none" w="med" len="med"/>
+                      <a:tailEnd type="none" w="med" len="med"/>
+                    </a:lnR>
+                    <a:lnT w="9525" cap="flat" cmpd="sng" algn="ctr">
+                      <a:solidFill>
+                        <a:srgbClr val="D9DCE1"/>
+                      </a:solidFill>
+                      <a:prstDash val="solid"/>
+                      <a:round/>
+                      <a:headEnd type="none" w="med" len="med"/>
+                      <a:tailEnd type="none" w="med" len="med"/>
+                    </a:lnT>
+                    <a:lnB w="9525" cap="flat" cmpd="sng" algn="ctr">
+                      <a:solidFill>
+                        <a:srgbClr val="D9DCE1"/>
+                      </a:solidFill>
+                      <a:prstDash val="solid"/>
+                      <a:round/>
+                      <a:headEnd type="none" w="med" len="med"/>
+                      <a:tailEnd type="none" w="med" len="med"/>
+                    </a:lnB>
+                  </a:tcPr>
+                </a:tc>
+                <a:tc>
+                  <a:txBody>
+                    <a:bodyPr/>
+                    <a:lstStyle/>
+                    <a:p>
+                      <a:pPr indent="0" marL="0">
+                        <a:buNone/>
+                      </a:pPr>
+                      <a:r>
+                        <a:rPr lang="en-US" sz="1500" dirty="0">
+                          <a:solidFill>
+                            <a:srgbClr val="1F2328"/>
+                          </a:solidFill>
+                        </a:rPr>
+                        <a:t>History + price, calendar</a:t>
+                      </a:r>
+                      <a:endParaRPr lang="en-US" sz="1500" dirty="0"/>
+                    </a:p>
+                  </a:txBody>
+                  <a:tcPr marL="73152" marR="73152" marT="73152" marB="73152" anchor="ctr">
+                    <a:lnL w="9525" cap="flat" cmpd="sng" algn="ctr">
+                      <a:solidFill>
+                        <a:srgbClr val="D9DCE1"/>
+                      </a:solidFill>
+                      <a:prstDash val="solid"/>
+                      <a:round/>
+                      <a:headEnd type="none" w="med" len="med"/>
+                      <a:tailEnd type="none" w="med" len="med"/>
+                    </a:lnL>
+                    <a:lnR w="9525" cap="flat" cmpd="sng" algn="ctr">
+                      <a:solidFill>
+                        <a:srgbClr val="D9DCE1"/>
+                      </a:solidFill>
+                      <a:prstDash val="solid"/>
+                      <a:round/>
+                      <a:headEnd type="none" w="med" len="med"/>
+                      <a:tailEnd type="none" w="med" len="med"/>
+                    </a:lnR>
+                    <a:lnT w="9525" cap="flat" cmpd="sng" algn="ctr">
+                      <a:solidFill>
+                        <a:srgbClr val="D9DCE1"/>
+                      </a:solidFill>
+                      <a:prstDash val="solid"/>
+                      <a:round/>
+                      <a:headEnd type="none" w="med" len="med"/>
+                      <a:tailEnd type="none" w="med" len="med"/>
+                    </a:lnT>
+                    <a:lnB w="9525" cap="flat" cmpd="sng" algn="ctr">
+                      <a:solidFill>
+                        <a:srgbClr val="D9DCE1"/>
+                      </a:solidFill>
+                      <a:prstDash val="solid"/>
+                      <a:round/>
+                      <a:headEnd type="none" w="med" len="med"/>
+                      <a:tailEnd type="none" w="med" len="med"/>
+                    </a:lnB>
+                  </a:tcPr>
+                </a:tc>
+              </a:tr>
             </a:tbl>
           </a:graphicData>
         </a:graphic>
@@ -10296,12 +10530,12 @@
         </p:nvSpPr>
         <p:spPr>
           <a:xfrm>
-            <a:off x="548640" y="5257800"/>
-            <a:ext cx="11064240" cy="777240"/>
+            <a:off x="548640" y="5577840"/>
+            <a:ext cx="11064240" cy="640080"/>
           </a:xfrm>
           <a:prstGeom prst="roundRect">
             <a:avLst>
-              <a:gd name="adj" fmla="val 14118"/>
+              <a:gd name="adj" fmla="val 17143"/>
             </a:avLst>
           </a:prstGeom>
           <a:solidFill>
@@ -10323,8 +10557,8 @@
         </p:nvSpPr>
         <p:spPr>
           <a:xfrm>
-            <a:off x="822960" y="5257800"/>
-            <a:ext cx="10607040" cy="777240"/>
+            <a:off x="822960" y="5577840"/>
+            <a:ext cx="10607040" cy="640080"/>
           </a:xfrm>
           <a:prstGeom prst="rect">
             <a:avLst/>
@@ -10340,7 +10574,7 @@
               <a:buNone/>
             </a:pPr>
             <a:r>
-              <a:rPr lang="en-US" sz="1500" b="1" dirty="0">
+              <a:rPr lang="en-US" sz="1400" b="1" dirty="0">
                 <a:solidFill>
                   <a:schemeClr val="tx2"/>
                 </a:solidFill>
@@ -10351,14 +10585,14 @@
               <a:buNone/>
             </a:pPr>
             <a:r>
-              <a:rPr lang="en-US" sz="1500" dirty="0">
+              <a:rPr lang="en-US" sz="1400" dirty="0">
                 <a:solidFill>
                   <a:schemeClr val="tx2"/>
                 </a:solidFill>
               </a:rPr>
-              <a:t>AutoETS, AutoARIMA and Chronos see only each series' own history; LightGBM also sees prices and the calendar.</a:t>
+              <a:t>AutoETS, AutoARIMA and Chronos see only each series' own history; LightGBM and Claude also see prices and the calendar.</a:t>
             </a:r>
-            <a:endParaRPr lang="en-US" sz="1500" dirty="0"/>
+            <a:endParaRPr lang="en-US" sz="1400" dirty="0"/>
           </a:p>
         </p:txBody>
       </p:sp>

</xml_diff>

<commit_message>
Speaker notes: drop exact Claude cost on slide 6
Co-Authored-By: Claude Opus 5.5 <noreply@anthropic.com>
</commit_message>
<xml_diff>
--- a/presentation/Group3_Forecasting_Presentation.pptx
+++ b/presentation/Group3_Forecasting_Presentation.pptx
@@ -115,26 +115,26 @@
   <p:extLst>
     <p:ext uri="{521415D9-36F7-43E2-AB2F-B90AF26B5E84}">
       <p14:sectionLst xmlns:p14="http://schemas.microsoft.com/office/powerpoint/2010/main">
-        <p14:section name="Question and data" id="{a42c395c-21a3-a36b-7302-4f5d3a85c61b}">
+        <p14:section name="Question and data" id="{a82aaaa7-9d02-5c41-d3b5-8f595e8e3e13}">
           <p14:sldIdLst>
             <p14:sldId id="256"/>
             <p14:sldId id="257"/>
           </p14:sldIdLst>
         </p14:section>
-        <p14:section name="Models and results" id="{81881492-96be-a306-a292-00e87ccd4434}">
+        <p14:section name="Models and results" id="{14548882-742f-3e94-baa6-a07fc84a4e8f}">
           <p14:sldIdLst>
             <p14:sldId id="258"/>
             <p14:sldId id="259"/>
             <p14:sldId id="260"/>
           </p14:sldIdLst>
         </p14:section>
-        <p14:section name="LLM experiment" id="{01dcbc77-e345-9229-31d2-d896987dbb58}">
+        <p14:section name="LLM experiment" id="{78de633b-7e10-9b15-f1d0-9178bb6a2935}">
           <p14:sldIdLst>
             <p14:sldId id="261"/>
             <p14:sldId id="262"/>
           </p14:sldIdLst>
         </p14:section>
-        <p14:section name="Answer and demo" id="{620f315b-c66d-baf0-ee93-1387d2ebc475}">
+        <p14:section name="Answer and demo" id="{92910036-308d-69b2-7e69-3347ca5a8111}">
           <p14:sldIdLst>
             <p14:sldId id="263"/>
             <p14:sldId id="264"/>
@@ -6110,7 +6110,7 @@
             <a:r>
               <a:rPr lang="en-US" dirty="0"/>
               <a:t>SPEAKER 3 (1:15)
-As an experiment, we also tried Claude, a general-purpose language model. Our code sends each product's last year of sales to Claude through its API, as text, one row per day, with the same calendar and price information LightGBM sees, and it returns a 28-day forecast with a short explanation. Running all 5,748 series would cost hundreds of dollars, so we tested a subset: 100 random items and the 12 store-by-department totals, for $13.54, and compared every model on exactly those series.
+As an experiment, we also tried Claude, a general-purpose language model. Our code sends each product's last year of sales to Claude through its API, as text, one row per day, with the same calendar and price information LightGBM sees, and it returns a 28-day forecast with a short explanation. Running all 5,748 series would cost hundreds of dollars, so we tested a subset: 100 random items and the 12 store-by-department totals, and compared every model on exactly those series.
 On the totals, Claude scored 0.58, level with the AutoETS-plus-LightGBM average and better than any single model. So it matched the best traditional approach, but did not beat it. On the 100 items, Claude came third, behind AutoETS and AutoARIMA.
 For fairness, we also fitted the other models directly on the totals instead of summing item forecasts, and that mattered: AutoARIMA improved from 0.90 to 0.64 and Chronos from 0.97 to 0.64. How you build a total matters as much as which model you use.
 So how did our two AI models compare in this study? Head to head on the same series, Claude was the more accurate: 0.58 against 0.64 for Chronos on the 12 totals, and 0.96 against 0.995 on the 100 items. But Chronos covered all 5,748 series in ten seconds for free, using only each product's sales history, while Claude covered 112 series in about nine minutes for $13.54, with calendar and price information added. And Claude came with a written explanation for every forecast, which Chronos can't give.

</xml_diff>

<commit_message>
Claude slides: explain the API and blind test, drop cost figures
Co-Authored-By: Claude Opus 5.5 <noreply@anthropic.com>
</commit_message>
<xml_diff>
--- a/presentation/Group3_Forecasting_Presentation.pptx
+++ b/presentation/Group3_Forecasting_Presentation.pptx
@@ -115,26 +115,26 @@
   <p:extLst>
     <p:ext uri="{521415D9-36F7-43E2-AB2F-B90AF26B5E84}">
       <p14:sectionLst xmlns:p14="http://schemas.microsoft.com/office/powerpoint/2010/main">
-        <p14:section name="Question and data" id="{649dd304-434d-ded9-99c1-9121d2d4555b}">
+        <p14:section name="Question and data" id="{cd7df499-e73c-1cbc-18a3-3fc1728970d7}">
           <p14:sldIdLst>
             <p14:sldId id="256"/>
             <p14:sldId id="257"/>
           </p14:sldIdLst>
         </p14:section>
-        <p14:section name="Models and results" id="{5b18f6d7-2d8d-5a9a-d350-0e39f0b4fee4}">
+        <p14:section name="Models and results" id="{74a89d42-6b35-0018-cdd9-ff960568e687}">
           <p14:sldIdLst>
             <p14:sldId id="258"/>
             <p14:sldId id="259"/>
             <p14:sldId id="260"/>
           </p14:sldIdLst>
         </p14:section>
-        <p14:section name="LLM experiment" id="{f3398a92-3f83-d017-0e7d-99db0c695973}">
+        <p14:section name="LLM experiment" id="{d509ad14-0ef6-4bef-124e-b149c8b2ab52}">
           <p14:sldIdLst>
             <p14:sldId id="261"/>
             <p14:sldId id="262"/>
           </p14:sldIdLst>
         </p14:section>
-        <p14:section name="Answer and demo" id="{16ebf6c4-663e-2ea4-4d5f-a6353b026362}">
+        <p14:section name="Answer and demo" id="{34914f11-49ab-cbc3-2ed8-52e23e913853}">
           <p14:sldIdLst>
             <p14:sldId id="263"/>
             <p14:sldId id="264"/>
@@ -5710,11 +5710,11 @@
             <a:r>
               <a:rPr lang="en-US" dirty="0"/>
               <a:t>SPEAKER 3 (1:15)
-As an experiment, we also tried Claude, a general-purpose language model. Our code sends each product's last year of sales to Claude through its API, as text, one row per day, with the same calendar and price information LightGBM sees, and it returns a 28-day forecast with a short explanation. Running all 5,748 series would cost hundreds of dollars, so we tested a subset: 100 random items and the 12 store-by-department totals, and compared every model on exactly those series.
-On the totals, Claude scored 0.58, level with the AutoETS-plus-LightGBM average and better than any single model. So it matched the best traditional approach, but did not beat it. On the 100 items, Claude came third, behind AutoETS and AutoARIMA.
-For fairness, we also fitted the other models directly on the totals instead of summing item forecasts, and that mattered: AutoARIMA improved from 0.90 to 0.64 and Chronos from 0.97 to 0.64. How you build a total matters as much as which model you use.
-So how did our two AI models compare in this study? Head to head on the same series, Claude was the more accurate: 0.58 against 0.64 for Chronos on the 12 totals, and 0.96 against 0.995 on the 100 items. But Chronos covered all 5,748 series in ten seconds for free, using only each product's sales history, while Claude covered 112 series in about nine minutes for $13.54, with calendar and price information added. And Claude came with a written explanation for every forecast, which Chronos can't give.
-TRANSITION: Using a language model also brings specific risks.</a:t>
+Now a generalist AI. Claude is a large language model, the same kind of model as ChatGPT. We used it through its API, which means our code, not a person, sends the requests. For each product, the code sends the past year of daily sales as plain text, one row per day with the date, holidays, food-stamp days and price, plus an instruction: forecast the next 28 days and answer in a fixed format. Claude reads the numbers, reasons about patterns such as weekends and holidays, and sends back 28 daily forecasts with a short explanation. No statistical model is fitted; it works from what it learned in training.
+Each request costs money and takes a few seconds, so to keep the cost down we used a subset instead of all 5,748 series: 100 randomly chosen products and the 12 store-by-department totals. Every other model was scored on exactly the same series, and to keep it fair, the other models were also fitted directly on those totals.
+How did it perform? On the store totals, very well: it matched our best traditional forecast, the AutoETS-plus-LightGBM average, and beat every single model, including Chronos. On individual products it was in the pack, behind AutoETS and AutoARIMA. So the generalist AI was more accurate than the specialist one, but far slower and more costly to run at scale.
+POINT AT: the Claude bars at the top of the chart, then the comparison table.
+TRANSITION: Using a language model also brings a specific risk.</a:t>
             </a:r>
             <a:endParaRPr lang="en-US" dirty="0"/>
           </a:p>
@@ -5802,11 +5802,12 @@
           <a:p>
             <a:r>
               <a:rPr lang="en-US" dirty="0"/>
-              <a:t>SPEAKER 3 (0:55)
-Forecasting with a language model has four risks. First, contamination: the M5 data is public, so Claude may have seen it in training. Our safeguard was the named-versus-blind test: we removed product names, dates and the year. Accuracy didn't change, 0.579 versus 0.583, so real names gave it no advantage.
-Second, outputs can vary between runs; we fixed the prompt and model and saved every response. Third, cost and scale, which is why we used a subset and compared every model on the same subset. Fourth, unusable answers: a language model might not reply with exactly 28 clean numbers. We made it answer in a fixed format and checked every reply, and all 224 requests, 112 series each run twice, came back usable.
-But be clear about the limit: the blind test reduces identity cues; it cannot guarantee contamination is excluded, because the sales pattern itself could still be recognised.
-BACKGROUND (not to read aloud): Our code asked Claude for 28 daily forecasts in a fixed JSON format, one number per day. The risk is that a chatbot answers with prose, skips days or adds extras, which a program can't use. We required that format, checked each reply had exactly 28 days, and retried automatically if a reply failed the check. '224 requests' = 112 series (12 store x department totals + 100 items) x 2 versions (named and blind). All 224 came back usable. If asked: every reply is saved in our repo, so anyone can re-score Claude's forecasts without calling it again.
+              <a:t>SPEAKER 3 (1:00)
+The obvious worry: M5 is public data, so Claude may have seen these exact sales during training, and be remembering rather than forecasting. So we ran a blind test. Every forecast was made twice: once with the real labels, meaning Walmart, the store and product IDs, and the real dates; and once with all of that hidden, just 'day 1, day 2' with no names and no year.
+Think of it as a blind taste test. It's the same idea as a permutation test in statistics: if the labels carry no information, taking them away shouldn't change the result. And it didn't: accuracy was practically identical with and without the labels, 0.579 versus 0.583. Knowing it was Walmart in 2016 gave Claude no advantage.
+We also saved every response so the results can be re-checked, and checked that every answer came back in the right format. One honest limit remains: hiding the labels can't hide the sales pattern itself. If Claude had memorised the shape of these series, a blind test couldn't catch it, so contamination can't be fully ruled out.
+IF ASKED (permutation test): it is the same idea, not a formal permutation test. A real one reshuffles labels many times to get a p-value; we made one with-labels vs without-labels comparison.
+BACKGROUND (not to read aloud): Our code asked Claude for 28 daily forecasts in a fixed JSON format. We checked each reply had exactly 28 days and retried automatically if not. 224 requests = 112 series x 2 versions (named and blind); all came back usable. Every reply is saved in our repo.
 TRANSITION: Speaker 4 will wrap up and show the dashboard.</a:t>
             </a:r>
             <a:endParaRPr lang="en-US" dirty="0"/>
@@ -14584,7 +14585,7 @@
                             <a:srgbClr val="1F2328"/>
                           </a:solidFill>
                         </a:rPr>
-                        <a:t>~3.7 h, ~$347</a:t>
+                        <a:t>Hours; paid per request</a:t>
                       </a:r>
                       <a:endParaRPr lang="en-US" sz="1300" dirty="0"/>
                     </a:p>
@@ -14740,7 +14741,7 @@
                   <a:srgbClr val="6B6A66"/>
                 </a:solidFill>
               </a:rPr>
-              <a:t>Claude covered a subset: 100 random items + 12 totals ($13.54), compared on the same series. Totals were also fitted directly for the other models.</a:t>
+              <a:t>Claude covered a subset to keep cost down: 100 random items + 12 totals, compared on the same series. Totals were also fitted directly for the other models.</a:t>
             </a:r>
             <a:endParaRPr lang="en-US" sz="1300" dirty="0"/>
           </a:p>
@@ -15370,7 +15371,7 @@
                   <a:srgbClr val="6B6A66"/>
                 </a:solidFill>
               </a:rPr>
-              <a:t>About $0.06 per series; hours for all 5,748</a:t>
+              <a:t>Paid per request; slow at scale</a:t>
             </a:r>
             <a:endParaRPr lang="en-US" sz="1400" dirty="0"/>
           </a:p>

</xml_diff>

<commit_message>
Speaker notes: trim slide 6 opener
Co-Authored-By: Claude Opus 5.5 <noreply@anthropic.com>
</commit_message>
<xml_diff>
--- a/presentation/Group3_Forecasting_Presentation.pptx
+++ b/presentation/Group3_Forecasting_Presentation.pptx
@@ -115,26 +115,26 @@
   <p:extLst>
     <p:ext uri="{521415D9-36F7-43E2-AB2F-B90AF26B5E84}">
       <p14:sectionLst xmlns:p14="http://schemas.microsoft.com/office/powerpoint/2010/main">
-        <p14:section name="Question and data" id="{cd7df499-e73c-1cbc-18a3-3fc1728970d7}">
+        <p14:section name="Question and data" id="{52359278-10ab-61a8-e84c-70415cdad271}">
           <p14:sldIdLst>
             <p14:sldId id="256"/>
             <p14:sldId id="257"/>
           </p14:sldIdLst>
         </p14:section>
-        <p14:section name="Models and results" id="{74a89d42-6b35-0018-cdd9-ff960568e687}">
+        <p14:section name="Models and results" id="{c925eb53-f3fc-4491-decb-52b7e3844104}">
           <p14:sldIdLst>
             <p14:sldId id="258"/>
             <p14:sldId id="259"/>
             <p14:sldId id="260"/>
           </p14:sldIdLst>
         </p14:section>
-        <p14:section name="LLM experiment" id="{d509ad14-0ef6-4bef-124e-b149c8b2ab52}">
+        <p14:section name="LLM experiment" id="{7341b9e7-79e9-d754-51e6-cce6f1e02362}">
           <p14:sldIdLst>
             <p14:sldId id="261"/>
             <p14:sldId id="262"/>
           </p14:sldIdLst>
         </p14:section>
-        <p14:section name="Answer and demo" id="{34914f11-49ab-cbc3-2ed8-52e23e913853}">
+        <p14:section name="Answer and demo" id="{9a3d4e0b-ea2a-2448-735f-2c94d5dda4af}">
           <p14:sldIdLst>
             <p14:sldId id="263"/>
             <p14:sldId id="264"/>
@@ -5710,7 +5710,7 @@
             <a:r>
               <a:rPr lang="en-US" dirty="0"/>
               <a:t>SPEAKER 3 (1:15)
-Now a generalist AI. Claude is a large language model, the same kind of model as ChatGPT. We used it through its API, which means our code, not a person, sends the requests. For each product, the code sends the past year of daily sales as plain text, one row per day with the date, holidays, food-stamp days and price, plus an instruction: forecast the next 28 days and answer in a fixed format. Claude reads the numbers, reasons about patterns such as weekends and holidays, and sends back 28 daily forecasts with a short explanation. No statistical model is fitted; it works from what it learned in training.
+Claude is a large language model, the same kind of model as ChatGPT. We used it through its API, which means our code, not a person, sends the requests. For each product, the code sends the past year of daily sales as plain text, one row per day with the date, holidays, food-stamp days and price, plus an instruction: forecast the next 28 days and answer in a fixed format. Claude reads the numbers, reasons about patterns such as weekends and holidays, and sends back 28 daily forecasts with a short explanation. No statistical model is fitted; it works from what it learned in training.
 Each request costs money and takes a few seconds, so to keep the cost down we used a subset instead of all 5,748 series: 100 randomly chosen products and the 12 store-by-department totals. Every other model was scored on exactly the same series, and to keep it fair, the other models were also fitted directly on those totals.
 How did it perform? On the store totals, very well: it matched our best traditional forecast, the AutoETS-plus-LightGBM average, and beat every single model, including Chronos. On individual products it was in the pack, behind AutoETS and AutoARIMA. So the generalist AI was more accurate than the specialist one, but far slower and more costly to run at scale.
 POINT AT: the Claude bars at the top of the chart, then the comparison table.

</xml_diff>

<commit_message>
Speaker notes: trim API sentence on slide 6
Co-Authored-By: Claude Opus 5.5 <noreply@anthropic.com>
</commit_message>
<xml_diff>
--- a/presentation/Group3_Forecasting_Presentation.pptx
+++ b/presentation/Group3_Forecasting_Presentation.pptx
@@ -115,26 +115,26 @@
   <p:extLst>
     <p:ext uri="{521415D9-36F7-43E2-AB2F-B90AF26B5E84}">
       <p14:sectionLst xmlns:p14="http://schemas.microsoft.com/office/powerpoint/2010/main">
-        <p14:section name="Question and data" id="{52359278-10ab-61a8-e84c-70415cdad271}">
+        <p14:section name="Question and data" id="{9e97d2e9-1b69-eda9-4079-e066bd2b94ab}">
           <p14:sldIdLst>
             <p14:sldId id="256"/>
             <p14:sldId id="257"/>
           </p14:sldIdLst>
         </p14:section>
-        <p14:section name="Models and results" id="{c925eb53-f3fc-4491-decb-52b7e3844104}">
+        <p14:section name="Models and results" id="{0b510f2d-e9a8-876c-a0ac-26d1ae3e1b56}">
           <p14:sldIdLst>
             <p14:sldId id="258"/>
             <p14:sldId id="259"/>
             <p14:sldId id="260"/>
           </p14:sldIdLst>
         </p14:section>
-        <p14:section name="LLM experiment" id="{7341b9e7-79e9-d754-51e6-cce6f1e02362}">
+        <p14:section name="LLM experiment" id="{3395c871-3020-264f-34ff-f0d9262b93b6}">
           <p14:sldIdLst>
             <p14:sldId id="261"/>
             <p14:sldId id="262"/>
           </p14:sldIdLst>
         </p14:section>
-        <p14:section name="Answer and demo" id="{9a3d4e0b-ea2a-2448-735f-2c94d5dda4af}">
+        <p14:section name="Answer and demo" id="{38691d2d-4b6e-75c8-4157-8292e209cee5}">
           <p14:sldIdLst>
             <p14:sldId id="263"/>
             <p14:sldId id="264"/>
@@ -5710,7 +5710,7 @@
             <a:r>
               <a:rPr lang="en-US" dirty="0"/>
               <a:t>SPEAKER 3 (1:15)
-Claude is a large language model, the same kind of model as ChatGPT. We used it through its API, which means our code, not a person, sends the requests. For each product, the code sends the past year of daily sales as plain text, one row per day with the date, holidays, food-stamp days and price, plus an instruction: forecast the next 28 days and answer in a fixed format. Claude reads the numbers, reasons about patterns such as weekends and holidays, and sends back 28 daily forecasts with a short explanation. No statistical model is fitted; it works from what it learned in training.
+Claude is a large language model, the same kind of model as ChatGPT. We used it through its API. For each product, our code sends the past year of daily sales as plain text, one row per day with the date, holidays, food-stamp days and price, plus an instruction: forecast the next 28 days and answer in a fixed format. Claude reads the numbers, reasons about patterns such as weekends and holidays, and sends back 28 daily forecasts with a short explanation. No statistical model is fitted; it works from what it learned in training.
 Each request costs money and takes a few seconds, so to keep the cost down we used a subset instead of all 5,748 series: 100 randomly chosen products and the 12 store-by-department totals. Every other model was scored on exactly the same series, and to keep it fair, the other models were also fitted directly on those totals.
 How did it perform? On the store totals, very well: it matched our best traditional forecast, the AutoETS-plus-LightGBM average, and beat every single model, including Chronos. On individual products it was in the pack, behind AutoETS and AutoARIMA. So the generalist AI was more accurate than the specialist one, but far slower and more costly to run at scale.
 POINT AT: the Claude bars at the top of the chart, then the comparison table.

</xml_diff>

<commit_message>
Speaker notes: plainer newsvendor result on slide 8
Co-Authored-By: Claude Opus 5.5 <noreply@anthropic.com>
</commit_message>
<xml_diff>
--- a/presentation/Group3_Forecasting_Presentation.pptx
+++ b/presentation/Group3_Forecasting_Presentation.pptx
@@ -115,26 +115,26 @@
   <p:extLst>
     <p:ext uri="{521415D9-36F7-43E2-AB2F-B90AF26B5E84}">
       <p14:sectionLst xmlns:p14="http://schemas.microsoft.com/office/powerpoint/2010/main">
-        <p14:section name="Question and data" id="{9e97d2e9-1b69-eda9-4079-e066bd2b94ab}">
+        <p14:section name="Question and data" id="{17bfd7a9-f210-6d2d-9e38-07502ce5c1e5}">
           <p14:sldIdLst>
             <p14:sldId id="256"/>
             <p14:sldId id="257"/>
           </p14:sldIdLst>
         </p14:section>
-        <p14:section name="Models and results" id="{0b510f2d-e9a8-876c-a0ac-26d1ae3e1b56}">
+        <p14:section name="Models and results" id="{02f5a30a-34cc-a672-8755-55111cebf1f6}">
           <p14:sldIdLst>
             <p14:sldId id="258"/>
             <p14:sldId id="259"/>
             <p14:sldId id="260"/>
           </p14:sldIdLst>
         </p14:section>
-        <p14:section name="LLM experiment" id="{3395c871-3020-264f-34ff-f0d9262b93b6}">
+        <p14:section name="LLM experiment" id="{7f7e13c0-e9bb-25ea-c07b-8f9761b84b7e}">
           <p14:sldIdLst>
             <p14:sldId id="261"/>
             <p14:sldId id="262"/>
           </p14:sldIdLst>
         </p14:section>
-        <p14:section name="Answer and demo" id="{38691d2d-4b6e-75c8-4157-8292e209cee5}">
+        <p14:section name="Answer and demo" id="{4249f3f5-4000-c4c7-da96-d1f3e0658b5f}">
           <p14:sldIdLst>
             <p14:sldId id="263"/>
             <p14:sldId id="264"/>
@@ -5899,7 +5899,7 @@
               <a:t>SPEAKER 4 (1:45)
 So, can AI foundation models beat traditional methods? Our answer: not yet on accuracy, yes on speed. LightGBM, AutoETS and their simple average were the three most accurate. Chronos was the clear winner on speed: ten seconds, no training.
 Our results have limits. First, Claude was tested on a subset, and our blind test can't fully rule out that it saw this public data. Second, sales are not demand: when a shelf is empty, sales show zero even if customers wanted the product.
-And the most important limitation for a business: accuracy isn't the real goal. Ordering stock is a newsvendor problem with two different costs. If you order too little, you lose the margin on every sale you miss; that's the underage cost. If you order too much, unsold food is wasted at its cost; that's the overage cost. Because those costs depend on the margin, the best order isn't the forecast itself but a quantile of demand, and our accuracy metrics treat over- and under-forecasting the same. When we turned each model's forecasts into orders, the profit differences at typical margins were within chance; only at an 80% margin, where running out is expensive, did the more accurate LightGBM earn significantly more.
+And the most important limitation for a business: accuracy isn't the real goal. Ordering stock is a newsvendor problem with two different costs. If you order too little, you lose the margin on every sale you miss; that's the underage cost. If you order too much, unsold food is wasted at its cost; that's the overage cost. Because those costs depend on the margin, the best order isn't the forecast itself but a quantile of demand, and our accuracy metrics treat over- and under-forecasting the same. So what happened when we turned each model's forecasts into actual orders? For most products, it barely mattered which model we used: the profit differences were small enough to be luck. Only for high-margin products, where running out of stock is expensive, did the more accurate model, LightGBM, clearly make more money.
 So our recommendation: average a statistical model like AutoETS with LightGBM, use Chronos where speed or a lack of training data matters, and choose models on the metric that matches the business decision. Our next step is a rolling backtest over several windows.
 Let me show you the business problem in our dashboard.
 TRANSITION: click the screenshot on the next slide.</a:t>

</xml_diff>

<commit_message>
Speaker notes: apply comment edits to the intended words
Co-Authored-By: Claude Opus 5.5 <noreply@anthropic.com>
</commit_message>
<xml_diff>
--- a/presentation/Group3_Forecasting_Presentation.pptx
+++ b/presentation/Group3_Forecasting_Presentation.pptx
@@ -115,26 +115,26 @@
   <p:extLst>
     <p:ext uri="{521415D9-36F7-43E2-AB2F-B90AF26B5E84}">
       <p14:sectionLst xmlns:p14="http://schemas.microsoft.com/office/powerpoint/2010/main">
-        <p14:section name="Question and data" id="{17bfd7a9-f210-6d2d-9e38-07502ce5c1e5}">
+        <p14:section name="Question and data" id="{814245fd-ed35-bb07-ee71-788c4fda35f0}">
           <p14:sldIdLst>
             <p14:sldId id="256"/>
             <p14:sldId id="257"/>
           </p14:sldIdLst>
         </p14:section>
-        <p14:section name="Models and results" id="{02f5a30a-34cc-a672-8755-55111cebf1f6}">
+        <p14:section name="Models and results" id="{dcd63c35-5cdf-58a4-a9b5-99b58e24a387}">
           <p14:sldIdLst>
             <p14:sldId id="258"/>
             <p14:sldId id="259"/>
             <p14:sldId id="260"/>
           </p14:sldIdLst>
         </p14:section>
-        <p14:section name="LLM experiment" id="{7f7e13c0-e9bb-25ea-c07b-8f9761b84b7e}">
+        <p14:section name="LLM experiment" id="{7e591dd5-84b9-0b1d-ee0d-a1ee64871b7c}">
           <p14:sldIdLst>
             <p14:sldId id="261"/>
             <p14:sldId id="262"/>
           </p14:sldIdLst>
         </p14:section>
-        <p14:section name="Answer and demo" id="{4249f3f5-4000-c4c7-da96-d1f3e0658b5f}">
+        <p14:section name="Answer and demo" id="{5a50ec0a-50a5-b94d-61bd-a97f51e3d0db}">
           <p14:sldIdLst>
             <p14:sldId id="263"/>
             <p14:sldId id="264"/>
@@ -5251,7 +5251,7 @@
             <a:r>
               <a:rPr lang="en-US" dirty="0"/>
               <a:t>SPEAKER 1 (0:45)
-Good afternoon, we're Group 3. A retail forecast has three jobs: be accurate, be cheap and fast enough to run every day for thousands of products, and support good stocking decisions. In Walmart's M5 forecasting competition, LightGBM, a machine-learning method, dominated the leaderboard and became the industry default. Since then, AI foundation models, pre-trained on huge datasets, can forecast a product they have never seen, with no training at all. So we ask: can these AI models beat traditional statistical and machine-learning methods, on accuracy and on efficiency?
+Good afternoon, we're Group 3. A retail forecast has three jobs: be accurate, be cheap and fast enough to run every day for thousands of products, and support good stocking decisions. LightGBM, a machine-learning method, dominates this kind of retail data: it dominated Walmart's M5 forecasting competition and became the industry default. Since then, AI foundation models, pre-trained on huge datasets, can forecast a product they have never seen, with no training at all. So we ask: can these AI models beat traditional statistical and machine-learning methods, on accuracy and on efficiency?
 TRANSITION: Here is our data and how we tested.</a:t>
             </a:r>
             <a:endParaRPr lang="en-US" dirty="0"/>
@@ -5436,7 +5436,7 @@
               <a:t>SPEAKER 2 (1:05)
 We compared five models. AutoETS and AutoARIMA are classic time series models: they fit one model to each product's own history, with a weekly cycle.
 LightGBM is the dominant approach for this kind of retail data; it dominated the M5 competition. It is one machine-learning model trained across all products at once, which then predicts each product. It also sees prices, holidays and food-stamp days.
-Chronos is Amazon's pre-trained AI model for time series, trained on about 100 billion data points from energy, traffic, weather and more. It was not trained on M5 or on any retail data, so this is a true zero-shot test. Seasonal naive, 'same weekday last week', is the benchmark.
+Chronos is Amazon's pre-trained AI model for time series, trained on about 100 billion data points from energy, traffic, weather and more. It was not trained on M5 or on any retail data: the Chronos paper lists M5 as a held-out test set. Seasonal naive, 'same weekday last week', is the benchmark.
 We also test the simplest possible combination: an unweighted average of AutoETS and LightGBM. And as an experiment, a second AI joins on a subset of series: Claude, a general-purpose language model, which we'll come back to later. Note that the inputs differ: only LightGBM and Claude see prices and the calendar.
 TRANSITION: So which model is best, and at what? Here's the scorecard.</a:t>
             </a:r>
@@ -5710,7 +5710,7 @@
             <a:r>
               <a:rPr lang="en-US" dirty="0"/>
               <a:t>SPEAKER 3 (1:15)
-Claude is a large language model, the same kind of model as ChatGPT. We used it through its API. For each product, our code sends the past year of daily sales as plain text, one row per day with the date, holidays, food-stamp days and price, plus an instruction: forecast the next 28 days and answer in a fixed format. Claude reads the numbers, reasons about patterns such as weekends and holidays, and sends back 28 daily forecasts with a short explanation. No statistical model is fitted; it works from what it learned in training.
+Now a generalist AI. We used Claude through its API. For each product, our code sends the past year of daily sales as plain text, one row per day with the date, holidays, food-stamp days and price, plus an instruction: forecast the next 28 days and answer in a fixed format. Claude reads the numbers, reasons about patterns such as weekends and holidays, and sends back 28 daily forecasts with a short explanation. No statistical model is fitted; it works from what it learned in training.
 Each request costs money and takes a few seconds, so to keep the cost down we used a subset instead of all 5,748 series: 100 randomly chosen products and the 12 store-by-department totals. Every other model was scored on exactly the same series, and to keep it fair, the other models were also fitted directly on those totals.
 How did it perform? On the store totals, very well: it matched our best traditional forecast, the AutoETS-plus-LightGBM average, and beat every single model, including Chronos. On individual products it was in the pack, behind AutoETS and AutoARIMA. So the generalist AI was more accurate than the specialist one, but far slower and more costly to run at scale.
 POINT AT: the Claude bars at the top of the chart, then the comparison table.
@@ -5897,7 +5897,7 @@
             <a:r>
               <a:rPr lang="en-US" dirty="0"/>
               <a:t>SPEAKER 4 (1:45)
-So, can AI foundation models beat traditional methods? Our answer: not yet on accuracy, yes on speed. LightGBM, AutoETS and their simple average were the three most accurate. Chronos was the clear winner on speed: ten seconds, no training.
+So, can AI foundation models beat traditional methods? Our answer: not yet on accuracy, yes on speed. LightGBM, AutoETS and their simple average were the three most accurate. Chronos was the clear winner on speed: ten seconds, no training. And Claude matched the best traditional approach on store totals.
 Our results have limits. First, Claude was tested on a subset, and our blind test can't fully rule out that it saw this public data. Second, sales are not demand: when a shelf is empty, sales show zero even if customers wanted the product.
 And the most important limitation for a business: accuracy isn't the real goal. Ordering stock is a newsvendor problem with two different costs. If you order too little, you lose the margin on every sale you miss; that's the underage cost. If you order too much, unsold food is wasted at its cost; that's the overage cost. Because those costs depend on the margin, the best order isn't the forecast itself but a quantile of demand, and our accuracy metrics treat over- and under-forecasting the same. So what happened when we turned each model's forecasts into actual orders? For most products, it barely mattered which model we used: the profit differences were small enough to be luck. Only for high-margin products, where running out of stock is expensive, did the more accurate model, LightGBM, clearly make more money.
 So our recommendation: average a statistical model like AutoETS with LightGBM, use Chronos where speed or a lack of training data matters, and choose models on the metric that matches the business decision. Our next step is a rolling backtest over several windows.

</xml_diff>

<commit_message>
Script and notes: drop references to the M5 competition
Co-Authored-By: Claude Opus 5.5 <noreply@anthropic.com>
</commit_message>
<xml_diff>
--- a/presentation/Group3_Forecasting_Presentation.pptx
+++ b/presentation/Group3_Forecasting_Presentation.pptx
@@ -115,26 +115,26 @@
   <p:extLst>
     <p:ext uri="{521415D9-36F7-43E2-AB2F-B90AF26B5E84}">
       <p14:sectionLst xmlns:p14="http://schemas.microsoft.com/office/powerpoint/2010/main">
-        <p14:section name="Question and data" id="{814245fd-ed35-bb07-ee71-788c4fda35f0}">
+        <p14:section name="Question and data" id="{eaf7f357-9fc7-484a-c2c6-1003b8a4f384}">
           <p14:sldIdLst>
             <p14:sldId id="256"/>
             <p14:sldId id="257"/>
           </p14:sldIdLst>
         </p14:section>
-        <p14:section name="Models and results" id="{dcd63c35-5cdf-58a4-a9b5-99b58e24a387}">
+        <p14:section name="Models and results" id="{875b4557-6ecd-ee48-5c63-f9b78f9726df}">
           <p14:sldIdLst>
             <p14:sldId id="258"/>
             <p14:sldId id="259"/>
             <p14:sldId id="260"/>
           </p14:sldIdLst>
         </p14:section>
-        <p14:section name="LLM experiment" id="{7e591dd5-84b9-0b1d-ee0d-a1ee64871b7c}">
+        <p14:section name="LLM experiment" id="{d17969de-74fc-ac83-11a5-5301cf009a46}">
           <p14:sldIdLst>
             <p14:sldId id="261"/>
             <p14:sldId id="262"/>
           </p14:sldIdLst>
         </p14:section>
-        <p14:section name="Answer and demo" id="{5a50ec0a-50a5-b94d-61bd-a97f51e3d0db}">
+        <p14:section name="Answer and demo" id="{a425c7d5-a933-40dd-0bba-b9c262c1fcb1}">
           <p14:sldIdLst>
             <p14:sldId id="263"/>
             <p14:sldId id="264"/>
@@ -5251,7 +5251,7 @@
             <a:r>
               <a:rPr lang="en-US" dirty="0"/>
               <a:t>SPEAKER 1 (0:45)
-Good afternoon, we're Group 3. A retail forecast has three jobs: be accurate, be cheap and fast enough to run every day for thousands of products, and support good stocking decisions. LightGBM, a machine-learning method, dominates this kind of retail data: it dominated Walmart's M5 forecasting competition and became the industry default. Since then, AI foundation models, pre-trained on huge datasets, can forecast a product they have never seen, with no training at all. So we ask: can these AI models beat traditional statistical and machine-learning methods, on accuracy and on efficiency?
+Good afternoon, we're Group 3. A retail forecast has three jobs: be accurate, be cheap and fast enough to run every day for thousands of products, and support good stocking decisions. LightGBM, a machine-learning method, dominates this kind of retail data and has become the industry default. Since then, AI foundation models, pre-trained on huge datasets, can forecast a product they have never seen, with no training at all. So we ask: can these AI models beat traditional statistical and machine-learning methods, on accuracy and on efficiency?
 TRANSITION: Here is our data and how we tested.</a:t>
             </a:r>
             <a:endParaRPr lang="en-US" dirty="0"/>
@@ -5344,7 +5344,7 @@
 We used Walmart's M5 data: all 1,437 food items in four California stores, so 5,748 daily series, each one item in one store, from 2011 to 2016.
 Every model trains on data up to May 22, 2016, and forecasts the next 28 days, the official M5 test window, which no model sees. The one model we tuned, LightGBM, was tuned only on the last 28 training days.
 Three features make this data hard. Sales follow a weekly rhythm: weekends sell about 20% above an average day. Food-stamp payment days add about 10%. And demand is sparse: the typical item sells nothing on half of all days.
-We score accuracy with WRMSSE, the competition's own metric: it scales each product's error by how hard it is to forecast and weights it by dollar sales. Lower is better, and below one beats a naive forecast. One caveat up front: this is a single 28-day window.
+We score accuracy with WRMSSE, the official M5 metric: it scales each product's error by how hard it is to forecast and weights it by dollar sales. Lower is better, and below one beats a naive forecast. One caveat up front: this is a single 28-day window.
 TRANSITION: Speaker 2 will introduce the models.</a:t>
             </a:r>
             <a:endParaRPr lang="en-US" dirty="0"/>
@@ -5435,7 +5435,7 @@
               <a:rPr lang="en-US" dirty="0"/>
               <a:t>SPEAKER 2 (1:05)
 We compared five models. AutoETS and AutoARIMA are classic time series models: they fit one model to each product's own history, with a weekly cycle.
-LightGBM is the dominant approach for this kind of retail data; it dominated the M5 competition. It is one machine-learning model trained across all products at once, which then predicts each product. It also sees prices, holidays and food-stamp days.
+LightGBM is the dominant approach for this kind of retail data. It is one machine-learning model trained across all products at once, which then predicts each product. It also sees prices, holidays and food-stamp days.
 Chronos is Amazon's pre-trained AI model for time series, trained on about 100 billion data points from energy, traffic, weather and more. It was not trained on M5 or on any retail data: the Chronos paper lists M5 as a held-out test set. Seasonal naive, 'same weekday last week', is the benchmark.
 We also test the simplest possible combination: an unweighted average of AutoETS and LightGBM. And as an experiment, a second AI joins on a subset of series: Claude, a general-purpose language model, which we'll come back to later. Note that the inputs differ: only LightGBM and Claude see prices and the calendar.
 TRANSITION: So which model is best, and at what? Here's the scorecard.</a:t>

</xml_diff>

<commit_message>
Chronos training data: say M5 and retail sets were held out, not 'no retail data'
Co-Authored-By: Claude Opus 5.5 <noreply@anthropic.com>
</commit_message>
<xml_diff>
--- a/presentation/Group3_Forecasting_Presentation.pptx
+++ b/presentation/Group3_Forecasting_Presentation.pptx
@@ -115,26 +115,26 @@
   <p:extLst>
     <p:ext uri="{521415D9-36F7-43E2-AB2F-B90AF26B5E84}">
       <p14:sectionLst xmlns:p14="http://schemas.microsoft.com/office/powerpoint/2010/main">
-        <p14:section name="Question and data" id="{eaf7f357-9fc7-484a-c2c6-1003b8a4f384}">
+        <p14:section name="Question and data" id="{1c509e01-e116-db33-df59-d40fa1cea936}">
           <p14:sldIdLst>
             <p14:sldId id="256"/>
             <p14:sldId id="257"/>
           </p14:sldIdLst>
         </p14:section>
-        <p14:section name="Models and results" id="{875b4557-6ecd-ee48-5c63-f9b78f9726df}">
+        <p14:section name="Models and results" id="{2af02e65-fb66-f5bf-ad2c-d1865758ff53}">
           <p14:sldIdLst>
             <p14:sldId id="258"/>
             <p14:sldId id="259"/>
             <p14:sldId id="260"/>
           </p14:sldIdLst>
         </p14:section>
-        <p14:section name="LLM experiment" id="{d17969de-74fc-ac83-11a5-5301cf009a46}">
+        <p14:section name="LLM experiment" id="{cbe3d561-e653-f0d9-7b82-d44853e6e947}">
           <p14:sldIdLst>
             <p14:sldId id="261"/>
             <p14:sldId id="262"/>
           </p14:sldIdLst>
         </p14:section>
-        <p14:section name="Answer and demo" id="{a425c7d5-a933-40dd-0bba-b9c262c1fcb1}">
+        <p14:section name="Answer and demo" id="{632ff50d-4a2f-9119-6108-1f3791fad0ab}">
           <p14:sldIdLst>
             <p14:sldId id="263"/>
             <p14:sldId id="264"/>
@@ -5436,7 +5436,7 @@
               <a:t>SPEAKER 2 (1:05)
 We compared five models. AutoETS and AutoARIMA are classic time series models: they fit one model to each product's own history, with a weekly cycle.
 LightGBM is the dominant approach for this kind of retail data. It is one machine-learning model trained across all products at once, which then predicts each product. It also sees prices, holidays and food-stamp days.
-Chronos is Amazon's pre-trained AI model for time series, trained on about 100 billion data points from energy, traffic, weather and more. It was not trained on M5 or on any retail data: the Chronos paper lists M5 as a held-out test set. Seasonal naive, 'same weekday last week', is the benchmark.
+Chronos is Amazon's pre-trained AI model for time series, trained on about 100 billion data points from energy, traffic, weather and more. It was not trained on our data: the Chronos paper keeps M5, and every retail dataset it uses, out of training as held-out tests. Seasonal naive, 'same weekday last week', is the benchmark.
 We also test the simplest possible combination: an unweighted average of AutoETS and LightGBM. And as an experiment, a second AI joins on a subset of series: Claude, a general-purpose language model, which we'll come back to later. Note that the inputs differ: only LightGBM and Claude see prices and the calendar.
 TRANSITION: So which model is best, and at what? Here's the scorecard.</a:t>
             </a:r>

</xml_diff>

<commit_message>
Slide 4 notes: explain RMSSE/WRMSSE, smaller is better
Co-Authored-By: Claude Opus 5.5 <noreply@anthropic.com>
</commit_message>
<xml_diff>
--- a/presentation/Group3_Forecasting_Presentation.pptx
+++ b/presentation/Group3_Forecasting_Presentation.pptx
@@ -115,26 +115,26 @@
   <p:extLst>
     <p:ext uri="{521415D9-36F7-43E2-AB2F-B90AF26B5E84}">
       <p14:sectionLst xmlns:p14="http://schemas.microsoft.com/office/powerpoint/2010/main">
-        <p14:section name="Question and data" id="{1c509e01-e116-db33-df59-d40fa1cea936}">
+        <p14:section name="Question and data" id="{86244d65-bdae-3efd-d44d-1a7d432090f6}">
           <p14:sldIdLst>
             <p14:sldId id="256"/>
             <p14:sldId id="257"/>
           </p14:sldIdLst>
         </p14:section>
-        <p14:section name="Models and results" id="{2af02e65-fb66-f5bf-ad2c-d1865758ff53}">
+        <p14:section name="Models and results" id="{9667a602-e17c-4fc8-f5e3-e665bcdd8202}">
           <p14:sldIdLst>
             <p14:sldId id="258"/>
             <p14:sldId id="259"/>
             <p14:sldId id="260"/>
           </p14:sldIdLst>
         </p14:section>
-        <p14:section name="LLM experiment" id="{cbe3d561-e653-f0d9-7b82-d44853e6e947}">
+        <p14:section name="LLM experiment" id="{1b072fb9-91c5-7b71-6132-717e86a39455}">
           <p14:sldIdLst>
             <p14:sldId id="261"/>
             <p14:sldId id="262"/>
           </p14:sldIdLst>
         </p14:section>
-        <p14:section name="Answer and demo" id="{632ff50d-4a2f-9119-6108-1f3791fad0ab}">
+        <p14:section name="Answer and demo" id="{b166d616-ad74-56f4-17bc-d3aac4dde18d}">
           <p14:sldIdLst>
             <p14:sldId id="263"/>
             <p14:sldId id="264"/>
@@ -5527,7 +5527,7 @@
             <a:r>
               <a:rPr lang="en-US" dirty="0"/>
               <a:t>SPEAKER 2 (1:00)
-Here is the scorecard: traditional models against AI, on four questions. Who is most accurate overall? A traditional model: the simple average of AutoETS and LightGBM, with LightGBM alone second and AutoETS close behind. Who forecasts store totals best? Again the traditional models. For single products? It's close, and there the AI is level with LightGBM. And who is fastest? The AI, Chronos, by far: seconds instead of minutes, with no training at all.
+Here is the scorecard: traditional models against AI, on four questions. First, how to read it: RMSSE measures how big a model's errors are compared with a naive "same as yesterday" forecast on the same product, and WRMSSE combines that across all products, weighted by dollar sales. Store totals show the average daily percentage error. In every accuracy column, smaller is better. Who is most accurate overall? A traditional model: the simple average of AutoETS and LightGBM, with LightGBM alone second and AutoETS close behind. Who forecasts store totals best? Again the traditional models. For single products? It's close, and there the AI is level with LightGBM. And who is fastest? The AI, Chronos, by far: seconds instead of minutes, with no training at all.
 So from a traditional point of view, the best choice is the AutoETS-plus-LightGBM average, and the AI's real strength is speed. The green cells show the winner of each column.
 POINT AT: the green cells, column by column.
 TRANSITION: Let's see what those forecasts actually look like.</a:t>

</xml_diff>

<commit_message>
Slide 4 notes: smoother scorecard script
Co-Authored-By: Claude Opus 5.5 <noreply@anthropic.com>
</commit_message>
<xml_diff>
--- a/presentation/Group3_Forecasting_Presentation.pptx
+++ b/presentation/Group3_Forecasting_Presentation.pptx
@@ -115,26 +115,26 @@
   <p:extLst>
     <p:ext uri="{521415D9-36F7-43E2-AB2F-B90AF26B5E84}">
       <p14:sectionLst xmlns:p14="http://schemas.microsoft.com/office/powerpoint/2010/main">
-        <p14:section name="Question and data" id="{86244d65-bdae-3efd-d44d-1a7d432090f6}">
+        <p14:section name="Question and data" id="{e53d33f4-aa6c-5c90-3469-f815ff60a652}">
           <p14:sldIdLst>
             <p14:sldId id="256"/>
             <p14:sldId id="257"/>
           </p14:sldIdLst>
         </p14:section>
-        <p14:section name="Models and results" id="{9667a602-e17c-4fc8-f5e3-e665bcdd8202}">
+        <p14:section name="Models and results" id="{2a24e641-66d8-7f25-ab56-c58e4180f592}">
           <p14:sldIdLst>
             <p14:sldId id="258"/>
             <p14:sldId id="259"/>
             <p14:sldId id="260"/>
           </p14:sldIdLst>
         </p14:section>
-        <p14:section name="LLM experiment" id="{1b072fb9-91c5-7b71-6132-717e86a39455}">
+        <p14:section name="LLM experiment" id="{314b57f1-0173-6e32-7d28-fdec6243a08e}">
           <p14:sldIdLst>
             <p14:sldId id="261"/>
             <p14:sldId id="262"/>
           </p14:sldIdLst>
         </p14:section>
-        <p14:section name="Answer and demo" id="{b166d616-ad74-56f4-17bc-d3aac4dde18d}">
+        <p14:section name="Answer and demo" id="{396e6b55-ff42-ee61-db58-567f5c5d19cf}">
           <p14:sldIdLst>
             <p14:sldId id="263"/>
             <p14:sldId id="264"/>
@@ -5527,7 +5527,7 @@
             <a:r>
               <a:rPr lang="en-US" dirty="0"/>
               <a:t>SPEAKER 2 (1:00)
-Here is the scorecard: traditional models against AI, on four questions. First, how to read it: RMSSE measures how big a model's errors are compared with a naive "same as yesterday" forecast on the same product, and WRMSSE combines that across all products, weighted by dollar sales. Store totals show the average daily percentage error. In every accuracy column, smaller is better. Who is most accurate overall? A traditional model: the simple average of AutoETS and LightGBM, with LightGBM alone second and AutoETS close behind. Who forecasts store totals best? Again the traditional models. For single products? It's close, and there the AI is level with LightGBM. And who is fastest? The AI, Chronos, by far: seconds instead of minutes, with no training at all.
+Here is the comparison: traditional models against AI, on four questions. A quick guide first. RMSSE compares a model's errors with a naive "same as yesterday" forecast for the same product, and WRMSSE combines that score across all products, weighted by dollar sales. The store-totals column is the average daily percentage error. In every accuracy column, smaller is better. So, who is most accurate overall? A traditional model: the simple average of AutoETS and LightGBM, with LightGBM alone in second. Who forecasts store totals best? Again, the traditional models. For single products, it's close, and the AI is level with LightGBM. And who is fastest? The AI, Chronos, by far: seconds instead of minutes, with no training at all.
 So from a traditional point of view, the best choice is the AutoETS-plus-LightGBM average, and the AI's real strength is speed. The green cells show the winner of each column.
 POINT AT: the green cells, column by column.
 TRANSITION: Let's see what those forecasts actually look like.</a:t>

</xml_diff>

<commit_message>
Slide 4: add how-to-read note for RMSSE/WRMSSE
Co-Authored-By: Claude Opus 5.5 <noreply@anthropic.com>
</commit_message>
<xml_diff>
--- a/presentation/Group3_Forecasting_Presentation.pptx
+++ b/presentation/Group3_Forecasting_Presentation.pptx
@@ -115,26 +115,26 @@
   <p:extLst>
     <p:ext uri="{521415D9-36F7-43E2-AB2F-B90AF26B5E84}">
       <p14:sectionLst xmlns:p14="http://schemas.microsoft.com/office/powerpoint/2010/main">
-        <p14:section name="Question and data" id="{e53d33f4-aa6c-5c90-3469-f815ff60a652}">
+        <p14:section name="Question and data" id="{53d658e8-032e-bfa3-1dee-736d2dd5e3a0}">
           <p14:sldIdLst>
             <p14:sldId id="256"/>
             <p14:sldId id="257"/>
           </p14:sldIdLst>
         </p14:section>
-        <p14:section name="Models and results" id="{2a24e641-66d8-7f25-ab56-c58e4180f592}">
+        <p14:section name="Models and results" id="{738f4158-b3ec-3b77-7d7b-e7fce3672d0b}">
           <p14:sldIdLst>
             <p14:sldId id="258"/>
             <p14:sldId id="259"/>
             <p14:sldId id="260"/>
           </p14:sldIdLst>
         </p14:section>
-        <p14:section name="LLM experiment" id="{314b57f1-0173-6e32-7d28-fdec6243a08e}">
+        <p14:section name="LLM experiment" id="{e99b4665-1e7f-9a6d-de67-77a79cb0d6c5}">
           <p14:sldIdLst>
             <p14:sldId id="261"/>
             <p14:sldId id="262"/>
           </p14:sldIdLst>
         </p14:section>
-        <p14:section name="Answer and demo" id="{396e6b55-ff42-ee61-db58-567f5c5d19cf}">
+        <p14:section name="Answer and demo" id="{a0d8a2d8-cadc-8722-f0c3-bdccfdd014a5}">
           <p14:sldIdLst>
             <p14:sldId id="263"/>
             <p14:sldId id="264"/>
@@ -13011,12 +13011,12 @@
         </p:nvSpPr>
         <p:spPr>
           <a:xfrm>
-            <a:off x="548640" y="5486400"/>
-            <a:ext cx="11064240" cy="731520"/>
+            <a:off x="548640" y="5349240"/>
+            <a:ext cx="11064240" cy="960120"/>
           </a:xfrm>
           <a:prstGeom prst="roundRect">
             <a:avLst>
-              <a:gd name="adj" fmla="val 15000"/>
+              <a:gd name="adj" fmla="val 11429"/>
             </a:avLst>
           </a:prstGeom>
           <a:solidFill>
@@ -13038,8 +13038,8 @@
         </p:nvSpPr>
         <p:spPr>
           <a:xfrm>
-            <a:off x="822960" y="5486400"/>
-            <a:ext cx="10607040" cy="731520"/>
+            <a:off x="822960" y="5349240"/>
+            <a:ext cx="10607040" cy="960120"/>
           </a:xfrm>
           <a:prstGeom prst="rect">
             <a:avLst/>
@@ -13052,6 +13052,40 @@
           <a:lstStyle/>
           <a:p>
             <a:pPr indent="0" marL="0">
+              <a:spcAft>
+                <a:spcPts val="400"/>
+              </a:spcAft>
+              <a:buNone/>
+            </a:pPr>
+            <a:r>
+              <a:rPr lang="en-US" sz="1400" b="1" dirty="0">
+                <a:solidFill>
+                  <a:srgbClr val="1F2328"/>
+                </a:solidFill>
+              </a:rPr>
+              <a:t>How to read: </a:t>
+            </a:r>
+            <a:pPr indent="0" marL="0">
+              <a:spcAft>
+                <a:spcPts val="400"/>
+              </a:spcAft>
+              <a:buNone/>
+            </a:pPr>
+            <a:r>
+              <a:rPr lang="en-US" sz="1400" dirty="0">
+                <a:solidFill>
+                  <a:schemeClr val="tx1"/>
+                </a:solidFill>
+              </a:rPr>
+              <a:t>RMSSE = error vs a naive “same as yesterday” forecast; WRMSSE = RMSSE weighted by dollar sales. Smaller is better.</a:t>
+            </a:r>
+            <a:endParaRPr lang="en-US" sz="1400" dirty="0"/>
+          </a:p>
+          <a:p>
+            <a:pPr indent="0" marL="0">
+              <a:spcAft>
+                <a:spcPts val="400"/>
+              </a:spcAft>
               <a:buNone/>
             </a:pPr>
             <a:r>
@@ -13063,6 +13097,9 @@
               <a:t>Best traditional choice: </a:t>
             </a:r>
             <a:pPr indent="0" marL="0">
+              <a:spcAft>
+                <a:spcPts val="400"/>
+              </a:spcAft>
               <a:buNone/>
             </a:pPr>
             <a:r>
@@ -13074,6 +13111,9 @@
               <a:t>the AutoETS + LightGBM average, for accuracy.   </a:t>
             </a:r>
             <a:pPr indent="0" marL="0">
+              <a:spcAft>
+                <a:spcPts val="400"/>
+              </a:spcAft>
               <a:buNone/>
             </a:pPr>
             <a:r>
@@ -13085,6 +13125,9 @@
               <a:t>Best AI strength: </a:t>
             </a:r>
             <a:pPr indent="0" marL="0">
+              <a:spcAft>
+                <a:spcPts val="400"/>
+              </a:spcAft>
               <a:buNone/>
             </a:pPr>
             <a:r>

</xml_diff>

<commit_message>
Slide 4 notes: explain the time column
Co-Authored-By: Claude Opus 5.5 <noreply@anthropic.com>
</commit_message>
<xml_diff>
--- a/presentation/Group3_Forecasting_Presentation.pptx
+++ b/presentation/Group3_Forecasting_Presentation.pptx
@@ -115,26 +115,26 @@
   <p:extLst>
     <p:ext uri="{521415D9-36F7-43E2-AB2F-B90AF26B5E84}">
       <p14:sectionLst xmlns:p14="http://schemas.microsoft.com/office/powerpoint/2010/main">
-        <p14:section name="Question and data" id="{53d658e8-032e-bfa3-1dee-736d2dd5e3a0}">
+        <p14:section name="Question and data" id="{90e84c1e-d90a-5f42-854d-93dafce27ef3}">
           <p14:sldIdLst>
             <p14:sldId id="256"/>
             <p14:sldId id="257"/>
           </p14:sldIdLst>
         </p14:section>
-        <p14:section name="Models and results" id="{738f4158-b3ec-3b77-7d7b-e7fce3672d0b}">
+        <p14:section name="Models and results" id="{34379a67-6d61-ffaf-2956-4f548a727d1f}">
           <p14:sldIdLst>
             <p14:sldId id="258"/>
             <p14:sldId id="259"/>
             <p14:sldId id="260"/>
           </p14:sldIdLst>
         </p14:section>
-        <p14:section name="LLM experiment" id="{e99b4665-1e7f-9a6d-de67-77a79cb0d6c5}">
+        <p14:section name="LLM experiment" id="{344b8a3e-bad3-0ebb-7670-72674a92d8aa}">
           <p14:sldIdLst>
             <p14:sldId id="261"/>
             <p14:sldId id="262"/>
           </p14:sldIdLst>
         </p14:section>
-        <p14:section name="Answer and demo" id="{a0d8a2d8-cadc-8722-f0c3-bdccfdd014a5}">
+        <p14:section name="Answer and demo" id="{34afb983-6575-f2c4-f1cb-fb50e408efa2}">
           <p14:sldIdLst>
             <p14:sldId id="263"/>
             <p14:sldId id="264"/>
@@ -5527,7 +5527,7 @@
             <a:r>
               <a:rPr lang="en-US" dirty="0"/>
               <a:t>SPEAKER 2 (1:00)
-Here is the comparison: traditional models against AI, on four questions. A quick guide first. RMSSE compares a model's errors with a naive "same as yesterday" forecast for the same product, and WRMSSE combines that score across all products, weighted by dollar sales. The store-totals column is the average daily percentage error. In every accuracy column, smaller is better. So, who is most accurate overall? A traditional model: the simple average of AutoETS and LightGBM, with LightGBM alone in second. Who forecasts store totals best? Again, the traditional models. For single products, it's close, and the AI is level with LightGBM. And who is fastest? The AI, Chronos, by far: seconds instead of minutes, with no training at all.
+Here is the comparison: traditional models against AI, on four questions. A quick guide first. RMSSE compares a model's errors with a naive "same as yesterday" forecast for the same product, and WRMSSE combines that score across all products, weighted by dollar sales. The store-totals column is the average daily percentage error. In every accuracy column, smaller is better. And the time column is how long each model takes to produce the whole forecast for all 5,748 products, including any training. So, who is most accurate overall? A traditional model: the simple average of AutoETS and LightGBM, with LightGBM alone in second. Who forecasts store totals best? Again, the traditional models. For single products, it's close, and the AI is level with LightGBM. And who is fastest? The AI, Chronos, by far: seconds instead of minutes, with no training at all.
 So from a traditional point of view, the best choice is the AutoETS-plus-LightGBM average, and the AI's real strength is speed. The green cells show the winner of each column.
 POINT AT: the green cells, column by column.
 TRANSITION: Let's see what those forecasts actually look like.</a:t>

</xml_diff>

<commit_message>
Slide 4 notes: fold time-column explanation into the speed answer
Co-Authored-By: Claude Opus 5.5 <noreply@anthropic.com>
</commit_message>
<xml_diff>
--- a/presentation/Group3_Forecasting_Presentation.pptx
+++ b/presentation/Group3_Forecasting_Presentation.pptx
@@ -115,26 +115,26 @@
   <p:extLst>
     <p:ext uri="{521415D9-36F7-43E2-AB2F-B90AF26B5E84}">
       <p14:sectionLst xmlns:p14="http://schemas.microsoft.com/office/powerpoint/2010/main">
-        <p14:section name="Question and data" id="{90e84c1e-d90a-5f42-854d-93dafce27ef3}">
+        <p14:section name="Question and data" id="{47c9ad14-8771-b9a7-447f-13ff01c06916}">
           <p14:sldIdLst>
             <p14:sldId id="256"/>
             <p14:sldId id="257"/>
           </p14:sldIdLst>
         </p14:section>
-        <p14:section name="Models and results" id="{34379a67-6d61-ffaf-2956-4f548a727d1f}">
+        <p14:section name="Models and results" id="{6fe48b8e-66a5-538f-3153-4dfd6ed928a1}">
           <p14:sldIdLst>
             <p14:sldId id="258"/>
             <p14:sldId id="259"/>
             <p14:sldId id="260"/>
           </p14:sldIdLst>
         </p14:section>
-        <p14:section name="LLM experiment" id="{344b8a3e-bad3-0ebb-7670-72674a92d8aa}">
+        <p14:section name="LLM experiment" id="{1a17eb9f-3b20-4867-ccc8-414550b20564}">
           <p14:sldIdLst>
             <p14:sldId id="261"/>
             <p14:sldId id="262"/>
           </p14:sldIdLst>
         </p14:section>
-        <p14:section name="Answer and demo" id="{34afb983-6575-f2c4-f1cb-fb50e408efa2}">
+        <p14:section name="Answer and demo" id="{7d3e7747-2096-cdd9-0c2d-41869fc34b27}">
           <p14:sldIdLst>
             <p14:sldId id="263"/>
             <p14:sldId id="264"/>
@@ -5527,7 +5527,7 @@
             <a:r>
               <a:rPr lang="en-US" dirty="0"/>
               <a:t>SPEAKER 2 (1:00)
-Here is the comparison: traditional models against AI, on four questions. A quick guide first. RMSSE compares a model's errors with a naive "same as yesterday" forecast for the same product, and WRMSSE combines that score across all products, weighted by dollar sales. The store-totals column is the average daily percentage error. In every accuracy column, smaller is better. And the time column is how long each model takes to produce the whole forecast for all 5,748 products, including any training. So, who is most accurate overall? A traditional model: the simple average of AutoETS and LightGBM, with LightGBM alone in second. Who forecasts store totals best? Again, the traditional models. For single products, it's close, and the AI is level with LightGBM. And who is fastest? The AI, Chronos, by far: seconds instead of minutes, with no training at all.
+Here is the comparison: traditional models against AI, on four questions. A quick guide first. RMSSE compares a model's errors with a naive "same as yesterday" forecast for the same product, and WRMSSE combines that score across all products, weighted by dollar sales. The store-totals column is the average daily percentage error. In every accuracy column, smaller is better. So, who is most accurate overall? A traditional model: the simple average of AutoETS and LightGBM, with LightGBM alone in second. Who forecasts store totals best? Again, the traditional models. For single products, it's close, and the AI is level with LightGBM. Finally, speed. The time column shows how long each model takes to produce the whole forecast for all 5,748 products, training included. Here the AI, Chronos, wins by far: seconds instead of minutes, because it needs no training at all.
 So from a traditional point of view, the best choice is the AutoETS-plus-LightGBM average, and the AI's real strength is speed. The green cells show the winner of each column.
 POINT AT: the green cells, column by column.
 TRANSITION: Let's see what those forecasts actually look like.</a:t>

</xml_diff>

<commit_message>
Slide 5 notes: explain why Chronos has the right shape but runs low
Co-Authored-By: Claude Opus 5.5 <noreply@anthropic.com>
</commit_message>
<xml_diff>
--- a/presentation/Group3_Forecasting_Presentation.pptx
+++ b/presentation/Group3_Forecasting_Presentation.pptx
@@ -115,26 +115,26 @@
   <p:extLst>
     <p:ext uri="{521415D9-36F7-43E2-AB2F-B90AF26B5E84}">
       <p14:sectionLst xmlns:p14="http://schemas.microsoft.com/office/powerpoint/2010/main">
-        <p14:section name="Question and data" id="{47c9ad14-8771-b9a7-447f-13ff01c06916}">
+        <p14:section name="Question and data" id="{9e7a9fb7-27e4-b9d6-7199-e837d19afda5}">
           <p14:sldIdLst>
             <p14:sldId id="256"/>
             <p14:sldId id="257"/>
           </p14:sldIdLst>
         </p14:section>
-        <p14:section name="Models and results" id="{6fe48b8e-66a5-538f-3153-4dfd6ed928a1}">
+        <p14:section name="Models and results" id="{3385542a-971d-6fbf-07cf-b532a7127659}">
           <p14:sldIdLst>
             <p14:sldId id="258"/>
             <p14:sldId id="259"/>
             <p14:sldId id="260"/>
           </p14:sldIdLst>
         </p14:section>
-        <p14:section name="LLM experiment" id="{1a17eb9f-3b20-4867-ccc8-414550b20564}">
+        <p14:section name="LLM experiment" id="{6cc2c8cd-8552-879f-12d6-9b8663e5276d}">
           <p14:sldIdLst>
             <p14:sldId id="261"/>
             <p14:sldId id="262"/>
           </p14:sldIdLst>
         </p14:section>
-        <p14:section name="Answer and demo" id="{7d3e7747-2096-cdd9-0c2d-41869fc34b27}">
+        <p14:section name="Answer and demo" id="{1447456d-0ac1-76f1-819f-78415044b6db}">
           <p14:sldIdLst>
             <p14:sldId id="263"/>
             <p14:sldId id="264"/>
@@ -5620,7 +5620,7 @@
               <a:rPr lang="en-US" dirty="0"/>
               <a:t>SPEAKER 2 (1:00)
 Here's what that looks like. The black line is actual daily sales across all four stores during the test month. The traditional average, in teal, rises and falls with every weekend peak. AutoARIMA, in green, is almost flat, and Chronos, in orange, has the right shape but sits too low.
-Why? AutoARIMA and Chronos look at one product at a time. For a product that sells a unit or two a day, the best guess is a flat line, and thousands of flat lines added up miss the weekend. LightGBM learns from all products together, so it sees the weekend rush, and averaging it with AutoETS smooths out the rest. Zoom into a single product, though, and the lines come together: one product's daily sales are mostly noise.
+Why? AutoARIMA and Chronos look at one product at a time. For a product that sells a unit or two a day, the best guess is a flat line, and thousands of flat lines added up miss the weekend. Chronos does pick up the weekly rhythm in busier products, so its total has the right shape. But it predicts the typical day, and for sparse products the typical day sells less than the average day, so each forecast is a little low, and across thousands of products that adds up to a total about 11% too low. LightGBM learns from all products together, so it sees the weekend rush, and averaging it with AutoETS smooths out the rest. Zoom into a single product, though, and the lines come together: one product's daily sales are mostly noise.
 TRANSITION: So the specialist AI is fast but less accurate. What about a generalist AI that reads and reasons? Speaker 3.</a:t>
             </a:r>
             <a:endParaRPr lang="en-US" dirty="0"/>

</xml_diff>

<commit_message>
Slide 5 notes: Chronos follows weekly pattern; low level from sparse items
Co-Authored-By: Claude Opus 5.5 <noreply@anthropic.com>
</commit_message>
<xml_diff>
--- a/presentation/Group3_Forecasting_Presentation.pptx
+++ b/presentation/Group3_Forecasting_Presentation.pptx
@@ -115,26 +115,26 @@
   <p:extLst>
     <p:ext uri="{521415D9-36F7-43E2-AB2F-B90AF26B5E84}">
       <p14:sectionLst xmlns:p14="http://schemas.microsoft.com/office/powerpoint/2010/main">
-        <p14:section name="Question and data" id="{9e7a9fb7-27e4-b9d6-7199-e837d19afda5}">
+        <p14:section name="Question and data" id="{c087666b-7c0e-a4d9-07ae-e1b01e445943}">
           <p14:sldIdLst>
             <p14:sldId id="256"/>
             <p14:sldId id="257"/>
           </p14:sldIdLst>
         </p14:section>
-        <p14:section name="Models and results" id="{3385542a-971d-6fbf-07cf-b532a7127659}">
+        <p14:section name="Models and results" id="{64eb1f95-21db-e24a-42a3-0b770329c524}">
           <p14:sldIdLst>
             <p14:sldId id="258"/>
             <p14:sldId id="259"/>
             <p14:sldId id="260"/>
           </p14:sldIdLst>
         </p14:section>
-        <p14:section name="LLM experiment" id="{6cc2c8cd-8552-879f-12d6-9b8663e5276d}">
+        <p14:section name="LLM experiment" id="{d924980a-6fcb-c937-4966-9e9bb5fb680b}">
           <p14:sldIdLst>
             <p14:sldId id="261"/>
             <p14:sldId id="262"/>
           </p14:sldIdLst>
         </p14:section>
-        <p14:section name="Answer and demo" id="{1447456d-0ac1-76f1-819f-78415044b6db}">
+        <p14:section name="Answer and demo" id="{20b0d37f-7379-6074-1e0b-d46f4453a8c5}">
           <p14:sldIdLst>
             <p14:sldId id="263"/>
             <p14:sldId id="264"/>
@@ -5620,7 +5620,7 @@
               <a:rPr lang="en-US" dirty="0"/>
               <a:t>SPEAKER 2 (1:00)
 Here's what that looks like. The black line is actual daily sales across all four stores during the test month. The traditional average, in teal, rises and falls with every weekend peak. AutoARIMA, in green, is almost flat, and Chronos, in orange, has the right shape but sits too low.
-Why? AutoARIMA and Chronos look at one product at a time. For a product that sells a unit or two a day, the best guess is a flat line, and thousands of flat lines added up miss the weekend. Chronos does pick up the weekly rhythm in busier products, so its total has the right shape. But it predicts the typical day, and for sparse products the typical day sells less than the average day, so each forecast is a little low, and across thousands of products that adds up to a total about 11% too low. LightGBM learns from all products together, so it sees the weekend rush, and averaging it with AutoETS smooths out the rest. Zoom into a single product, though, and the lines come together: one product's daily sales are mostly noise.
+Why? AutoARIMA and Chronos look at one product at a time. For a product that sells a unit or two a day, AutoARIMA's best guess is a flat line, and thousands of flat lines added up miss the weekend. Chronos does follow each product's own weekly pattern, which is why its shape is right. But it aims at the typical day, and for products that often sell nothing, the typical day is below the average, so it under-forecasts the sparse products most and the total ends up about 11% low. LightGBM learns from all products together, so it sees the weekend rush, and averaging it with AutoETS smooths out the rest. Zoom into a single product, though, and the lines come together: one product's daily sales are mostly noise.
 TRANSITION: So the specialist AI is fast but less accurate. What about a generalist AI that reads and reasons? Speaker 3.</a:t>
             </a:r>
             <a:endParaRPr lang="en-US" dirty="0"/>

</xml_diff>

<commit_message>
Slide 5 notes: drop single-product sentence
Co-Authored-By: Claude Opus 5.5 <noreply@anthropic.com>
</commit_message>
<xml_diff>
--- a/presentation/Group3_Forecasting_Presentation.pptx
+++ b/presentation/Group3_Forecasting_Presentation.pptx
@@ -115,26 +115,26 @@
   <p:extLst>
     <p:ext uri="{521415D9-36F7-43E2-AB2F-B90AF26B5E84}">
       <p14:sectionLst xmlns:p14="http://schemas.microsoft.com/office/powerpoint/2010/main">
-        <p14:section name="Question and data" id="{c087666b-7c0e-a4d9-07ae-e1b01e445943}">
+        <p14:section name="Question and data" id="{6457a11b-2e00-d16b-d8e7-a6ea70a1b295}">
           <p14:sldIdLst>
             <p14:sldId id="256"/>
             <p14:sldId id="257"/>
           </p14:sldIdLst>
         </p14:section>
-        <p14:section name="Models and results" id="{64eb1f95-21db-e24a-42a3-0b770329c524}">
+        <p14:section name="Models and results" id="{12d43392-109d-0b02-4404-d168bcd271c8}">
           <p14:sldIdLst>
             <p14:sldId id="258"/>
             <p14:sldId id="259"/>
             <p14:sldId id="260"/>
           </p14:sldIdLst>
         </p14:section>
-        <p14:section name="LLM experiment" id="{d924980a-6fcb-c937-4966-9e9bb5fb680b}">
+        <p14:section name="LLM experiment" id="{ba8d30fc-75be-301c-8687-4889bb886f7c}">
           <p14:sldIdLst>
             <p14:sldId id="261"/>
             <p14:sldId id="262"/>
           </p14:sldIdLst>
         </p14:section>
-        <p14:section name="Answer and demo" id="{20b0d37f-7379-6074-1e0b-d46f4453a8c5}">
+        <p14:section name="Answer and demo" id="{edfb8a1d-2922-ea5f-aa1c-0378c7ebd974}">
           <p14:sldIdLst>
             <p14:sldId id="263"/>
             <p14:sldId id="264"/>
@@ -5620,7 +5620,7 @@
               <a:rPr lang="en-US" dirty="0"/>
               <a:t>SPEAKER 2 (1:00)
 Here's what that looks like. The black line is actual daily sales across all four stores during the test month. The traditional average, in teal, rises and falls with every weekend peak. AutoARIMA, in green, is almost flat, and Chronos, in orange, has the right shape but sits too low.
-Why? AutoARIMA and Chronos look at one product at a time. For a product that sells a unit or two a day, AutoARIMA's best guess is a flat line, and thousands of flat lines added up miss the weekend. Chronos does follow each product's own weekly pattern, which is why its shape is right. But it aims at the typical day, and for products that often sell nothing, the typical day is below the average, so it under-forecasts the sparse products most and the total ends up about 11% low. LightGBM learns from all products together, so it sees the weekend rush, and averaging it with AutoETS smooths out the rest. Zoom into a single product, though, and the lines come together: one product's daily sales are mostly noise.
+Why? AutoARIMA and Chronos look at one product at a time. For a product that sells a unit or two a day, AutoARIMA's best guess is a flat line, and thousands of flat lines added up miss the weekend. Chronos does follow each product's own weekly pattern, which is why its shape is right. But it aims at the typical day, and for products that often sell nothing, the typical day is below the average, so it under-forecasts the sparse products most and the total ends up about 11% low. LightGBM learns from all products together, so it sees the weekend rush, and averaging it with AutoETS smooths out the rest.
 TRANSITION: So the specialist AI is fast but less accurate. What about a generalist AI that reads and reasons? Speaker 3.</a:t>
             </a:r>
             <a:endParaRPr lang="en-US" dirty="0"/>

</xml_diff>

<commit_message>
Reframe conclusion: use a traditional ensemble
AI shows no clear accuracy advantage and lacks interpretability, so the
answer is now "use a traditional ensemble" rather than "not yet on
accuracy, yes on speed". Applied consistently across README, report and
deck.

- README: retitle sections 4 and 8; note the negative binomial assumption
  behind the point-forecast newsvendor orders
- Report: rewrite the Answer paragraph; merge conclusions 1-2, drop
  "AI wins on speed", reframe the Claude conclusion; drop the Chronos
  clause from the recommendation; remove the "Simple LightGBM" limitation;
  re-render HTML and PDF
- Deck: update slides 5 and 9 and speaker notes in build_deck.js and the
  pptx; re-export the PDF
- Remove presentation/Presentation_Script.pdf

Co-Authored-By: Claude Opus 5.5 <noreply@anthropic.com>
</commit_message>
<xml_diff>
--- a/presentation/Group3_Forecasting_Presentation.pptx
+++ b/presentation/Group3_Forecasting_Presentation.pptx
@@ -4623,7 +4623,7 @@
 (0:00-0:20) FORECAST EXPLORER. This is Shelf Signal, which extends our teammate's original dashboard with all our models. Here's one store's department total: the black line is actual sales, and you can switch each model on and off. The ensemble and LightGBM follow the weekend peaks; Chronos runs low.
 (0:20-0:40) AI LAB. Here Claude explains its own forecast in plain English, and this chart is the named-versus-blind test: every point sits on the diagonal, so real names gave it no advantage.
 (0:40-1:30) ORDER PLANNER. Now the business problem. For this item, the model forecasts about eight units for the day. At a 50% margin, the best order is the median of demand. Drop the margin to 20%: a wasted unit now costs four times a lost sale, so the order falls. Raise it to 80%: a lost sale costs four times a wasted unit, so we order more. Same forecast, different decision. The table scores every model's orders against actual sales: the profit ranking isn't the same as the accuracy ranking, and at typical margins the differences are small.
-(close) That's our project: traditional methods still lead on accuracy, AI wins on speed, and the right order depends on your costs. Thank you, and we're happy to take questions.
+(close) That's our project: traditional methods still lead on accuracy, AI offers no clear accuracy advantage and lacks interpretability, and the right order depends on your costs. Thank you, and we're happy to take questions.
 [Press Cmd+Tab to return to the slides for Q&amp;A.]</a:t>
             </a:r>
           </a:p>
@@ -4959,7 +4959,7 @@
               <a:rPr lang="en-US" dirty="0"/>
               <a:t>SPEAKER 2 (1:00)
 Here is the scorecard: traditional models against AI, on four questions. Who is most accurate overall? A traditional model: the simple average of AutoETS and LightGBM, with LightGBM alone second and AutoETS close behind. Who forecasts store totals best? Again the traditional models. For single products? It's close, and there the AI is level with LightGBM. And who is fastest? The AI, Chronos, by far: seconds instead of minutes, with no training at all.
-So from a traditional point of view, the best choice is the AutoETS-plus-LightGBM average, and the AI's real strength is speed. The green cells show the winner of each column.
+So from a traditional point of view, the best choice is the AutoETS-plus-LightGBM average, and the AI is faster but offers no clear accuracy advantage. The green cells show the winner of each column.
 POINT AT: the green cells, column by column.
 TRANSITION: Let's see what those forecasts actually look like.</a:t>
             </a:r>
@@ -5324,10 +5324,10 @@
             <a:r>
               <a:rPr lang="en-US" dirty="0"/>
               <a:t>SPEAKER 4 (1:45)
-So, can AI foundation models beat traditional methods? Our answer: not yet on accuracy, yes on speed. LightGBM, AutoETS and their simple average were the three most accurate. Chronos was the clear winner on speed: ten seconds, no training. And Claude matched the best traditional approach on store totals.
+So, can AI foundation models beat traditional methods? Our answer: use a traditional ensemble. LightGBM, AutoETS and their simple average were the three most accurate. AI showed no clear accuracy advantage: Chronos was fast, ten seconds with no training, but less accurate than the benchmark, and Claude only matched the best traditional approach on store totals, on a small subset. And AI lacks interpretability: Chronos is a black box, and Claude's written reasoning can't be verified.
 Our results have limits. First, Claude was tested on a subset, and our blind test can't fully rule out that it saw this public data. Second, sales are not demand: when a shelf is empty, sales show zero even if customers wanted the product.
 And the most important limitation for a business: accuracy isn't the real goal. Ordering stock is a newsvendor problem with two different costs. If you order too little, you lose the margin on every sale you miss; that's the underage cost. If you order too much, unsold food is wasted at its cost; that's the overage cost. Because those costs depend on the margin, the best order isn't the forecast itself but a quantile of demand, and our accuracy metrics treat over- and under-forecasting the same. So what happened when we turned each model's forecasts into actual orders? For most products, it barely mattered which model we used: the profit differences were small enough to be luck. Only for high-margin products, where running out of stock is expensive, did the more accurate model, LightGBM, clearly make more money.
-So our recommendation: average a statistical model like AutoETS with LightGBM, use Chronos where speed or a lack of training data matters, and choose models on the metric that matches the business decision. Our next step is a rolling backtest over several windows.
+So our recommendation: use the traditional ensemble, an average of a statistical model like AutoETS with LightGBM, and choose models on the metric that matches the business decision. Our next step is a rolling backtest over several windows.
 Let me show you the business problem in our dashboard.
 TRANSITION: click the screenshot on the next slide.</a:t>
             </a:r>
@@ -10966,7 +10966,7 @@
                   <a:schemeClr val="tx2"/>
                 </a:solidFill>
               </a:rPr>
-              <a:t>Traditional wins accuracy; AI wins speed</a:t>
+              <a:t>Traditional models win on accuracy</a:t>
             </a:r>
             <a:endParaRPr lang="en-US" sz="3400" dirty="0"/>
           </a:p>
@@ -13845,7 +13845,7 @@
                   <a:srgbClr val="EB6834"/>
                 </a:solidFill>
               </a:rPr>
-              <a:t>Best AI strength: </a:t>
+              <a:t>AI: </a:t>
             </a:r>
             <a:r>
               <a:rPr lang="en-US" sz="1400" dirty="0">
@@ -13853,7 +13853,7 @@
                   <a:schemeClr val="tx1"/>
                 </a:solidFill>
               </a:rPr>
-              <a:t>Chronos, for speed with no training.</a:t>
+              <a:t>fast, but no clear accuracy edge.</a:t>
             </a:r>
             <a:endParaRPr lang="en-US" sz="1400" dirty="0"/>
           </a:p>
@@ -16721,7 +16721,7 @@
                   <a:schemeClr val="bg1"/>
                 </a:solidFill>
               </a:rPr>
-              <a:t>Our answer: not yet on accuracy, yes on speed</a:t>
+              <a:t>Our answer: use a traditional ensemble</a:t>
             </a:r>
             <a:endParaRPr lang="en-US" sz="3400" dirty="0"/>
           </a:p>
@@ -16941,7 +16941,7 @@
                   <a:schemeClr val="bg1"/>
                 </a:solidFill>
               </a:rPr>
-              <a:t>Chronos wins on speed</a:t>
+              <a:t>AI shows no clear accuracy edge</a:t>
             </a:r>
             <a:endParaRPr lang="en-US" sz="1900" dirty="0"/>
           </a:p>
@@ -16977,7 +16977,7 @@
                   <a:schemeClr val="bg2"/>
                 </a:solidFill>
               </a:rPr>
-              <a:t>10 s for all series, no training</a:t>
+              <a:t>Chronos trails the benchmark; Claude tested on 112 only</a:t>
             </a:r>
             <a:endParaRPr lang="en-US" sz="1400" dirty="0"/>
           </a:p>
@@ -17069,7 +17069,7 @@
                   <a:schemeClr val="bg1"/>
                 </a:solidFill>
               </a:rPr>
-              <a:t>Claude matched the best on totals</a:t>
+              <a:t>AI lacks interpretability</a:t>
             </a:r>
             <a:endParaRPr lang="en-US" sz="1900" dirty="0"/>
           </a:p>
@@ -17105,7 +17105,7 @@
                   <a:schemeClr val="bg2"/>
                 </a:solidFill>
               </a:rPr>
-              <a:t>Promising, but tested on 112 series only</a:t>
+              <a:t>Black boxes; Claude's reasoning can't be verified</a:t>
             </a:r>
             <a:endParaRPr lang="en-US" sz="1400" dirty="0"/>
           </a:p>

</xml_diff>

<commit_message>
Research question: accuracy, at a practical cost; parallel efficiency sentences
Co-Authored-By: Claude Opus 5.5 <noreply@anthropic.com>
</commit_message>
<xml_diff>
--- a/presentation/Group3_Forecasting_Presentation.pptx
+++ b/presentation/Group3_Forecasting_Presentation.pptx
@@ -4706,7 +4706,7 @@
           </a:p>
           <a:p>
             <a:r>
-              <a:t>Good afternoon, we're Group 3. A retail forecast has three jobs: be accurate, be cheap and fast enough to run every day for thousands of products, and support good stocking decisions. LightGBM, a machine-learning method, dominates this kind of retail data and has become the industry default. Since then, AI foundation models, pre-trained on huge datasets, can forecast a product they have never seen, with no training at all. So we ask: can these AI models beat traditional statistical and machine-learning methods, on accuracy and on efficiency?</a:t>
+              <a:t>Good afternoon, we're Group 3. A retail forecast has three jobs: be accurate, be cheap and fast enough to run every day for thousands of products, and support good stocking decisions. LightGBM, a machine-learning method, dominates this kind of retail data and has become the industry default. Since then, AI foundation models, pre-trained on huge datasets, can forecast a product they have never seen, with no training at all. So we ask: can these AI models beat traditional statistical and machine-learning methods, on accuracy, and at a practical cost?</a:t>
             </a:r>
           </a:p>
           <a:p>
@@ -7437,7 +7437,7 @@
                 </a:solidFill>
                 <a:latin typeface="Calibri"/>
               </a:rPr>
-              <a:t>Can pre-trained AI forecast as well as traditional methods, and faster?</a:t>
+              <a:t>Can pre-trained AI forecast as well as traditional methods, at a practical cost?</a:t>
             </a:r>
           </a:p>
         </p:txBody>

</xml_diff>